<commit_message>
updated files with images from the app
</commit_message>
<xml_diff>
--- a/docs/presentation/HuskiesPaws-BigRedHacks-2026.pptx
+++ b/docs/presentation/HuskiesPaws-BigRedHacks-2026.pptx
@@ -113,25 +113,25 @@
   <p:extLst>
     <p:ext uri="{521415D9-36F7-43E2-AB2F-B90AF26B5E84}">
       <p14:sectionLst xmlns:p14="http://schemas.microsoft.com/office/powerpoint/2010/main">
-        <p14:section name="Pitch" id="{90a19555-80b2-8a80-d8b2-ec307d1d6db0}">
+        <p14:section name="Pitch" id="{75c60f64-f831-6c14-78a7-61d93ef339ec}">
           <p14:sldIdLst>
             <p14:sldId id="256"/>
             <p14:sldId id="257"/>
             <p14:sldId id="258"/>
           </p14:sldIdLst>
         </p14:section>
-        <p14:section name="Demo" id="{ca88bde7-691e-7ec5-bce8-05ee2ad6c12a}">
+        <p14:section name="Demo" id="{e85ba79f-efed-ae6f-698c-c17e38775cb1}">
           <p14:sldIdLst>
             <p14:sldId id="259"/>
           </p14:sldIdLst>
         </p14:section>
-        <p14:section name="Build" id="{ccca3474-e5e5-b56f-91fa-36c25b8a35f8}">
+        <p14:section name="Build" id="{a9fd02b3-0671-ec03-9fc5-fd48b3121434}">
           <p14:sldIdLst>
             <p14:sldId id="260"/>
             <p14:sldId id="261"/>
           </p14:sldIdLst>
         </p14:section>
-        <p14:section name="Close" id="{42d45996-dd05-7059-408c-92bcd9a0dc71}">
+        <p14:section name="Close" id="{781d7c0b-19e4-d151-c0d1-62d4b7a8e03b}">
           <p14:sldIdLst>
             <p14:sldId id="262"/>
           </p14:sldIdLst>
@@ -716,7 +716,7 @@
           <a:p>
             <a:r>
               <a:rPr lang="en-US" dirty="0"/>
-              <a:t>About 30 seconds. Loop: Explore, Walk, Discover, Collect. Pip scouts with Wikipedia and OpenStreetMap. Fern starts the walk. Moss tells the story from those facts. Capture and eggs reward the walk. Then go to the live phone.</a:t>
+              <a:t>About 30 seconds. Loop: Explore, Walk, Discover, Collect. Pip scouts with Wikipedia and OpenStreetMap. Fern starts the walk. Moss tells the story from those facts. Capture and eggs reward the walk. Point at the screenshot: a real landmark, a squad pet, and Walk there. Then go to the live phone.</a:t>
             </a:r>
             <a:endParaRPr lang="en-US" dirty="0"/>
           </a:p>
@@ -980,7 +980,7 @@
           <a:p>
             <a:r>
               <a:rPr lang="en-US" dirty="0"/>
-              <a:t>About 25 seconds. Three things they saw: navigation is play; walking earns creatures; the squad can live in iMessage. ISS rare-hatch boost is in shared logic. Be honest about Grok keys, deploy, and background GPS.</a:t>
+              <a:t>About 25 seconds. Three things they saw: navigation is play; walking earns creatures; you can hold a real landmark. ISS rare-hatch boost is in shared logic. Be honest about Grok keys, deploy, and background GPS. The squad can also live in iMessage.</a:t>
             </a:r>
             <a:endParaRPr lang="en-US" dirty="0"/>
           </a:p>
@@ -1174,8 +1174,8 @@
         </p:nvSpPr>
         <p:spPr>
           <a:xfrm>
-            <a:off x="548640" y="256032"/>
-            <a:ext cx="11064240" cy="658368"/>
+            <a:off x="457200" y="201168"/>
+            <a:ext cx="11247120" cy="566928"/>
           </a:xfrm>
           <a:prstGeom prst="rect">
             <a:avLst/>
@@ -1188,7 +1188,7 @@
           <a:lstStyle>
             <a:lvl1pPr algn="l" indent="0" marL="0">
               <a:buNone/>
-              <a:defRPr lang="en-US" sz="3600" b="1" dirty="0">
+              <a:defRPr lang="en-US" sz="3000" b="1" dirty="0">
                 <a:solidFill>
                   <a:schemeClr val="tx1"/>
                 </a:solidFill>
@@ -1199,7 +1199,7 @@
             <a:pPr algn="l" indent="0" marL="0">
               <a:buNone/>
             </a:pPr>
-            <a:endParaRPr lang="en-US" sz="3600" dirty="0"/>
+            <a:endParaRPr lang="en-US" sz="3000" dirty="0"/>
           </a:p>
         </p:txBody>
       </p:sp>
@@ -1211,8 +1211,8 @@
         </p:nvSpPr>
         <p:spPr>
           <a:xfrm>
-            <a:off x="548640" y="6547104"/>
-            <a:ext cx="11064240" cy="182880"/>
+            <a:off x="457200" y="6547104"/>
+            <a:ext cx="11247120" cy="182880"/>
           </a:xfrm>
           <a:prstGeom prst="rect">
             <a:avLst/>
@@ -1552,8 +1552,8 @@
         </p:nvSpPr>
         <p:spPr>
           <a:xfrm>
-            <a:off x="548640" y="256032"/>
-            <a:ext cx="11064240" cy="658368"/>
+            <a:off x="457200" y="201168"/>
+            <a:ext cx="11247120" cy="566928"/>
           </a:xfrm>
           <a:prstGeom prst="rect">
             <a:avLst/>
@@ -1569,14 +1569,14 @@
               <a:buNone/>
             </a:pPr>
             <a:r>
-              <a:rPr lang="en-US" sz="3600" b="1" dirty="0">
+              <a:rPr lang="en-US" sz="3000" b="1" dirty="0">
                 <a:solidFill>
                   <a:schemeClr val="tx1"/>
                 </a:solidFill>
               </a:rPr>
               <a:t>HuskiesPaws</a:t>
             </a:r>
-            <a:endParaRPr lang="en-US" sz="3600" dirty="0"/>
+            <a:endParaRPr lang="en-US" sz="3000" dirty="0"/>
           </a:p>
         </p:txBody>
       </p:sp>
@@ -1596,8 +1596,8 @@
         </p:blipFill>
         <p:spPr>
           <a:xfrm>
-            <a:off x="640080" y="1097280"/>
-            <a:ext cx="2011680" cy="2011680"/>
+            <a:off x="502920" y="1051560"/>
+            <a:ext cx="1920240" cy="1920240"/>
           </a:xfrm>
           <a:prstGeom prst="rect">
             <a:avLst/>
@@ -1606,14 +1606,14 @@
       </p:pic>
       <p:sp>
         <p:nvSpPr>
-          <p:cNvPr id="4" name="tagline"/>
-          <p:cNvSpPr txBox="1"/>
-          <p:nvPr/>
-        </p:nvSpPr>
-        <p:spPr>
-          <a:xfrm>
-            <a:off x="2880360" y="1143000"/>
-            <a:ext cx="8595360" cy="777240"/>
+          <p:cNvPr id="4" name="Text 1"/>
+          <p:cNvSpPr txBox="1"/>
+          <p:nvPr/>
+        </p:nvSpPr>
+        <p:spPr>
+          <a:xfrm>
+            <a:off x="2651760" y="1097280"/>
+            <a:ext cx="8961120" cy="731520"/>
           </a:xfrm>
           <a:prstGeom prst="rect">
             <a:avLst/>
@@ -1629,27 +1629,27 @@
               <a:buNone/>
             </a:pPr>
             <a:r>
-              <a:rPr lang="en-US" sz="2400" i="1" dirty="0">
+              <a:rPr lang="en-US" sz="2200" i="1" dirty="0">
                 <a:solidFill>
                   <a:schemeClr val="accent5"/>
                 </a:solidFill>
               </a:rPr>
               <a:t>Turn everyday walks into a creature-collecting adventure.</a:t>
             </a:r>
-            <a:endParaRPr lang="en-US" sz="2400" dirty="0"/>
-          </a:p>
-        </p:txBody>
-      </p:sp>
-      <p:sp>
-        <p:nvSpPr>
-          <p:cNvPr id="5" name="event"/>
-          <p:cNvSpPr txBox="1"/>
-          <p:nvPr/>
-        </p:nvSpPr>
-        <p:spPr>
-          <a:xfrm>
-            <a:off x="2880360" y="1965960"/>
-            <a:ext cx="8595360" cy="365760"/>
+            <a:endParaRPr lang="en-US" sz="2200" dirty="0"/>
+          </a:p>
+        </p:txBody>
+      </p:sp>
+      <p:sp>
+        <p:nvSpPr>
+          <p:cNvPr id="5" name="Text 2"/>
+          <p:cNvSpPr txBox="1"/>
+          <p:nvPr/>
+        </p:nvSpPr>
+        <p:spPr>
+          <a:xfrm>
+            <a:off x="2651760" y="1874520"/>
+            <a:ext cx="8961120" cy="365760"/>
           </a:xfrm>
           <a:prstGeom prst="rect">
             <a:avLst/>
@@ -1665,27 +1665,27 @@
               <a:buNone/>
             </a:pPr>
             <a:r>
-              <a:rPr lang="en-US" sz="1800" dirty="0">
+              <a:rPr lang="en-US" sz="1600" dirty="0">
                 <a:solidFill>
                   <a:schemeClr val="accent6"/>
                 </a:solidFill>
               </a:rPr>
               <a:t>BigRed//Hacks 2026  ·  Navigation  ·  the phone app</a:t>
             </a:r>
-            <a:endParaRPr lang="en-US" sz="1800" dirty="0"/>
-          </a:p>
-        </p:txBody>
-      </p:sp>
-      <p:sp>
-        <p:nvSpPr>
-          <p:cNvPr id="6" name="chip-Luis Mendez"/>
+            <a:endParaRPr lang="en-US" sz="1600" dirty="0"/>
+          </a:p>
+        </p:txBody>
+      </p:sp>
+      <p:sp>
+        <p:nvSpPr>
+          <p:cNvPr id="6" name="chip-0"/>
           <p:cNvSpPr/>
           <p:nvPr/>
         </p:nvSpPr>
         <p:spPr>
           <a:xfrm>
-            <a:off x="640080" y="3246120"/>
-            <a:ext cx="3611880" cy="1097280"/>
+            <a:off x="502920" y="3246120"/>
+            <a:ext cx="3657600" cy="960120"/>
           </a:xfrm>
           <a:prstGeom prst="roundRect">
             <a:avLst>
@@ -1699,7 +1699,7 @@
           <a:effectLst>
             <a:outerShdw sx="100000" sy="100000" kx="0" ky="0" algn="bl" rotWithShape="0" blurRad="101600" dist="25400" dir="5400000">
               <a:srgbClr val="0B1F3A">
-                <a:alpha val="8000"/>
+                <a:alpha val="10000"/>
               </a:srgbClr>
             </a:outerShdw>
           </a:effectLst>
@@ -1713,8 +1713,8 @@
         </p:nvSpPr>
         <p:spPr>
           <a:xfrm>
-            <a:off x="822960" y="3429000"/>
-            <a:ext cx="3246120" cy="731520"/>
+            <a:off x="640080" y="3383280"/>
+            <a:ext cx="3383280" cy="685800"/>
           </a:xfrm>
           <a:prstGeom prst="rect">
             <a:avLst/>
@@ -1730,27 +1730,27 @@
               <a:buNone/>
             </a:pPr>
             <a:r>
-              <a:rPr lang="en-US" sz="2000" b="1" dirty="0">
+              <a:rPr lang="en-US" sz="1800" b="1" dirty="0">
                 <a:solidFill>
                   <a:schemeClr val="tx1"/>
                 </a:solidFill>
               </a:rPr>
               <a:t>Luis Mendez</a:t>
             </a:r>
-            <a:endParaRPr lang="en-US" sz="2000" dirty="0"/>
-          </a:p>
-        </p:txBody>
-      </p:sp>
-      <p:sp>
-        <p:nvSpPr>
-          <p:cNvPr id="8" name="chip-Abdullah Rashid"/>
+            <a:endParaRPr lang="en-US" sz="1800" dirty="0"/>
+          </a:p>
+        </p:txBody>
+      </p:sp>
+      <p:sp>
+        <p:nvSpPr>
+          <p:cNvPr id="8" name="chip-1"/>
           <p:cNvSpPr/>
           <p:nvPr/>
         </p:nvSpPr>
         <p:spPr>
           <a:xfrm>
-            <a:off x="4480560" y="3246120"/>
-            <a:ext cx="3611880" cy="1097280"/>
+            <a:off x="4343400" y="3246120"/>
+            <a:ext cx="3657600" cy="960120"/>
           </a:xfrm>
           <a:prstGeom prst="roundRect">
             <a:avLst>
@@ -1764,7 +1764,7 @@
           <a:effectLst>
             <a:outerShdw sx="100000" sy="100000" kx="0" ky="0" algn="bl" rotWithShape="0" blurRad="101600" dist="25400" dir="5400000">
               <a:srgbClr val="0B1F3A">
-                <a:alpha val="8000"/>
+                <a:alpha val="10000"/>
               </a:srgbClr>
             </a:outerShdw>
           </a:effectLst>
@@ -1778,8 +1778,8 @@
         </p:nvSpPr>
         <p:spPr>
           <a:xfrm>
-            <a:off x="4663440" y="3429000"/>
-            <a:ext cx="3246120" cy="731520"/>
+            <a:off x="4480560" y="3383280"/>
+            <a:ext cx="3383280" cy="685800"/>
           </a:xfrm>
           <a:prstGeom prst="rect">
             <a:avLst/>
@@ -1795,27 +1795,27 @@
               <a:buNone/>
             </a:pPr>
             <a:r>
-              <a:rPr lang="en-US" sz="2000" b="1" dirty="0">
+              <a:rPr lang="en-US" sz="1800" b="1" dirty="0">
                 <a:solidFill>
                   <a:schemeClr val="tx1"/>
                 </a:solidFill>
               </a:rPr>
               <a:t>Abdullah Rashid</a:t>
             </a:r>
-            <a:endParaRPr lang="en-US" sz="2000" dirty="0"/>
-          </a:p>
-        </p:txBody>
-      </p:sp>
-      <p:sp>
-        <p:nvSpPr>
-          <p:cNvPr id="10" name="chip-Built with Cursor"/>
+            <a:endParaRPr lang="en-US" sz="1800" dirty="0"/>
+          </a:p>
+        </p:txBody>
+      </p:sp>
+      <p:sp>
+        <p:nvSpPr>
+          <p:cNvPr id="10" name="chip-2"/>
           <p:cNvSpPr/>
           <p:nvPr/>
         </p:nvSpPr>
         <p:spPr>
           <a:xfrm>
-            <a:off x="8321040" y="3246120"/>
-            <a:ext cx="3611880" cy="1097280"/>
+            <a:off x="8183880" y="3246120"/>
+            <a:ext cx="3657600" cy="960120"/>
           </a:xfrm>
           <a:prstGeom prst="roundRect">
             <a:avLst>
@@ -1829,7 +1829,7 @@
           <a:effectLst>
             <a:outerShdw sx="100000" sy="100000" kx="0" ky="0" algn="bl" rotWithShape="0" blurRad="101600" dist="25400" dir="5400000">
               <a:srgbClr val="0B1F3A">
-                <a:alpha val="8000"/>
+                <a:alpha val="10000"/>
               </a:srgbClr>
             </a:outerShdw>
           </a:effectLst>
@@ -1843,8 +1843,8 @@
         </p:nvSpPr>
         <p:spPr>
           <a:xfrm>
-            <a:off x="8503920" y="3429000"/>
-            <a:ext cx="3246120" cy="731520"/>
+            <a:off x="8321040" y="3383280"/>
+            <a:ext cx="3383280" cy="685800"/>
           </a:xfrm>
           <a:prstGeom prst="rect">
             <a:avLst/>
@@ -1860,14 +1860,14 @@
               <a:buNone/>
             </a:pPr>
             <a:r>
-              <a:rPr lang="en-US" sz="2000" b="1" dirty="0">
+              <a:rPr lang="en-US" sz="1800" b="1" dirty="0">
                 <a:solidFill>
                   <a:schemeClr val="tx1"/>
                 </a:solidFill>
               </a:rPr>
               <a:t>Built with Cursor</a:t>
             </a:r>
-            <a:endParaRPr lang="en-US" sz="2000" dirty="0"/>
+            <a:endParaRPr lang="en-US" sz="1800" dirty="0"/>
           </a:p>
         </p:txBody>
       </p:sp>
@@ -1887,8 +1887,8 @@
         </p:blipFill>
         <p:spPr>
           <a:xfrm>
-            <a:off x="3794760" y="4617720"/>
-            <a:ext cx="1325880" cy="1325880"/>
+            <a:off x="3840480" y="4480560"/>
+            <a:ext cx="1234440" cy="1234440"/>
           </a:xfrm>
           <a:prstGeom prst="rect">
             <a:avLst/>
@@ -1911,8 +1911,8 @@
         </p:blipFill>
         <p:spPr>
           <a:xfrm>
-            <a:off x="5440680" y="4617720"/>
-            <a:ext cx="1325880" cy="1325880"/>
+            <a:off x="5486400" y="4480560"/>
+            <a:ext cx="1234440" cy="1234440"/>
           </a:xfrm>
           <a:prstGeom prst="rect">
             <a:avLst/>
@@ -1935,8 +1935,8 @@
         </p:blipFill>
         <p:spPr>
           <a:xfrm>
-            <a:off x="7086600" y="4617720"/>
-            <a:ext cx="1325880" cy="1325880"/>
+            <a:off x="7132320" y="4480560"/>
+            <a:ext cx="1234440" cy="1234440"/>
           </a:xfrm>
           <a:prstGeom prst="rect">
             <a:avLst/>
@@ -1978,8 +1978,8 @@
         </p:nvSpPr>
         <p:spPr>
           <a:xfrm>
-            <a:off x="548640" y="256032"/>
-            <a:ext cx="11064240" cy="658368"/>
+            <a:off x="457200" y="201168"/>
+            <a:ext cx="11247120" cy="566928"/>
           </a:xfrm>
           <a:prstGeom prst="rect">
             <a:avLst/>
@@ -1995,31 +1995,31 @@
               <a:buNone/>
             </a:pPr>
             <a:r>
-              <a:rPr lang="en-US" sz="3600" b="1" dirty="0">
+              <a:rPr lang="en-US" sz="3000" b="1" dirty="0">
                 <a:solidFill>
                   <a:schemeClr val="tx1"/>
                 </a:solidFill>
               </a:rPr>
               <a:t>Maps get you there. They do not make you look.</a:t>
             </a:r>
-            <a:endParaRPr lang="en-US" sz="3600" dirty="0"/>
-          </a:p>
-        </p:txBody>
-      </p:sp>
-      <p:sp>
-        <p:nvSpPr>
-          <p:cNvPr id="3" name="problem-0"/>
+            <a:endParaRPr lang="en-US" sz="3000" dirty="0"/>
+          </a:p>
+        </p:txBody>
+      </p:sp>
+      <p:sp>
+        <p:nvSpPr>
+          <p:cNvPr id="3" name="p-0"/>
           <p:cNvSpPr/>
           <p:nvPr/>
         </p:nvSpPr>
         <p:spPr>
           <a:xfrm>
-            <a:off x="548640" y="1143000"/>
-            <a:ext cx="3611880" cy="3246120"/>
+            <a:off x="502920" y="1051560"/>
+            <a:ext cx="3657600" cy="3383280"/>
           </a:xfrm>
           <a:prstGeom prst="roundRect">
             <a:avLst>
-              <a:gd name="adj" fmla="val 4507"/>
+              <a:gd name="adj" fmla="val 3784"/>
             </a:avLst>
           </a:prstGeom>
           <a:solidFill>
@@ -2029,7 +2029,7 @@
           <a:effectLst>
             <a:outerShdw sx="100000" sy="100000" kx="0" ky="0" algn="bl" rotWithShape="0" blurRad="101600" dist="25400" dir="5400000">
               <a:srgbClr val="0B1F3A">
-                <a:alpha val="8000"/>
+                <a:alpha val="10000"/>
               </a:srgbClr>
             </a:outerShdw>
           </a:effectLst>
@@ -2037,14 +2037,14 @@
       </p:sp>
       <p:sp>
         <p:nvSpPr>
-          <p:cNvPr id="4" name="dot-0"/>
+          <p:cNvPr id="4" name="n-0"/>
           <p:cNvSpPr/>
           <p:nvPr/>
         </p:nvSpPr>
         <p:spPr>
           <a:xfrm>
-            <a:off x="1920240" y="1371600"/>
-            <a:ext cx="822960" cy="822960"/>
+            <a:off x="1920240" y="1325880"/>
+            <a:ext cx="777240" cy="777240"/>
           </a:xfrm>
           <a:prstGeom prst="ellipse">
             <a:avLst/>
@@ -2063,8 +2063,8 @@
         </p:nvSpPr>
         <p:spPr>
           <a:xfrm>
-            <a:off x="1920240" y="1481328"/>
-            <a:ext cx="822960" cy="594360"/>
+            <a:off x="1920240" y="1417320"/>
+            <a:ext cx="777240" cy="594360"/>
           </a:xfrm>
           <a:prstGeom prst="rect">
             <a:avLst/>
@@ -2099,8 +2099,8 @@
         </p:nvSpPr>
         <p:spPr>
           <a:xfrm>
-            <a:off x="777240" y="2377440"/>
-            <a:ext cx="3154680" cy="640080"/>
+            <a:off x="731520" y="2286000"/>
+            <a:ext cx="3200400" cy="640080"/>
           </a:xfrm>
           <a:prstGeom prst="rect">
             <a:avLst/>
@@ -2135,8 +2135,8 @@
         </p:nvSpPr>
         <p:spPr>
           <a:xfrm>
-            <a:off x="822960" y="3063240"/>
-            <a:ext cx="3063240" cy="1005840"/>
+            <a:off x="777240" y="2971800"/>
+            <a:ext cx="3108960" cy="1097280"/>
           </a:xfrm>
           <a:prstGeom prst="rect">
             <a:avLst/>
@@ -2165,18 +2165,18 @@
       </p:sp>
       <p:sp>
         <p:nvSpPr>
-          <p:cNvPr id="8" name="problem-1"/>
+          <p:cNvPr id="8" name="p-1"/>
           <p:cNvSpPr/>
           <p:nvPr/>
         </p:nvSpPr>
         <p:spPr>
           <a:xfrm>
-            <a:off x="4343400" y="1143000"/>
-            <a:ext cx="3611880" cy="3246120"/>
+            <a:off x="4343400" y="1051560"/>
+            <a:ext cx="3657600" cy="3383280"/>
           </a:xfrm>
           <a:prstGeom prst="roundRect">
             <a:avLst>
-              <a:gd name="adj" fmla="val 4507"/>
+              <a:gd name="adj" fmla="val 3784"/>
             </a:avLst>
           </a:prstGeom>
           <a:solidFill>
@@ -2186,7 +2186,7 @@
           <a:effectLst>
             <a:outerShdw sx="100000" sy="100000" kx="0" ky="0" algn="bl" rotWithShape="0" blurRad="101600" dist="25400" dir="5400000">
               <a:srgbClr val="0B1F3A">
-                <a:alpha val="8000"/>
+                <a:alpha val="10000"/>
               </a:srgbClr>
             </a:outerShdw>
           </a:effectLst>
@@ -2194,14 +2194,14 @@
       </p:sp>
       <p:sp>
         <p:nvSpPr>
-          <p:cNvPr id="9" name="dot-1"/>
+          <p:cNvPr id="9" name="n-1"/>
           <p:cNvSpPr/>
           <p:nvPr/>
         </p:nvSpPr>
         <p:spPr>
           <a:xfrm>
-            <a:off x="5715000" y="1371600"/>
-            <a:ext cx="822960" cy="822960"/>
+            <a:off x="5760720" y="1325880"/>
+            <a:ext cx="777240" cy="777240"/>
           </a:xfrm>
           <a:prstGeom prst="ellipse">
             <a:avLst/>
@@ -2220,8 +2220,8 @@
         </p:nvSpPr>
         <p:spPr>
           <a:xfrm>
-            <a:off x="5715000" y="1481328"/>
-            <a:ext cx="822960" cy="594360"/>
+            <a:off x="5760720" y="1417320"/>
+            <a:ext cx="777240" cy="594360"/>
           </a:xfrm>
           <a:prstGeom prst="rect">
             <a:avLst/>
@@ -2256,8 +2256,8 @@
         </p:nvSpPr>
         <p:spPr>
           <a:xfrm>
-            <a:off x="4572000" y="2377440"/>
-            <a:ext cx="3154680" cy="640080"/>
+            <a:off x="4572000" y="2286000"/>
+            <a:ext cx="3200400" cy="640080"/>
           </a:xfrm>
           <a:prstGeom prst="rect">
             <a:avLst/>
@@ -2292,8 +2292,8 @@
         </p:nvSpPr>
         <p:spPr>
           <a:xfrm>
-            <a:off x="4617720" y="3063240"/>
-            <a:ext cx="3063240" cy="1005840"/>
+            <a:off x="4617720" y="2971800"/>
+            <a:ext cx="3108960" cy="1097280"/>
           </a:xfrm>
           <a:prstGeom prst="rect">
             <a:avLst/>
@@ -2322,18 +2322,18 @@
       </p:sp>
       <p:sp>
         <p:nvSpPr>
-          <p:cNvPr id="13" name="problem-2"/>
+          <p:cNvPr id="13" name="p-2"/>
           <p:cNvSpPr/>
           <p:nvPr/>
         </p:nvSpPr>
         <p:spPr>
           <a:xfrm>
-            <a:off x="8138160" y="1143000"/>
-            <a:ext cx="3611880" cy="3246120"/>
+            <a:off x="8183880" y="1051560"/>
+            <a:ext cx="3657600" cy="3383280"/>
           </a:xfrm>
           <a:prstGeom prst="roundRect">
             <a:avLst>
-              <a:gd name="adj" fmla="val 4507"/>
+              <a:gd name="adj" fmla="val 3784"/>
             </a:avLst>
           </a:prstGeom>
           <a:solidFill>
@@ -2343,7 +2343,7 @@
           <a:effectLst>
             <a:outerShdw sx="100000" sy="100000" kx="0" ky="0" algn="bl" rotWithShape="0" blurRad="101600" dist="25400" dir="5400000">
               <a:srgbClr val="0B1F3A">
-                <a:alpha val="8000"/>
+                <a:alpha val="10000"/>
               </a:srgbClr>
             </a:outerShdw>
           </a:effectLst>
@@ -2351,14 +2351,14 @@
       </p:sp>
       <p:sp>
         <p:nvSpPr>
-          <p:cNvPr id="14" name="dot-2"/>
+          <p:cNvPr id="14" name="n-2"/>
           <p:cNvSpPr/>
           <p:nvPr/>
         </p:nvSpPr>
         <p:spPr>
           <a:xfrm>
-            <a:off x="9509760" y="1371600"/>
-            <a:ext cx="822960" cy="822960"/>
+            <a:off x="9601200" y="1325880"/>
+            <a:ext cx="777240" cy="777240"/>
           </a:xfrm>
           <a:prstGeom prst="ellipse">
             <a:avLst/>
@@ -2377,8 +2377,8 @@
         </p:nvSpPr>
         <p:spPr>
           <a:xfrm>
-            <a:off x="9509760" y="1481328"/>
-            <a:ext cx="822960" cy="594360"/>
+            <a:off x="9601200" y="1417320"/>
+            <a:ext cx="777240" cy="594360"/>
           </a:xfrm>
           <a:prstGeom prst="rect">
             <a:avLst/>
@@ -2413,8 +2413,8 @@
         </p:nvSpPr>
         <p:spPr>
           <a:xfrm>
-            <a:off x="8366760" y="2377440"/>
-            <a:ext cx="3154680" cy="640080"/>
+            <a:off x="8412480" y="2286000"/>
+            <a:ext cx="3200400" cy="640080"/>
           </a:xfrm>
           <a:prstGeom prst="rect">
             <a:avLst/>
@@ -2449,8 +2449,8 @@
         </p:nvSpPr>
         <p:spPr>
           <a:xfrm>
-            <a:off x="8412480" y="3063240"/>
-            <a:ext cx="3063240" cy="1005840"/>
+            <a:off x="8458200" y="2971800"/>
+            <a:ext cx="3108960" cy="1097280"/>
           </a:xfrm>
           <a:prstGeom prst="rect">
             <a:avLst/>
@@ -2471,7 +2471,7 @@
                   <a:schemeClr val="accent6"/>
                 </a:solidFill>
               </a:rPr>
-              <a:t>Campus already has stories. Nothing asks you to notice.</a:t>
+              <a:t>Campus already has stories.</a:t>
             </a:r>
             <a:endParaRPr lang="en-US" sz="1600" dirty="0"/>
           </a:p>
@@ -2485,8 +2485,8 @@
         </p:nvSpPr>
         <p:spPr>
           <a:xfrm>
-            <a:off x="548640" y="4617720"/>
-            <a:ext cx="11064240" cy="640080"/>
+            <a:off x="502920" y="4709160"/>
+            <a:ext cx="11155680" cy="640080"/>
           </a:xfrm>
           <a:prstGeom prst="rect">
             <a:avLst/>
@@ -2548,8 +2548,8 @@
         </p:nvSpPr>
         <p:spPr>
           <a:xfrm>
-            <a:off x="548640" y="256032"/>
-            <a:ext cx="11064240" cy="658368"/>
+            <a:off x="457200" y="201168"/>
+            <a:ext cx="11247120" cy="566928"/>
           </a:xfrm>
           <a:prstGeom prst="rect">
             <a:avLst/>
@@ -2565,31 +2565,31 @@
               <a:buNone/>
             </a:pPr>
             <a:r>
-              <a:rPr lang="en-US" sz="3600" b="1" dirty="0">
+              <a:rPr lang="en-US" sz="3000" b="1" dirty="0">
                 <a:solidFill>
                   <a:schemeClr val="tx1"/>
                 </a:solidFill>
               </a:rPr>
               <a:t>Explore  →  Walk  →  Discover  →  Collect</a:t>
             </a:r>
-            <a:endParaRPr lang="en-US" sz="3600" dirty="0"/>
-          </a:p>
-        </p:txBody>
-      </p:sp>
-      <p:sp>
-        <p:nvSpPr>
-          <p:cNvPr id="3" name="loop-Explore"/>
+            <a:endParaRPr lang="en-US" sz="3000" dirty="0"/>
+          </a:p>
+        </p:txBody>
+      </p:sp>
+      <p:sp>
+        <p:nvSpPr>
+          <p:cNvPr id="3" name="loop-0"/>
           <p:cNvSpPr/>
           <p:nvPr/>
         </p:nvSpPr>
         <p:spPr>
           <a:xfrm>
-            <a:off x="502920" y="1051560"/>
-            <a:ext cx="2788920" cy="3977640"/>
+            <a:off x="457200" y="960120"/>
+            <a:ext cx="4892040" cy="987552"/>
           </a:xfrm>
           <a:prstGeom prst="roundRect">
             <a:avLst>
-              <a:gd name="adj" fmla="val 5246"/>
+              <a:gd name="adj" fmla="val 12963"/>
             </a:avLst>
           </a:prstGeom>
           <a:solidFill>
@@ -2599,15 +2599,636 @@
           <a:effectLst>
             <a:outerShdw sx="100000" sy="100000" kx="0" ky="0" algn="bl" rotWithShape="0" blurRad="101600" dist="25400" dir="5400000">
               <a:srgbClr val="0B1F3A">
-                <a:alpha val="8000"/>
+                <a:alpha val="10000"/>
               </a:srgbClr>
             </a:outerShdw>
           </a:effectLst>
         </p:spPr>
       </p:sp>
+      <p:sp>
+        <p:nvSpPr>
+          <p:cNvPr id="4" name="loop-n-0"/>
+          <p:cNvSpPr/>
+          <p:nvPr/>
+        </p:nvSpPr>
+        <p:spPr>
+          <a:xfrm>
+            <a:off x="621792" y="1161288"/>
+            <a:ext cx="566928" cy="566928"/>
+          </a:xfrm>
+          <a:prstGeom prst="ellipse">
+            <a:avLst/>
+          </a:prstGeom>
+          <a:solidFill>
+            <a:schemeClr val="accent1"/>
+          </a:solidFill>
+          <a:ln/>
+        </p:spPr>
+      </p:sp>
+      <p:sp>
+        <p:nvSpPr>
+          <p:cNvPr id="5" name="Text 3"/>
+          <p:cNvSpPr txBox="1"/>
+          <p:nvPr/>
+        </p:nvSpPr>
+        <p:spPr>
+          <a:xfrm>
+            <a:off x="621792" y="1216152"/>
+            <a:ext cx="566928" cy="457200"/>
+          </a:xfrm>
+          <a:prstGeom prst="rect">
+            <a:avLst/>
+          </a:prstGeom>
+          <a:noFill/>
+          <a:ln/>
+        </p:spPr>
+        <p:txBody>
+          <a:bodyPr wrap="square" lIns="0" tIns="0" rIns="0" bIns="0" rtlCol="0" anchor="ctr"/>
+          <a:lstStyle/>
+          <a:p>
+            <a:pPr algn="ctr" indent="0" marL="0">
+              <a:buNone/>
+            </a:pPr>
+            <a:r>
+              <a:rPr lang="en-US" sz="1800" b="1" dirty="0">
+                <a:solidFill>
+                  <a:srgbClr val="FFFFFF"/>
+                </a:solidFill>
+              </a:rPr>
+              <a:t>1</a:t>
+            </a:r>
+            <a:endParaRPr lang="en-US" sz="1800" dirty="0"/>
+          </a:p>
+        </p:txBody>
+      </p:sp>
+      <p:sp>
+        <p:nvSpPr>
+          <p:cNvPr id="6" name="Text 4"/>
+          <p:cNvSpPr txBox="1"/>
+          <p:nvPr/>
+        </p:nvSpPr>
+        <p:spPr>
+          <a:xfrm>
+            <a:off x="1371600" y="1069848"/>
+            <a:ext cx="3749040" cy="347472"/>
+          </a:xfrm>
+          <a:prstGeom prst="rect">
+            <a:avLst/>
+          </a:prstGeom>
+          <a:noFill/>
+          <a:ln/>
+        </p:spPr>
+        <p:txBody>
+          <a:bodyPr wrap="square" lIns="0" tIns="0" rIns="0" bIns="0" rtlCol="0" anchor="ctr"/>
+          <a:lstStyle/>
+          <a:p>
+            <a:pPr indent="0" marL="0">
+              <a:buNone/>
+            </a:pPr>
+            <a:r>
+              <a:rPr lang="en-US" sz="1800" b="1" dirty="0">
+                <a:solidFill>
+                  <a:schemeClr val="tx1"/>
+                </a:solidFill>
+              </a:rPr>
+              <a:t>Explore</a:t>
+            </a:r>
+            <a:endParaRPr lang="en-US" sz="1800" dirty="0"/>
+          </a:p>
+        </p:txBody>
+      </p:sp>
+      <p:sp>
+        <p:nvSpPr>
+          <p:cNvPr id="7" name="Text 5"/>
+          <p:cNvSpPr txBox="1"/>
+          <p:nvPr/>
+        </p:nvSpPr>
+        <p:spPr>
+          <a:xfrm>
+            <a:off x="1371600" y="1417320"/>
+            <a:ext cx="3749040" cy="384048"/>
+          </a:xfrm>
+          <a:prstGeom prst="rect">
+            <a:avLst/>
+          </a:prstGeom>
+          <a:noFill/>
+          <a:ln/>
+        </p:spPr>
+        <p:txBody>
+          <a:bodyPr wrap="square" lIns="0" tIns="0" rIns="0" bIns="0" rtlCol="0" anchor="ctr"/>
+          <a:lstStyle/>
+          <a:p>
+            <a:pPr indent="0" marL="0">
+              <a:buNone/>
+            </a:pPr>
+            <a:r>
+              <a:rPr lang="en-US" sz="1400" dirty="0">
+                <a:solidFill>
+                  <a:schemeClr val="accent6"/>
+                </a:solidFill>
+              </a:rPr>
+              <a:t>Pip scouts a real nearby place.</a:t>
+            </a:r>
+            <a:endParaRPr lang="en-US" sz="1400" dirty="0"/>
+          </a:p>
+        </p:txBody>
+      </p:sp>
+      <p:sp>
+        <p:nvSpPr>
+          <p:cNvPr id="8" name="loop-1"/>
+          <p:cNvSpPr/>
+          <p:nvPr/>
+        </p:nvSpPr>
+        <p:spPr>
+          <a:xfrm>
+            <a:off x="457200" y="2057400"/>
+            <a:ext cx="4892040" cy="987552"/>
+          </a:xfrm>
+          <a:prstGeom prst="roundRect">
+            <a:avLst>
+              <a:gd name="adj" fmla="val 12963"/>
+            </a:avLst>
+          </a:prstGeom>
+          <a:solidFill>
+            <a:srgbClr val="FFFFFF"/>
+          </a:solidFill>
+          <a:ln/>
+          <a:effectLst>
+            <a:outerShdw sx="100000" sy="100000" kx="0" ky="0" algn="bl" rotWithShape="0" blurRad="101600" dist="25400" dir="5400000">
+              <a:srgbClr val="0B1F3A">
+                <a:alpha val="10000"/>
+              </a:srgbClr>
+            </a:outerShdw>
+          </a:effectLst>
+        </p:spPr>
+      </p:sp>
+      <p:sp>
+        <p:nvSpPr>
+          <p:cNvPr id="9" name="loop-n-1"/>
+          <p:cNvSpPr/>
+          <p:nvPr/>
+        </p:nvSpPr>
+        <p:spPr>
+          <a:xfrm>
+            <a:off x="621792" y="2258568"/>
+            <a:ext cx="566928" cy="566928"/>
+          </a:xfrm>
+          <a:prstGeom prst="ellipse">
+            <a:avLst/>
+          </a:prstGeom>
+          <a:solidFill>
+            <a:schemeClr val="accent1"/>
+          </a:solidFill>
+          <a:ln/>
+        </p:spPr>
+      </p:sp>
+      <p:sp>
+        <p:nvSpPr>
+          <p:cNvPr id="10" name="Text 8"/>
+          <p:cNvSpPr txBox="1"/>
+          <p:nvPr/>
+        </p:nvSpPr>
+        <p:spPr>
+          <a:xfrm>
+            <a:off x="621792" y="2313432"/>
+            <a:ext cx="566928" cy="457200"/>
+          </a:xfrm>
+          <a:prstGeom prst="rect">
+            <a:avLst/>
+          </a:prstGeom>
+          <a:noFill/>
+          <a:ln/>
+        </p:spPr>
+        <p:txBody>
+          <a:bodyPr wrap="square" lIns="0" tIns="0" rIns="0" bIns="0" rtlCol="0" anchor="ctr"/>
+          <a:lstStyle/>
+          <a:p>
+            <a:pPr algn="ctr" indent="0" marL="0">
+              <a:buNone/>
+            </a:pPr>
+            <a:r>
+              <a:rPr lang="en-US" sz="1800" b="1" dirty="0">
+                <a:solidFill>
+                  <a:srgbClr val="FFFFFF"/>
+                </a:solidFill>
+              </a:rPr>
+              <a:t>2</a:t>
+            </a:r>
+            <a:endParaRPr lang="en-US" sz="1800" dirty="0"/>
+          </a:p>
+        </p:txBody>
+      </p:sp>
+      <p:sp>
+        <p:nvSpPr>
+          <p:cNvPr id="11" name="Text 9"/>
+          <p:cNvSpPr txBox="1"/>
+          <p:nvPr/>
+        </p:nvSpPr>
+        <p:spPr>
+          <a:xfrm>
+            <a:off x="1371600" y="2167128"/>
+            <a:ext cx="3749040" cy="347472"/>
+          </a:xfrm>
+          <a:prstGeom prst="rect">
+            <a:avLst/>
+          </a:prstGeom>
+          <a:noFill/>
+          <a:ln/>
+        </p:spPr>
+        <p:txBody>
+          <a:bodyPr wrap="square" lIns="0" tIns="0" rIns="0" bIns="0" rtlCol="0" anchor="ctr"/>
+          <a:lstStyle/>
+          <a:p>
+            <a:pPr indent="0" marL="0">
+              <a:buNone/>
+            </a:pPr>
+            <a:r>
+              <a:rPr lang="en-US" sz="1800" b="1" dirty="0">
+                <a:solidFill>
+                  <a:schemeClr val="tx1"/>
+                </a:solidFill>
+              </a:rPr>
+              <a:t>Walk</a:t>
+            </a:r>
+            <a:endParaRPr lang="en-US" sz="1800" dirty="0"/>
+          </a:p>
+        </p:txBody>
+      </p:sp>
+      <p:sp>
+        <p:nvSpPr>
+          <p:cNvPr id="12" name="Text 10"/>
+          <p:cNvSpPr txBox="1"/>
+          <p:nvPr/>
+        </p:nvSpPr>
+        <p:spPr>
+          <a:xfrm>
+            <a:off x="1371600" y="2514600"/>
+            <a:ext cx="3749040" cy="384048"/>
+          </a:xfrm>
+          <a:prstGeom prst="rect">
+            <a:avLst/>
+          </a:prstGeom>
+          <a:noFill/>
+          <a:ln/>
+        </p:spPr>
+        <p:txBody>
+          <a:bodyPr wrap="square" lIns="0" tIns="0" rIns="0" bIns="0" rtlCol="0" anchor="ctr"/>
+          <a:lstStyle/>
+          <a:p>
+            <a:pPr indent="0" marL="0">
+              <a:buNone/>
+            </a:pPr>
+            <a:r>
+              <a:rPr lang="en-US" sz="1400" dirty="0">
+                <a:solidFill>
+                  <a:schemeClr val="accent6"/>
+                </a:solidFill>
+              </a:rPr>
+              <a:t>Fern turns it into a route.</a:t>
+            </a:r>
+            <a:endParaRPr lang="en-US" sz="1400" dirty="0"/>
+          </a:p>
+        </p:txBody>
+      </p:sp>
+      <p:sp>
+        <p:nvSpPr>
+          <p:cNvPr id="13" name="loop-2"/>
+          <p:cNvSpPr/>
+          <p:nvPr/>
+        </p:nvSpPr>
+        <p:spPr>
+          <a:xfrm>
+            <a:off x="457200" y="3154680"/>
+            <a:ext cx="4892040" cy="987552"/>
+          </a:xfrm>
+          <a:prstGeom prst="roundRect">
+            <a:avLst>
+              <a:gd name="adj" fmla="val 12963"/>
+            </a:avLst>
+          </a:prstGeom>
+          <a:solidFill>
+            <a:srgbClr val="FFFFFF"/>
+          </a:solidFill>
+          <a:ln/>
+          <a:effectLst>
+            <a:outerShdw sx="100000" sy="100000" kx="0" ky="0" algn="bl" rotWithShape="0" blurRad="101600" dist="25400" dir="5400000">
+              <a:srgbClr val="0B1F3A">
+                <a:alpha val="10000"/>
+              </a:srgbClr>
+            </a:outerShdw>
+          </a:effectLst>
+        </p:spPr>
+      </p:sp>
+      <p:sp>
+        <p:nvSpPr>
+          <p:cNvPr id="14" name="loop-n-2"/>
+          <p:cNvSpPr/>
+          <p:nvPr/>
+        </p:nvSpPr>
+        <p:spPr>
+          <a:xfrm>
+            <a:off x="621792" y="3355848"/>
+            <a:ext cx="566928" cy="566928"/>
+          </a:xfrm>
+          <a:prstGeom prst="ellipse">
+            <a:avLst/>
+          </a:prstGeom>
+          <a:solidFill>
+            <a:schemeClr val="accent1"/>
+          </a:solidFill>
+          <a:ln/>
+        </p:spPr>
+      </p:sp>
+      <p:sp>
+        <p:nvSpPr>
+          <p:cNvPr id="15" name="Text 13"/>
+          <p:cNvSpPr txBox="1"/>
+          <p:nvPr/>
+        </p:nvSpPr>
+        <p:spPr>
+          <a:xfrm>
+            <a:off x="621792" y="3410712"/>
+            <a:ext cx="566928" cy="457200"/>
+          </a:xfrm>
+          <a:prstGeom prst="rect">
+            <a:avLst/>
+          </a:prstGeom>
+          <a:noFill/>
+          <a:ln/>
+        </p:spPr>
+        <p:txBody>
+          <a:bodyPr wrap="square" lIns="0" tIns="0" rIns="0" bIns="0" rtlCol="0" anchor="ctr"/>
+          <a:lstStyle/>
+          <a:p>
+            <a:pPr algn="ctr" indent="0" marL="0">
+              <a:buNone/>
+            </a:pPr>
+            <a:r>
+              <a:rPr lang="en-US" sz="1800" b="1" dirty="0">
+                <a:solidFill>
+                  <a:srgbClr val="FFFFFF"/>
+                </a:solidFill>
+              </a:rPr>
+              <a:t>3</a:t>
+            </a:r>
+            <a:endParaRPr lang="en-US" sz="1800" dirty="0"/>
+          </a:p>
+        </p:txBody>
+      </p:sp>
+      <p:sp>
+        <p:nvSpPr>
+          <p:cNvPr id="16" name="Text 14"/>
+          <p:cNvSpPr txBox="1"/>
+          <p:nvPr/>
+        </p:nvSpPr>
+        <p:spPr>
+          <a:xfrm>
+            <a:off x="1371600" y="3264408"/>
+            <a:ext cx="3749040" cy="347472"/>
+          </a:xfrm>
+          <a:prstGeom prst="rect">
+            <a:avLst/>
+          </a:prstGeom>
+          <a:noFill/>
+          <a:ln/>
+        </p:spPr>
+        <p:txBody>
+          <a:bodyPr wrap="square" lIns="0" tIns="0" rIns="0" bIns="0" rtlCol="0" anchor="ctr"/>
+          <a:lstStyle/>
+          <a:p>
+            <a:pPr indent="0" marL="0">
+              <a:buNone/>
+            </a:pPr>
+            <a:r>
+              <a:rPr lang="en-US" sz="1800" b="1" dirty="0">
+                <a:solidFill>
+                  <a:schemeClr val="tx1"/>
+                </a:solidFill>
+              </a:rPr>
+              <a:t>Discover</a:t>
+            </a:r>
+            <a:endParaRPr lang="en-US" sz="1800" dirty="0"/>
+          </a:p>
+        </p:txBody>
+      </p:sp>
+      <p:sp>
+        <p:nvSpPr>
+          <p:cNvPr id="17" name="Text 15"/>
+          <p:cNvSpPr txBox="1"/>
+          <p:nvPr/>
+        </p:nvSpPr>
+        <p:spPr>
+          <a:xfrm>
+            <a:off x="1371600" y="3611880"/>
+            <a:ext cx="3749040" cy="384048"/>
+          </a:xfrm>
+          <a:prstGeom prst="rect">
+            <a:avLst/>
+          </a:prstGeom>
+          <a:noFill/>
+          <a:ln/>
+        </p:spPr>
+        <p:txBody>
+          <a:bodyPr wrap="square" lIns="0" tIns="0" rIns="0" bIns="0" rtlCol="0" anchor="ctr"/>
+          <a:lstStyle/>
+          <a:p>
+            <a:pPr indent="0" marL="0">
+              <a:buNone/>
+            </a:pPr>
+            <a:r>
+              <a:rPr lang="en-US" sz="1400" dirty="0">
+                <a:solidFill>
+                  <a:schemeClr val="accent6"/>
+                </a:solidFill>
+              </a:rPr>
+              <a:t>Moss tells the grounded story.</a:t>
+            </a:r>
+            <a:endParaRPr lang="en-US" sz="1400" dirty="0"/>
+          </a:p>
+        </p:txBody>
+      </p:sp>
+      <p:sp>
+        <p:nvSpPr>
+          <p:cNvPr id="18" name="loop-3"/>
+          <p:cNvSpPr/>
+          <p:nvPr/>
+        </p:nvSpPr>
+        <p:spPr>
+          <a:xfrm>
+            <a:off x="457200" y="4251960"/>
+            <a:ext cx="4892040" cy="987552"/>
+          </a:xfrm>
+          <a:prstGeom prst="roundRect">
+            <a:avLst>
+              <a:gd name="adj" fmla="val 12963"/>
+            </a:avLst>
+          </a:prstGeom>
+          <a:solidFill>
+            <a:srgbClr val="FFFFFF"/>
+          </a:solidFill>
+          <a:ln/>
+          <a:effectLst>
+            <a:outerShdw sx="100000" sy="100000" kx="0" ky="0" algn="bl" rotWithShape="0" blurRad="101600" dist="25400" dir="5400000">
+              <a:srgbClr val="0B1F3A">
+                <a:alpha val="10000"/>
+              </a:srgbClr>
+            </a:outerShdw>
+          </a:effectLst>
+        </p:spPr>
+      </p:sp>
+      <p:sp>
+        <p:nvSpPr>
+          <p:cNvPr id="19" name="loop-n-3"/>
+          <p:cNvSpPr/>
+          <p:nvPr/>
+        </p:nvSpPr>
+        <p:spPr>
+          <a:xfrm>
+            <a:off x="621792" y="4453128"/>
+            <a:ext cx="566928" cy="566928"/>
+          </a:xfrm>
+          <a:prstGeom prst="ellipse">
+            <a:avLst/>
+          </a:prstGeom>
+          <a:solidFill>
+            <a:schemeClr val="accent1"/>
+          </a:solidFill>
+          <a:ln/>
+        </p:spPr>
+      </p:sp>
+      <p:sp>
+        <p:nvSpPr>
+          <p:cNvPr id="20" name="Text 18"/>
+          <p:cNvSpPr txBox="1"/>
+          <p:nvPr/>
+        </p:nvSpPr>
+        <p:spPr>
+          <a:xfrm>
+            <a:off x="621792" y="4507992"/>
+            <a:ext cx="566928" cy="457200"/>
+          </a:xfrm>
+          <a:prstGeom prst="rect">
+            <a:avLst/>
+          </a:prstGeom>
+          <a:noFill/>
+          <a:ln/>
+        </p:spPr>
+        <p:txBody>
+          <a:bodyPr wrap="square" lIns="0" tIns="0" rIns="0" bIns="0" rtlCol="0" anchor="ctr"/>
+          <a:lstStyle/>
+          <a:p>
+            <a:pPr algn="ctr" indent="0" marL="0">
+              <a:buNone/>
+            </a:pPr>
+            <a:r>
+              <a:rPr lang="en-US" sz="1800" b="1" dirty="0">
+                <a:solidFill>
+                  <a:srgbClr val="FFFFFF"/>
+                </a:solidFill>
+              </a:rPr>
+              <a:t>4</a:t>
+            </a:r>
+            <a:endParaRPr lang="en-US" sz="1800" dirty="0"/>
+          </a:p>
+        </p:txBody>
+      </p:sp>
+      <p:sp>
+        <p:nvSpPr>
+          <p:cNvPr id="21" name="Text 19"/>
+          <p:cNvSpPr txBox="1"/>
+          <p:nvPr/>
+        </p:nvSpPr>
+        <p:spPr>
+          <a:xfrm>
+            <a:off x="1371600" y="4361688"/>
+            <a:ext cx="3749040" cy="347472"/>
+          </a:xfrm>
+          <a:prstGeom prst="rect">
+            <a:avLst/>
+          </a:prstGeom>
+          <a:noFill/>
+          <a:ln/>
+        </p:spPr>
+        <p:txBody>
+          <a:bodyPr wrap="square" lIns="0" tIns="0" rIns="0" bIns="0" rtlCol="0" anchor="ctr"/>
+          <a:lstStyle/>
+          <a:p>
+            <a:pPr indent="0" marL="0">
+              <a:buNone/>
+            </a:pPr>
+            <a:r>
+              <a:rPr lang="en-US" sz="1800" b="1" dirty="0">
+                <a:solidFill>
+                  <a:schemeClr val="tx1"/>
+                </a:solidFill>
+              </a:rPr>
+              <a:t>Collect</a:t>
+            </a:r>
+            <a:endParaRPr lang="en-US" sz="1800" dirty="0"/>
+          </a:p>
+        </p:txBody>
+      </p:sp>
+      <p:sp>
+        <p:nvSpPr>
+          <p:cNvPr id="22" name="Text 20"/>
+          <p:cNvSpPr txBox="1"/>
+          <p:nvPr/>
+        </p:nvSpPr>
+        <p:spPr>
+          <a:xfrm>
+            <a:off x="1371600" y="4709160"/>
+            <a:ext cx="3749040" cy="384048"/>
+          </a:xfrm>
+          <a:prstGeom prst="rect">
+            <a:avLst/>
+          </a:prstGeom>
+          <a:noFill/>
+          <a:ln/>
+        </p:spPr>
+        <p:txBody>
+          <a:bodyPr wrap="square" lIns="0" tIns="0" rIns="0" bIns="0" rtlCol="0" anchor="ctr"/>
+          <a:lstStyle/>
+          <a:p>
+            <a:pPr indent="0" marL="0">
+              <a:buNone/>
+            </a:pPr>
+            <a:r>
+              <a:rPr lang="en-US" sz="1400" dirty="0">
+                <a:solidFill>
+                  <a:schemeClr val="accent6"/>
+                </a:solidFill>
+              </a:rPr>
+              <a:t>Capture it. Walking fills eggs.</a:t>
+            </a:r>
+            <a:endParaRPr lang="en-US" sz="1400" dirty="0"/>
+          </a:p>
+        </p:txBody>
+      </p:sp>
+      <p:sp>
+        <p:nvSpPr>
+          <p:cNvPr id="23" name="solution-phone-frame"/>
+          <p:cNvSpPr/>
+          <p:nvPr/>
+        </p:nvSpPr>
+        <p:spPr>
+          <a:xfrm>
+            <a:off x="5596128" y="841248"/>
+            <a:ext cx="2767440" cy="5221224"/>
+          </a:xfrm>
+          <a:prstGeom prst="roundRect">
+            <a:avLst>
+              <a:gd name="adj" fmla="val 5947"/>
+            </a:avLst>
+          </a:prstGeom>
+          <a:solidFill>
+            <a:srgbClr val="0B1F3A"/>
+          </a:solidFill>
+          <a:ln/>
+        </p:spPr>
+      </p:sp>
       <p:pic>
         <p:nvPicPr>
-          <p:cNvPr id="4" name="art-Explore" descr="G:\broswer download\big-red-hacks2026\docs\presentation\assets\scout.png">    </p:cNvPr>
+          <p:cNvPr id="24" name="solution-phone" descr="G:\broswer download\big-red-hacks2026\docs\presentation\app_images\295D7A3E-924B-40C7-9900-0A4613317A96.jpg">    </p:cNvPr>
           <p:cNvPicPr>
             <a:picLocks noChangeAspect="1"/>
           </p:cNvPicPr>
@@ -2621,8 +3242,8 @@
         </p:blipFill>
         <p:spPr>
           <a:xfrm>
-            <a:off x="1005840" y="1234440"/>
-            <a:ext cx="1783080" cy="1783080"/>
+            <a:off x="5669280" y="914400"/>
+            <a:ext cx="2621136" cy="5074920"/>
           </a:xfrm>
           <a:prstGeom prst="rect">
             <a:avLst/>
@@ -2631,126 +3252,18 @@
       </p:pic>
       <p:sp>
         <p:nvSpPr>
-          <p:cNvPr id="5" name="Text 2"/>
-          <p:cNvSpPr txBox="1"/>
-          <p:nvPr/>
-        </p:nvSpPr>
-        <p:spPr>
-          <a:xfrm>
-            <a:off x="640080" y="3108960"/>
-            <a:ext cx="2514600" cy="411480"/>
-          </a:xfrm>
-          <a:prstGeom prst="rect">
-            <a:avLst/>
-          </a:prstGeom>
-          <a:noFill/>
-          <a:ln/>
-        </p:spPr>
-        <p:txBody>
-          <a:bodyPr wrap="square" lIns="0" tIns="0" rIns="0" bIns="0" rtlCol="0" anchor="ctr"/>
-          <a:lstStyle/>
-          <a:p>
-            <a:pPr algn="ctr" indent="0" marL="0">
-              <a:buNone/>
-            </a:pPr>
-            <a:r>
-              <a:rPr lang="en-US" sz="2200" b="1" dirty="0">
-                <a:solidFill>
-                  <a:schemeClr val="tx1"/>
-                </a:solidFill>
-              </a:rPr>
-              <a:t>Explore</a:t>
-            </a:r>
-            <a:endParaRPr lang="en-US" sz="2200" dirty="0"/>
-          </a:p>
-        </p:txBody>
-      </p:sp>
-      <p:sp>
-        <p:nvSpPr>
-          <p:cNvPr id="6" name="Text 3"/>
-          <p:cNvSpPr txBox="1"/>
-          <p:nvPr/>
-        </p:nvSpPr>
-        <p:spPr>
-          <a:xfrm>
-            <a:off x="640080" y="3520440"/>
-            <a:ext cx="2514600" cy="292608"/>
-          </a:xfrm>
-          <a:prstGeom prst="rect">
-            <a:avLst/>
-          </a:prstGeom>
-          <a:noFill/>
-          <a:ln/>
-        </p:spPr>
-        <p:txBody>
-          <a:bodyPr wrap="square" lIns="0" tIns="0" rIns="0" bIns="0" rtlCol="0" anchor="ctr"/>
-          <a:lstStyle/>
-          <a:p>
-            <a:pPr algn="ctr" indent="0" marL="0">
-              <a:buNone/>
-            </a:pPr>
-            <a:r>
-              <a:rPr lang="en-US" sz="1400" dirty="0">
-                <a:solidFill>
-                  <a:schemeClr val="accent1"/>
-                </a:solidFill>
-              </a:rPr>
-              <a:t>Pip</a:t>
-            </a:r>
-            <a:endParaRPr lang="en-US" sz="1400" dirty="0"/>
-          </a:p>
-        </p:txBody>
-      </p:sp>
-      <p:sp>
-        <p:nvSpPr>
-          <p:cNvPr id="7" name="Text 4"/>
-          <p:cNvSpPr txBox="1"/>
-          <p:nvPr/>
-        </p:nvSpPr>
-        <p:spPr>
-          <a:xfrm>
-            <a:off x="667512" y="3858768"/>
-            <a:ext cx="2468880" cy="1005840"/>
-          </a:xfrm>
-          <a:prstGeom prst="rect">
-            <a:avLst/>
-          </a:prstGeom>
-          <a:noFill/>
-          <a:ln/>
-        </p:spPr>
-        <p:txBody>
-          <a:bodyPr wrap="square" lIns="0" tIns="0" rIns="0" bIns="0" rtlCol="0" anchor="ctr"/>
-          <a:lstStyle/>
-          <a:p>
-            <a:pPr algn="ctr" indent="0" marL="0">
-              <a:buNone/>
-            </a:pPr>
-            <a:r>
-              <a:rPr lang="en-US" sz="1400" dirty="0">
-                <a:solidFill>
-                  <a:schemeClr val="accent6"/>
-                </a:solidFill>
-              </a:rPr>
-              <a:t>Scouts a nearby place with Wikipedia and OSM.</a:t>
-            </a:r>
-            <a:endParaRPr lang="en-US" sz="1400" dirty="0"/>
-          </a:p>
-        </p:txBody>
-      </p:sp>
-      <p:sp>
-        <p:nvSpPr>
-          <p:cNvPr id="8" name="loop-Walk"/>
+          <p:cNvPr id="25" name="sol-call-1"/>
           <p:cNvSpPr/>
           <p:nvPr/>
         </p:nvSpPr>
         <p:spPr>
           <a:xfrm>
-            <a:off x="3429000" y="1051560"/>
-            <a:ext cx="2788920" cy="3977640"/>
+            <a:off x="8455008" y="1691640"/>
+            <a:ext cx="3200400" cy="1234440"/>
           </a:xfrm>
           <a:prstGeom prst="roundRect">
             <a:avLst>
-              <a:gd name="adj" fmla="val 5246"/>
+              <a:gd name="adj" fmla="val 10370"/>
             </a:avLst>
           </a:prstGeom>
           <a:solidFill>
@@ -2760,103 +3273,43 @@
           <a:effectLst>
             <a:outerShdw sx="100000" sy="100000" kx="0" ky="0" algn="bl" rotWithShape="0" blurRad="101600" dist="25400" dir="5400000">
               <a:srgbClr val="0B1F3A">
-                <a:alpha val="8000"/>
+                <a:alpha val="10000"/>
               </a:srgbClr>
             </a:outerShdw>
           </a:effectLst>
         </p:spPr>
       </p:sp>
-      <p:pic>
-        <p:nvPicPr>
-          <p:cNvPr id="9" name="art-Walk" descr="G:\broswer download\big-red-hacks2026\docs\presentation\assets\pathfinder.png">    </p:cNvPr>
-          <p:cNvPicPr>
-            <a:picLocks noChangeAspect="1"/>
-          </p:cNvPicPr>
-          <p:nvPr/>
-        </p:nvPicPr>
-        <p:blipFill>
-          <a:blip r:embed="rId2"/>
-          <a:stretch>
-            <a:fillRect/>
-          </a:stretch>
-        </p:blipFill>
-        <p:spPr>
-          <a:xfrm>
-            <a:off x="3931920" y="1234440"/>
-            <a:ext cx="1783080" cy="1783080"/>
-          </a:xfrm>
-          <a:prstGeom prst="rect">
-            <a:avLst/>
-          </a:prstGeom>
-        </p:spPr>
-      </p:pic>
-      <p:sp>
-        <p:nvSpPr>
-          <p:cNvPr id="10" name="Text 6"/>
-          <p:cNvSpPr txBox="1"/>
-          <p:nvPr/>
-        </p:nvSpPr>
-        <p:spPr>
-          <a:xfrm>
-            <a:off x="3566160" y="3108960"/>
-            <a:ext cx="2514600" cy="411480"/>
-          </a:xfrm>
-          <a:prstGeom prst="rect">
-            <a:avLst/>
-          </a:prstGeom>
-          <a:noFill/>
-          <a:ln/>
-        </p:spPr>
-        <p:txBody>
-          <a:bodyPr wrap="square" lIns="0" tIns="0" rIns="0" bIns="0" rtlCol="0" anchor="ctr"/>
-          <a:lstStyle/>
-          <a:p>
-            <a:pPr algn="ctr" indent="0" marL="0">
-              <a:buNone/>
-            </a:pPr>
-            <a:r>
-              <a:rPr lang="en-US" sz="2200" b="1" dirty="0">
+      <p:sp>
+        <p:nvSpPr>
+          <p:cNvPr id="26" name="Text 23"/>
+          <p:cNvSpPr txBox="1"/>
+          <p:nvPr/>
+        </p:nvSpPr>
+        <p:spPr>
+          <a:xfrm>
+            <a:off x="8583024" y="1764792"/>
+            <a:ext cx="2944368" cy="1088136"/>
+          </a:xfrm>
+          <a:prstGeom prst="rect">
+            <a:avLst/>
+          </a:prstGeom>
+          <a:noFill/>
+          <a:ln/>
+        </p:spPr>
+        <p:txBody>
+          <a:bodyPr wrap="square" lIns="0" tIns="0" rIns="0" bIns="0" rtlCol="0" anchor="ctr"/>
+          <a:lstStyle/>
+          <a:p>
+            <a:pPr indent="0" marL="0">
+              <a:buNone/>
+            </a:pPr>
+            <a:r>
+              <a:rPr lang="en-US" sz="1400" dirty="0">
                 <a:solidFill>
                   <a:schemeClr val="tx1"/>
                 </a:solidFill>
               </a:rPr>
-              <a:t>Walk</a:t>
-            </a:r>
-            <a:endParaRPr lang="en-US" sz="2200" dirty="0"/>
-          </a:p>
-        </p:txBody>
-      </p:sp>
-      <p:sp>
-        <p:nvSpPr>
-          <p:cNvPr id="11" name="Text 7"/>
-          <p:cNvSpPr txBox="1"/>
-          <p:nvPr/>
-        </p:nvSpPr>
-        <p:spPr>
-          <a:xfrm>
-            <a:off x="3566160" y="3520440"/>
-            <a:ext cx="2514600" cy="292608"/>
-          </a:xfrm>
-          <a:prstGeom prst="rect">
-            <a:avLst/>
-          </a:prstGeom>
-          <a:noFill/>
-          <a:ln/>
-        </p:spPr>
-        <p:txBody>
-          <a:bodyPr wrap="square" lIns="0" tIns="0" rIns="0" bIns="0" rtlCol="0" anchor="ctr"/>
-          <a:lstStyle/>
-          <a:p>
-            <a:pPr algn="ctr" indent="0" marL="0">
-              <a:buNone/>
-            </a:pPr>
-            <a:r>
-              <a:rPr lang="en-US" sz="1400" dirty="0">
-                <a:solidFill>
-                  <a:schemeClr val="accent1"/>
-                </a:solidFill>
-              </a:rPr>
-              <a:t>Fern</a:t>
+              <a:t>Bailey Hall, a real campus place.</a:t>
             </a:r>
             <a:endParaRPr lang="en-US" sz="1400" dirty="0"/>
           </a:p>
@@ -2864,54 +3317,18 @@
       </p:sp>
       <p:sp>
         <p:nvSpPr>
-          <p:cNvPr id="12" name="Text 8"/>
-          <p:cNvSpPr txBox="1"/>
-          <p:nvPr/>
-        </p:nvSpPr>
-        <p:spPr>
-          <a:xfrm>
-            <a:off x="3593592" y="3858768"/>
-            <a:ext cx="2468880" cy="1005840"/>
-          </a:xfrm>
-          <a:prstGeom prst="rect">
-            <a:avLst/>
-          </a:prstGeom>
-          <a:noFill/>
-          <a:ln/>
-        </p:spPr>
-        <p:txBody>
-          <a:bodyPr wrap="square" lIns="0" tIns="0" rIns="0" bIns="0" rtlCol="0" anchor="ctr"/>
-          <a:lstStyle/>
-          <a:p>
-            <a:pPr algn="ctr" indent="0" marL="0">
-              <a:buNone/>
-            </a:pPr>
-            <a:r>
-              <a:rPr lang="en-US" sz="1400" dirty="0">
-                <a:solidFill>
-                  <a:schemeClr val="accent6"/>
-                </a:solidFill>
-              </a:rPr>
-              <a:t>Guides the route. The trail blooms.</a:t>
-            </a:r>
-            <a:endParaRPr lang="en-US" sz="1400" dirty="0"/>
-          </a:p>
-        </p:txBody>
-      </p:sp>
-      <p:sp>
-        <p:nvSpPr>
-          <p:cNvPr id="13" name="loop-Discover"/>
+          <p:cNvPr id="27" name="sol-call-2"/>
           <p:cNvSpPr/>
           <p:nvPr/>
         </p:nvSpPr>
         <p:spPr>
           <a:xfrm>
-            <a:off x="6355080" y="1051560"/>
-            <a:ext cx="2788920" cy="3977640"/>
+            <a:off x="8455008" y="3108960"/>
+            <a:ext cx="3200400" cy="1325880"/>
           </a:xfrm>
           <a:prstGeom prst="roundRect">
             <a:avLst>
-              <a:gd name="adj" fmla="val 5246"/>
+              <a:gd name="adj" fmla="val 9655"/>
             </a:avLst>
           </a:prstGeom>
           <a:solidFill>
@@ -2921,338 +3338,45 @@
           <a:effectLst>
             <a:outerShdw sx="100000" sy="100000" kx="0" ky="0" algn="bl" rotWithShape="0" blurRad="101600" dist="25400" dir="5400000">
               <a:srgbClr val="0B1F3A">
-                <a:alpha val="8000"/>
+                <a:alpha val="10000"/>
               </a:srgbClr>
             </a:outerShdw>
           </a:effectLst>
         </p:spPr>
       </p:sp>
-      <p:pic>
-        <p:nvPicPr>
-          <p:cNvPr id="14" name="art-Discover" descr="G:\broswer download\big-red-hacks2026\docs\presentation\assets\storyteller.png">    </p:cNvPr>
-          <p:cNvPicPr>
-            <a:picLocks noChangeAspect="1"/>
-          </p:cNvPicPr>
-          <p:nvPr/>
-        </p:nvPicPr>
-        <p:blipFill>
-          <a:blip r:embed="rId3"/>
-          <a:stretch>
-            <a:fillRect/>
-          </a:stretch>
-        </p:blipFill>
-        <p:spPr>
-          <a:xfrm>
-            <a:off x="6858000" y="1234440"/>
-            <a:ext cx="1783080" cy="1783080"/>
-          </a:xfrm>
-          <a:prstGeom prst="rect">
-            <a:avLst/>
-          </a:prstGeom>
-        </p:spPr>
-      </p:pic>
-      <p:sp>
-        <p:nvSpPr>
-          <p:cNvPr id="15" name="Text 10"/>
-          <p:cNvSpPr txBox="1"/>
-          <p:nvPr/>
-        </p:nvSpPr>
-        <p:spPr>
-          <a:xfrm>
-            <a:off x="6492240" y="3108960"/>
-            <a:ext cx="2514600" cy="411480"/>
-          </a:xfrm>
-          <a:prstGeom prst="rect">
-            <a:avLst/>
-          </a:prstGeom>
-          <a:noFill/>
-          <a:ln/>
-        </p:spPr>
-        <p:txBody>
-          <a:bodyPr wrap="square" lIns="0" tIns="0" rIns="0" bIns="0" rtlCol="0" anchor="ctr"/>
-          <a:lstStyle/>
-          <a:p>
-            <a:pPr algn="ctr" indent="0" marL="0">
-              <a:buNone/>
-            </a:pPr>
-            <a:r>
-              <a:rPr lang="en-US" sz="2200" b="1" dirty="0">
+      <p:sp>
+        <p:nvSpPr>
+          <p:cNvPr id="28" name="Text 25"/>
+          <p:cNvSpPr txBox="1"/>
+          <p:nvPr/>
+        </p:nvSpPr>
+        <p:spPr>
+          <a:xfrm>
+            <a:off x="8583024" y="3182112"/>
+            <a:ext cx="2944368" cy="1179576"/>
+          </a:xfrm>
+          <a:prstGeom prst="rect">
+            <a:avLst/>
+          </a:prstGeom>
+          <a:noFill/>
+          <a:ln/>
+        </p:spPr>
+        <p:txBody>
+          <a:bodyPr wrap="square" lIns="0" tIns="0" rIns="0" bIns="0" rtlCol="0" anchor="ctr"/>
+          <a:lstStyle/>
+          <a:p>
+            <a:pPr indent="0" marL="0">
+              <a:buNone/>
+            </a:pPr>
+            <a:r>
+              <a:rPr lang="en-US" sz="1400" dirty="0">
                 <a:solidFill>
                   <a:schemeClr val="tx1"/>
                 </a:solidFill>
               </a:rPr>
-              <a:t>Discover</a:t>
-            </a:r>
-            <a:endParaRPr lang="en-US" sz="2200" dirty="0"/>
-          </a:p>
-        </p:txBody>
-      </p:sp>
-      <p:sp>
-        <p:nvSpPr>
-          <p:cNvPr id="16" name="Text 11"/>
-          <p:cNvSpPr txBox="1"/>
-          <p:nvPr/>
-        </p:nvSpPr>
-        <p:spPr>
-          <a:xfrm>
-            <a:off x="6492240" y="3520440"/>
-            <a:ext cx="2514600" cy="292608"/>
-          </a:xfrm>
-          <a:prstGeom prst="rect">
-            <a:avLst/>
-          </a:prstGeom>
-          <a:noFill/>
-          <a:ln/>
-        </p:spPr>
-        <p:txBody>
-          <a:bodyPr wrap="square" lIns="0" tIns="0" rIns="0" bIns="0" rtlCol="0" anchor="ctr"/>
-          <a:lstStyle/>
-          <a:p>
-            <a:pPr algn="ctr" indent="0" marL="0">
-              <a:buNone/>
-            </a:pPr>
-            <a:r>
-              <a:rPr lang="en-US" sz="1400" dirty="0">
-                <a:solidFill>
-                  <a:schemeClr val="accent1"/>
-                </a:solidFill>
-              </a:rPr>
-              <a:t>Moss</a:t>
+              <a:t>Pick a squad pet, then tap Walk there.</a:t>
             </a:r>
             <a:endParaRPr lang="en-US" sz="1400" dirty="0"/>
-          </a:p>
-        </p:txBody>
-      </p:sp>
-      <p:sp>
-        <p:nvSpPr>
-          <p:cNvPr id="17" name="Text 12"/>
-          <p:cNvSpPr txBox="1"/>
-          <p:nvPr/>
-        </p:nvSpPr>
-        <p:spPr>
-          <a:xfrm>
-            <a:off x="6519672" y="3858768"/>
-            <a:ext cx="2468880" cy="1005840"/>
-          </a:xfrm>
-          <a:prstGeom prst="rect">
-            <a:avLst/>
-          </a:prstGeom>
-          <a:noFill/>
-          <a:ln/>
-        </p:spPr>
-        <p:txBody>
-          <a:bodyPr wrap="square" lIns="0" tIns="0" rIns="0" bIns="0" rtlCol="0" anchor="ctr"/>
-          <a:lstStyle/>
-          <a:p>
-            <a:pPr algn="ctr" indent="0" marL="0">
-              <a:buNone/>
-            </a:pPr>
-            <a:r>
-              <a:rPr lang="en-US" sz="1400" dirty="0">
-                <a:solidFill>
-                  <a:schemeClr val="accent6"/>
-                </a:solidFill>
-              </a:rPr>
-              <a:t>Tells the grounded story.</a:t>
-            </a:r>
-            <a:endParaRPr lang="en-US" sz="1400" dirty="0"/>
-          </a:p>
-        </p:txBody>
-      </p:sp>
-      <p:sp>
-        <p:nvSpPr>
-          <p:cNvPr id="18" name="loop-Collect"/>
-          <p:cNvSpPr/>
-          <p:nvPr/>
-        </p:nvSpPr>
-        <p:spPr>
-          <a:xfrm>
-            <a:off x="9281160" y="1051560"/>
-            <a:ext cx="2788920" cy="3977640"/>
-          </a:xfrm>
-          <a:prstGeom prst="roundRect">
-            <a:avLst>
-              <a:gd name="adj" fmla="val 5246"/>
-            </a:avLst>
-          </a:prstGeom>
-          <a:solidFill>
-            <a:srgbClr val="FFFFFF"/>
-          </a:solidFill>
-          <a:ln/>
-          <a:effectLst>
-            <a:outerShdw sx="100000" sy="100000" kx="0" ky="0" algn="bl" rotWithShape="0" blurRad="101600" dist="25400" dir="5400000">
-              <a:srgbClr val="0B1F3A">
-                <a:alpha val="8000"/>
-              </a:srgbClr>
-            </a:outerShdw>
-          </a:effectLst>
-        </p:spPr>
-      </p:sp>
-      <p:pic>
-        <p:nvPicPr>
-          <p:cNvPr id="19" name="art-Collect" descr="G:\broswer download\big-red-hacks2026\mobile\assets\badges\gold.png">    </p:cNvPr>
-          <p:cNvPicPr>
-            <a:picLocks noChangeAspect="1"/>
-          </p:cNvPicPr>
-          <p:nvPr/>
-        </p:nvPicPr>
-        <p:blipFill>
-          <a:blip r:embed="rId4"/>
-          <a:stretch>
-            <a:fillRect/>
-          </a:stretch>
-        </p:blipFill>
-        <p:spPr>
-          <a:xfrm>
-            <a:off x="9784080" y="1234440"/>
-            <a:ext cx="1783080" cy="1783080"/>
-          </a:xfrm>
-          <a:prstGeom prst="rect">
-            <a:avLst/>
-          </a:prstGeom>
-        </p:spPr>
-      </p:pic>
-      <p:sp>
-        <p:nvSpPr>
-          <p:cNvPr id="20" name="Text 14"/>
-          <p:cNvSpPr txBox="1"/>
-          <p:nvPr/>
-        </p:nvSpPr>
-        <p:spPr>
-          <a:xfrm>
-            <a:off x="9418320" y="3108960"/>
-            <a:ext cx="2514600" cy="411480"/>
-          </a:xfrm>
-          <a:prstGeom prst="rect">
-            <a:avLst/>
-          </a:prstGeom>
-          <a:noFill/>
-          <a:ln/>
-        </p:spPr>
-        <p:txBody>
-          <a:bodyPr wrap="square" lIns="0" tIns="0" rIns="0" bIns="0" rtlCol="0" anchor="ctr"/>
-          <a:lstStyle/>
-          <a:p>
-            <a:pPr algn="ctr" indent="0" marL="0">
-              <a:buNone/>
-            </a:pPr>
-            <a:r>
-              <a:rPr lang="en-US" sz="2200" b="1" dirty="0">
-                <a:solidFill>
-                  <a:schemeClr val="tx1"/>
-                </a:solidFill>
-              </a:rPr>
-              <a:t>Collect</a:t>
-            </a:r>
-            <a:endParaRPr lang="en-US" sz="2200" dirty="0"/>
-          </a:p>
-        </p:txBody>
-      </p:sp>
-      <p:sp>
-        <p:nvSpPr>
-          <p:cNvPr id="21" name="Text 15"/>
-          <p:cNvSpPr txBox="1"/>
-          <p:nvPr/>
-        </p:nvSpPr>
-        <p:spPr>
-          <a:xfrm>
-            <a:off x="9418320" y="3520440"/>
-            <a:ext cx="2514600" cy="292608"/>
-          </a:xfrm>
-          <a:prstGeom prst="rect">
-            <a:avLst/>
-          </a:prstGeom>
-          <a:noFill/>
-          <a:ln/>
-        </p:spPr>
-        <p:txBody>
-          <a:bodyPr wrap="square" lIns="0" tIns="0" rIns="0" bIns="0" rtlCol="0" anchor="ctr"/>
-          <a:lstStyle/>
-          <a:p>
-            <a:pPr algn="ctr" indent="0" marL="0">
-              <a:buNone/>
-            </a:pPr>
-            <a:r>
-              <a:rPr lang="en-US" sz="1400" dirty="0">
-                <a:solidFill>
-                  <a:schemeClr val="accent1"/>
-                </a:solidFill>
-              </a:rPr>
-              <a:t>You</a:t>
-            </a:r>
-            <a:endParaRPr lang="en-US" sz="1400" dirty="0"/>
-          </a:p>
-        </p:txBody>
-      </p:sp>
-      <p:sp>
-        <p:nvSpPr>
-          <p:cNvPr id="22" name="Text 16"/>
-          <p:cNvSpPr txBox="1"/>
-          <p:nvPr/>
-        </p:nvSpPr>
-        <p:spPr>
-          <a:xfrm>
-            <a:off x="9445752" y="3858768"/>
-            <a:ext cx="2468880" cy="1005840"/>
-          </a:xfrm>
-          <a:prstGeom prst="rect">
-            <a:avLst/>
-          </a:prstGeom>
-          <a:noFill/>
-          <a:ln/>
-        </p:spPr>
-        <p:txBody>
-          <a:bodyPr wrap="square" lIns="0" tIns="0" rIns="0" bIns="0" rtlCol="0" anchor="ctr"/>
-          <a:lstStyle/>
-          <a:p>
-            <a:pPr algn="ctr" indent="0" marL="0">
-              <a:buNone/>
-            </a:pPr>
-            <a:r>
-              <a:rPr lang="en-US" sz="1400" dirty="0">
-                <a:solidFill>
-                  <a:schemeClr val="accent6"/>
-                </a:solidFill>
-              </a:rPr>
-              <a:t>Capture the landmark. Eggs fill as you walk.</a:t>
-            </a:r>
-            <a:endParaRPr lang="en-US" sz="1400" dirty="0"/>
-          </a:p>
-        </p:txBody>
-      </p:sp>
-      <p:sp>
-        <p:nvSpPr>
-          <p:cNvPr id="23" name="Text 17"/>
-          <p:cNvSpPr txBox="1"/>
-          <p:nvPr/>
-        </p:nvSpPr>
-        <p:spPr>
-          <a:xfrm>
-            <a:off x="548640" y="5166360"/>
-            <a:ext cx="11064240" cy="1097280"/>
-          </a:xfrm>
-          <a:prstGeom prst="rect">
-            <a:avLst/>
-          </a:prstGeom>
-          <a:noFill/>
-          <a:ln/>
-        </p:spPr>
-        <p:txBody>
-          <a:bodyPr wrap="square" lIns="0" tIns="0" rIns="0" bIns="0" rtlCol="0" anchor="ctr"/>
-          <a:lstStyle/>
-          <a:p>
-            <a:pPr indent="0" marL="0">
-              <a:buNone/>
-            </a:pPr>
-            <a:r>
-              <a:rPr lang="en-US" sz="1600" dirty="0">
-                <a:solidFill>
-                  <a:schemeClr val="accent6"/>
-                </a:solidFill>
-              </a:rPr>
-              <a:t>Pip, Fern, and Moss — original art from the app.</a:t>
-            </a:r>
-            <a:endParaRPr lang="en-US" sz="1600" dirty="0"/>
           </a:p>
         </p:txBody>
       </p:sp>
@@ -3291,8 +3415,8 @@
         </p:nvSpPr>
         <p:spPr>
           <a:xfrm>
-            <a:off x="548640" y="256032"/>
-            <a:ext cx="11064240" cy="658368"/>
+            <a:off x="457200" y="201168"/>
+            <a:ext cx="11247120" cy="566928"/>
           </a:xfrm>
           <a:prstGeom prst="rect">
             <a:avLst/>
@@ -3308,14 +3432,14 @@
               <a:buNone/>
             </a:pPr>
             <a:r>
-              <a:rPr lang="en-US" sz="3600" b="1" dirty="0">
+              <a:rPr lang="en-US" sz="3000" b="1" dirty="0">
                 <a:solidFill>
                   <a:schemeClr val="tx1"/>
                 </a:solidFill>
               </a:rPr>
               <a:t>Keep this slide up. Hand them the phone.</a:t>
             </a:r>
-            <a:endParaRPr lang="en-US" sz="3600" dirty="0"/>
+            <a:endParaRPr lang="en-US" sz="3000" dirty="0"/>
           </a:p>
         </p:txBody>
       </p:sp>
@@ -3327,22 +3451,22 @@
         </p:nvSpPr>
         <p:spPr>
           <a:xfrm>
-            <a:off x="548640" y="1051560"/>
-            <a:ext cx="11109960" cy="685800"/>
+            <a:off x="457200" y="868680"/>
+            <a:ext cx="11292840" cy="530352"/>
           </a:xfrm>
           <a:prstGeom prst="roundRect">
             <a:avLst>
-              <a:gd name="adj" fmla="val 21333"/>
+              <a:gd name="adj" fmla="val 24138"/>
             </a:avLst>
           </a:prstGeom>
           <a:solidFill>
-            <a:schemeClr val="tx2"/>
+            <a:srgbClr val="0B1F3A"/>
           </a:solidFill>
           <a:ln/>
           <a:effectLst>
             <a:outerShdw sx="100000" sy="100000" kx="0" ky="0" algn="bl" rotWithShape="0" blurRad="101600" dist="25400" dir="5400000">
               <a:srgbClr val="0B1F3A">
-                <a:alpha val="8000"/>
+                <a:alpha val="10000"/>
               </a:srgbClr>
             </a:outerShdw>
           </a:effectLst>
@@ -3356,8 +3480,8 @@
         </p:nvSpPr>
         <p:spPr>
           <a:xfrm>
-            <a:off x="731520" y="1143000"/>
-            <a:ext cx="10744200" cy="502920"/>
+            <a:off x="594360" y="932688"/>
+            <a:ext cx="11018520" cy="402336"/>
           </a:xfrm>
           <a:prstGeom prst="rect">
             <a:avLst/>
@@ -3373,31 +3497,101 @@
               <a:buNone/>
             </a:pPr>
             <a:r>
-              <a:rPr lang="en-US" sz="2000" b="1" dirty="0">
+              <a:rPr lang="en-US" sz="1800" b="1" dirty="0">
                 <a:solidFill>
                   <a:schemeClr val="accent3"/>
                 </a:solidFill>
               </a:rPr>
-              <a:t>Demo Walk is ON  ·  steps are simulated at the table</a:t>
-            </a:r>
-            <a:endParaRPr lang="en-US" sz="2000" dirty="0"/>
-          </a:p>
-        </p:txBody>
-      </p:sp>
-      <p:sp>
-        <p:nvSpPr>
-          <p:cNvPr id="5" name="demo-1"/>
+              <a:t>Demo Walk is ON  ·  steps at the table are simulated</a:t>
+            </a:r>
+            <a:endParaRPr lang="en-US" sz="1800" dirty="0"/>
+          </a:p>
+        </p:txBody>
+      </p:sp>
+      <p:pic>
+        <p:nvPicPr>
+          <p:cNvPr id="5" name="demo-league" descr="G:\broswer download\big-red-hacks2026\docs\presentation\app_images\ED702DFD-F3B0-4517-8C60-E4FEB548C8EB.jpg">    </p:cNvPr>
+          <p:cNvPicPr>
+            <a:picLocks noChangeAspect="1"/>
+          </p:cNvPicPr>
+          <p:nvPr/>
+        </p:nvPicPr>
+        <p:blipFill>
+          <a:blip r:embed="rId1"/>
+          <a:stretch>
+            <a:fillRect/>
+          </a:stretch>
+        </p:blipFill>
+        <p:spPr>
+          <a:xfrm>
+            <a:off x="457200" y="1554480"/>
+            <a:ext cx="4089313" cy="4160520"/>
+          </a:xfrm>
+          <a:prstGeom prst="rect">
+            <a:avLst/>
+          </a:prstGeom>
+        </p:spPr>
+      </p:pic>
+      <p:sp>
+        <p:nvSpPr>
+          <p:cNvPr id="6" name="demo-walk-frame"/>
           <p:cNvSpPr/>
           <p:nvPr/>
         </p:nvSpPr>
         <p:spPr>
           <a:xfrm>
-            <a:off x="548640" y="1965960"/>
-            <a:ext cx="2788920" cy="2331720"/>
+            <a:off x="4674529" y="1481328"/>
+            <a:ext cx="2295164" cy="4306824"/>
           </a:xfrm>
           <a:prstGeom prst="roundRect">
             <a:avLst>
-              <a:gd name="adj" fmla="val 6275"/>
+              <a:gd name="adj" fmla="val 7171"/>
+            </a:avLst>
+          </a:prstGeom>
+          <a:solidFill>
+            <a:srgbClr val="0B1F3A"/>
+          </a:solidFill>
+          <a:ln/>
+        </p:spPr>
+      </p:sp>
+      <p:pic>
+        <p:nvPicPr>
+          <p:cNvPr id="7" name="demo-walk" descr="G:\broswer download\big-red-hacks2026\docs\presentation\app_images\295D7A3E-924B-40C7-9900-0A4613317A96.jpg">    </p:cNvPr>
+          <p:cNvPicPr>
+            <a:picLocks noChangeAspect="1"/>
+          </p:cNvPicPr>
+          <p:nvPr/>
+        </p:nvPicPr>
+        <p:blipFill>
+          <a:blip r:embed="rId2"/>
+          <a:stretch>
+            <a:fillRect/>
+          </a:stretch>
+        </p:blipFill>
+        <p:spPr>
+          <a:xfrm>
+            <a:off x="4747681" y="1554480"/>
+            <a:ext cx="2148860" cy="4160520"/>
+          </a:xfrm>
+          <a:prstGeom prst="rect">
+            <a:avLst/>
+          </a:prstGeom>
+        </p:spPr>
+      </p:pic>
+      <p:sp>
+        <p:nvSpPr>
+          <p:cNvPr id="8" name="c1"/>
+          <p:cNvSpPr/>
+          <p:nvPr/>
+        </p:nvSpPr>
+        <p:spPr>
+          <a:xfrm>
+            <a:off x="7097709" y="1554480"/>
+            <a:ext cx="4652331" cy="1280160"/>
+          </a:xfrm>
+          <a:prstGeom prst="roundRect">
+            <a:avLst>
+              <a:gd name="adj" fmla="val 10000"/>
             </a:avLst>
           </a:prstGeom>
           <a:solidFill>
@@ -3407,7 +3601,7 @@
           <a:effectLst>
             <a:outerShdw sx="100000" sy="100000" kx="0" ky="0" algn="bl" rotWithShape="0" blurRad="101600" dist="25400" dir="5400000">
               <a:srgbClr val="0B1F3A">
-                <a:alpha val="8000"/>
+                <a:alpha val="10000"/>
               </a:srgbClr>
             </a:outerShdw>
           </a:effectLst>
@@ -3415,110 +3609,54 @@
       </p:sp>
       <p:sp>
         <p:nvSpPr>
-          <p:cNvPr id="6" name="n-1"/>
+          <p:cNvPr id="9" name="Text 5"/>
+          <p:cNvSpPr txBox="1"/>
+          <p:nvPr/>
+        </p:nvSpPr>
+        <p:spPr>
+          <a:xfrm>
+            <a:off x="7225725" y="1627632"/>
+            <a:ext cx="4396299" cy="1133856"/>
+          </a:xfrm>
+          <a:prstGeom prst="rect">
+            <a:avLst/>
+          </a:prstGeom>
+          <a:noFill/>
+          <a:ln/>
+        </p:spPr>
+        <p:txBody>
+          <a:bodyPr wrap="square" lIns="0" tIns="0" rIns="0" bIns="0" rtlCol="0" anchor="ctr"/>
+          <a:lstStyle/>
+          <a:p>
+            <a:pPr indent="0" marL="0">
+              <a:buNone/>
+            </a:pPr>
+            <a:r>
+              <a:rPr lang="en-US" sz="1400" dirty="0">
+                <a:solidFill>
+                  <a:schemeClr val="tx1"/>
+                </a:solidFill>
+              </a:rPr>
+              <a:t>1–2  Pip explores. League-up. Practice walk.</a:t>
+            </a:r>
+            <a:endParaRPr lang="en-US" sz="1400" dirty="0"/>
+          </a:p>
+        </p:txBody>
+      </p:sp>
+      <p:sp>
+        <p:nvSpPr>
+          <p:cNvPr id="10" name="c2"/>
           <p:cNvSpPr/>
           <p:nvPr/>
         </p:nvSpPr>
         <p:spPr>
           <a:xfrm>
-            <a:off x="1554480" y="2194560"/>
-            <a:ext cx="731520" cy="731520"/>
-          </a:xfrm>
-          <a:prstGeom prst="ellipse">
-            <a:avLst/>
-          </a:prstGeom>
-          <a:solidFill>
-            <a:schemeClr val="accent1"/>
-          </a:solidFill>
-          <a:ln/>
-        </p:spPr>
-      </p:sp>
-      <p:sp>
-        <p:nvSpPr>
-          <p:cNvPr id="7" name="Text 5"/>
-          <p:cNvSpPr txBox="1"/>
-          <p:nvPr/>
-        </p:nvSpPr>
-        <p:spPr>
-          <a:xfrm>
-            <a:off x="1554480" y="2286000"/>
-            <a:ext cx="731520" cy="548640"/>
-          </a:xfrm>
-          <a:prstGeom prst="rect">
-            <a:avLst/>
-          </a:prstGeom>
-          <a:noFill/>
-          <a:ln/>
-        </p:spPr>
-        <p:txBody>
-          <a:bodyPr wrap="square" lIns="0" tIns="0" rIns="0" bIns="0" rtlCol="0" anchor="ctr"/>
-          <a:lstStyle/>
-          <a:p>
-            <a:pPr algn="ctr" indent="0" marL="0">
-              <a:buNone/>
-            </a:pPr>
-            <a:r>
-              <a:rPr lang="en-US" sz="2400" b="1" dirty="0">
-                <a:solidFill>
-                  <a:srgbClr val="FFFFFF"/>
-                </a:solidFill>
-              </a:rPr>
-              <a:t>1</a:t>
-            </a:r>
-            <a:endParaRPr lang="en-US" sz="2400" dirty="0"/>
-          </a:p>
-        </p:txBody>
-      </p:sp>
-      <p:sp>
-        <p:nvSpPr>
-          <p:cNvPr id="8" name="Text 6"/>
-          <p:cNvSpPr txBox="1"/>
-          <p:nvPr/>
-        </p:nvSpPr>
-        <p:spPr>
-          <a:xfrm>
-            <a:off x="685800" y="3108960"/>
-            <a:ext cx="2514600" cy="868680"/>
-          </a:xfrm>
-          <a:prstGeom prst="rect">
-            <a:avLst/>
-          </a:prstGeom>
-          <a:noFill/>
-          <a:ln/>
-        </p:spPr>
-        <p:txBody>
-          <a:bodyPr wrap="square" lIns="0" tIns="0" rIns="0" bIns="0" rtlCol="0" anchor="ctr"/>
-          <a:lstStyle/>
-          <a:p>
-            <a:pPr algn="ctr" indent="0" marL="0">
-              <a:buNone/>
-            </a:pPr>
-            <a:r>
-              <a:rPr lang="en-US" sz="2200" b="1" dirty="0">
-                <a:solidFill>
-                  <a:schemeClr val="tx1"/>
-                </a:solidFill>
-              </a:rPr>
-              <a:t>Pip explores</a:t>
-            </a:r>
-            <a:endParaRPr lang="en-US" sz="2200" dirty="0"/>
-          </a:p>
-        </p:txBody>
-      </p:sp>
-      <p:sp>
-        <p:nvSpPr>
-          <p:cNvPr id="9" name="demo-2"/>
-          <p:cNvSpPr/>
-          <p:nvPr/>
-        </p:nvSpPr>
-        <p:spPr>
-          <a:xfrm>
-            <a:off x="3474720" y="1965960"/>
-            <a:ext cx="2788920" cy="2331720"/>
+            <a:off x="7097709" y="2971800"/>
+            <a:ext cx="4652331" cy="1280160"/>
           </a:xfrm>
           <a:prstGeom prst="roundRect">
             <a:avLst>
-              <a:gd name="adj" fmla="val 6275"/>
+              <a:gd name="adj" fmla="val 10000"/>
             </a:avLst>
           </a:prstGeom>
           <a:solidFill>
@@ -3528,7 +3666,7 @@
           <a:effectLst>
             <a:outerShdw sx="100000" sy="100000" kx="0" ky="0" algn="bl" rotWithShape="0" blurRad="101600" dist="25400" dir="5400000">
               <a:srgbClr val="0B1F3A">
-                <a:alpha val="8000"/>
+                <a:alpha val="10000"/>
               </a:srgbClr>
             </a:outerShdw>
           </a:effectLst>
@@ -3536,110 +3674,54 @@
       </p:sp>
       <p:sp>
         <p:nvSpPr>
-          <p:cNvPr id="10" name="n-2"/>
+          <p:cNvPr id="11" name="Text 7"/>
+          <p:cNvSpPr txBox="1"/>
+          <p:nvPr/>
+        </p:nvSpPr>
+        <p:spPr>
+          <a:xfrm>
+            <a:off x="7225725" y="3044952"/>
+            <a:ext cx="4396299" cy="1133856"/>
+          </a:xfrm>
+          <a:prstGeom prst="rect">
+            <a:avLst/>
+          </a:prstGeom>
+          <a:noFill/>
+          <a:ln/>
+        </p:spPr>
+        <p:txBody>
+          <a:bodyPr wrap="square" lIns="0" tIns="0" rIns="0" bIns="0" rtlCol="0" anchor="ctr"/>
+          <a:lstStyle/>
+          <a:p>
+            <a:pPr indent="0" marL="0">
+              <a:buNone/>
+            </a:pPr>
+            <a:r>
+              <a:rPr lang="en-US" sz="1400" dirty="0">
+                <a:solidFill>
+                  <a:schemeClr val="tx1"/>
+                </a:solidFill>
+              </a:rPr>
+              <a:t>3  Pick Bailey Hall. Start the 161 m walk.</a:t>
+            </a:r>
+            <a:endParaRPr lang="en-US" sz="1400" dirty="0"/>
+          </a:p>
+        </p:txBody>
+      </p:sp>
+      <p:sp>
+        <p:nvSpPr>
+          <p:cNvPr id="12" name="c3"/>
           <p:cNvSpPr/>
           <p:nvPr/>
         </p:nvSpPr>
         <p:spPr>
           <a:xfrm>
-            <a:off x="4480560" y="2194560"/>
-            <a:ext cx="731520" cy="731520"/>
-          </a:xfrm>
-          <a:prstGeom prst="ellipse">
-            <a:avLst/>
-          </a:prstGeom>
-          <a:solidFill>
-            <a:schemeClr val="accent1"/>
-          </a:solidFill>
-          <a:ln/>
-        </p:spPr>
-      </p:sp>
-      <p:sp>
-        <p:nvSpPr>
-          <p:cNvPr id="11" name="Text 9"/>
-          <p:cNvSpPr txBox="1"/>
-          <p:nvPr/>
-        </p:nvSpPr>
-        <p:spPr>
-          <a:xfrm>
-            <a:off x="4480560" y="2286000"/>
-            <a:ext cx="731520" cy="548640"/>
-          </a:xfrm>
-          <a:prstGeom prst="rect">
-            <a:avLst/>
-          </a:prstGeom>
-          <a:noFill/>
-          <a:ln/>
-        </p:spPr>
-        <p:txBody>
-          <a:bodyPr wrap="square" lIns="0" tIns="0" rIns="0" bIns="0" rtlCol="0" anchor="ctr"/>
-          <a:lstStyle/>
-          <a:p>
-            <a:pPr algn="ctr" indent="0" marL="0">
-              <a:buNone/>
-            </a:pPr>
-            <a:r>
-              <a:rPr lang="en-US" sz="2400" b="1" dirty="0">
-                <a:solidFill>
-                  <a:srgbClr val="FFFFFF"/>
-                </a:solidFill>
-              </a:rPr>
-              <a:t>2</a:t>
-            </a:r>
-            <a:endParaRPr lang="en-US" sz="2400" dirty="0"/>
-          </a:p>
-        </p:txBody>
-      </p:sp>
-      <p:sp>
-        <p:nvSpPr>
-          <p:cNvPr id="12" name="Text 10"/>
-          <p:cNvSpPr txBox="1"/>
-          <p:nvPr/>
-        </p:nvSpPr>
-        <p:spPr>
-          <a:xfrm>
-            <a:off x="3611880" y="3108960"/>
-            <a:ext cx="2514600" cy="868680"/>
-          </a:xfrm>
-          <a:prstGeom prst="rect">
-            <a:avLst/>
-          </a:prstGeom>
-          <a:noFill/>
-          <a:ln/>
-        </p:spPr>
-        <p:txBody>
-          <a:bodyPr wrap="square" lIns="0" tIns="0" rIns="0" bIns="0" rtlCol="0" anchor="ctr"/>
-          <a:lstStyle/>
-          <a:p>
-            <a:pPr algn="ctr" indent="0" marL="0">
-              <a:buNone/>
-            </a:pPr>
-            <a:r>
-              <a:rPr lang="en-US" sz="2200" b="1" dirty="0">
-                <a:solidFill>
-                  <a:schemeClr val="tx1"/>
-                </a:solidFill>
-              </a:rPr>
-              <a:t>Choose a place</a:t>
-            </a:r>
-            <a:endParaRPr lang="en-US" sz="2200" dirty="0"/>
-          </a:p>
-        </p:txBody>
-      </p:sp>
-      <p:sp>
-        <p:nvSpPr>
-          <p:cNvPr id="13" name="demo-3"/>
-          <p:cNvSpPr/>
-          <p:nvPr/>
-        </p:nvSpPr>
-        <p:spPr>
-          <a:xfrm>
-            <a:off x="6400800" y="1965960"/>
-            <a:ext cx="2788920" cy="2331720"/>
+            <a:off x="7097709" y="4389120"/>
+            <a:ext cx="4652331" cy="1280160"/>
           </a:xfrm>
           <a:prstGeom prst="roundRect">
             <a:avLst>
-              <a:gd name="adj" fmla="val 6275"/>
+              <a:gd name="adj" fmla="val 10000"/>
             </a:avLst>
           </a:prstGeom>
           <a:solidFill>
@@ -3649,7 +3731,7 @@
           <a:effectLst>
             <a:outerShdw sx="100000" sy="100000" kx="0" ky="0" algn="bl" rotWithShape="0" blurRad="101600" dist="25400" dir="5400000">
               <a:srgbClr val="0B1F3A">
-                <a:alpha val="8000"/>
+                <a:alpha val="10000"/>
               </a:srgbClr>
             </a:outerShdw>
           </a:effectLst>
@@ -3657,315 +3739,37 @@
       </p:sp>
       <p:sp>
         <p:nvSpPr>
-          <p:cNvPr id="14" name="n-3"/>
-          <p:cNvSpPr/>
-          <p:nvPr/>
-        </p:nvSpPr>
-        <p:spPr>
-          <a:xfrm>
-            <a:off x="7406640" y="2194560"/>
-            <a:ext cx="731520" cy="731520"/>
-          </a:xfrm>
-          <a:prstGeom prst="ellipse">
-            <a:avLst/>
-          </a:prstGeom>
-          <a:solidFill>
-            <a:schemeClr val="accent1"/>
-          </a:solidFill>
-          <a:ln/>
-        </p:spPr>
-      </p:sp>
-      <p:sp>
-        <p:nvSpPr>
-          <p:cNvPr id="15" name="Text 13"/>
-          <p:cNvSpPr txBox="1"/>
-          <p:nvPr/>
-        </p:nvSpPr>
-        <p:spPr>
-          <a:xfrm>
-            <a:off x="7406640" y="2286000"/>
-            <a:ext cx="731520" cy="548640"/>
-          </a:xfrm>
-          <a:prstGeom prst="rect">
-            <a:avLst/>
-          </a:prstGeom>
-          <a:noFill/>
-          <a:ln/>
-        </p:spPr>
-        <p:txBody>
-          <a:bodyPr wrap="square" lIns="0" tIns="0" rIns="0" bIns="0" rtlCol="0" anchor="ctr"/>
-          <a:lstStyle/>
-          <a:p>
-            <a:pPr algn="ctr" indent="0" marL="0">
-              <a:buNone/>
-            </a:pPr>
-            <a:r>
-              <a:rPr lang="en-US" sz="2400" b="1" dirty="0">
-                <a:solidFill>
-                  <a:srgbClr val="FFFFFF"/>
-                </a:solidFill>
-              </a:rPr>
-              <a:t>3</a:t>
-            </a:r>
-            <a:endParaRPr lang="en-US" sz="2400" dirty="0"/>
-          </a:p>
-        </p:txBody>
-      </p:sp>
-      <p:sp>
-        <p:nvSpPr>
-          <p:cNvPr id="16" name="Text 14"/>
-          <p:cNvSpPr txBox="1"/>
-          <p:nvPr/>
-        </p:nvSpPr>
-        <p:spPr>
-          <a:xfrm>
-            <a:off x="6537960" y="3108960"/>
-            <a:ext cx="2514600" cy="868680"/>
-          </a:xfrm>
-          <a:prstGeom prst="rect">
-            <a:avLst/>
-          </a:prstGeom>
-          <a:noFill/>
-          <a:ln/>
-        </p:spPr>
-        <p:txBody>
-          <a:bodyPr wrap="square" lIns="0" tIns="0" rIns="0" bIns="0" rtlCol="0" anchor="ctr"/>
-          <a:lstStyle/>
-          <a:p>
-            <a:pPr algn="ctr" indent="0" marL="0">
-              <a:buNone/>
-            </a:pPr>
-            <a:r>
-              <a:rPr lang="en-US" sz="2200" b="1" dirty="0">
+          <p:cNvPr id="13" name="Text 9"/>
+          <p:cNvSpPr txBox="1"/>
+          <p:nvPr/>
+        </p:nvSpPr>
+        <p:spPr>
+          <a:xfrm>
+            <a:off x="7225725" y="4462272"/>
+            <a:ext cx="4396299" cy="1133856"/>
+          </a:xfrm>
+          <a:prstGeom prst="rect">
+            <a:avLst/>
+          </a:prstGeom>
+          <a:noFill/>
+          <a:ln/>
+        </p:spPr>
+        <p:txBody>
+          <a:bodyPr wrap="square" lIns="0" tIns="0" rIns="0" bIns="0" rtlCol="0" anchor="ctr"/>
+          <a:lstStyle/>
+          <a:p>
+            <a:pPr indent="0" marL="0">
+              <a:buNone/>
+            </a:pPr>
+            <a:r>
+              <a:rPr lang="en-US" sz="1400" dirty="0">
                 <a:solidFill>
                   <a:schemeClr val="tx1"/>
                 </a:solidFill>
               </a:rPr>
-              <a:t>Start a walk</a:t>
-            </a:r>
-            <a:endParaRPr lang="en-US" sz="2200" dirty="0"/>
-          </a:p>
-        </p:txBody>
-      </p:sp>
-      <p:sp>
-        <p:nvSpPr>
-          <p:cNvPr id="17" name="demo-4"/>
-          <p:cNvSpPr/>
-          <p:nvPr/>
-        </p:nvSpPr>
-        <p:spPr>
-          <a:xfrm>
-            <a:off x="9326880" y="1965960"/>
-            <a:ext cx="2788920" cy="2331720"/>
-          </a:xfrm>
-          <a:prstGeom prst="roundRect">
-            <a:avLst>
-              <a:gd name="adj" fmla="val 6275"/>
-            </a:avLst>
-          </a:prstGeom>
-          <a:solidFill>
-            <a:srgbClr val="FFFFFF"/>
-          </a:solidFill>
-          <a:ln/>
-          <a:effectLst>
-            <a:outerShdw sx="100000" sy="100000" kx="0" ky="0" algn="bl" rotWithShape="0" blurRad="101600" dist="25400" dir="5400000">
-              <a:srgbClr val="0B1F3A">
-                <a:alpha val="8000"/>
-              </a:srgbClr>
-            </a:outerShdw>
-          </a:effectLst>
-        </p:spPr>
-      </p:sp>
-      <p:sp>
-        <p:nvSpPr>
-          <p:cNvPr id="18" name="n-4"/>
-          <p:cNvSpPr/>
-          <p:nvPr/>
-        </p:nvSpPr>
-        <p:spPr>
-          <a:xfrm>
-            <a:off x="10332720" y="2194560"/>
-            <a:ext cx="731520" cy="731520"/>
-          </a:xfrm>
-          <a:prstGeom prst="ellipse">
-            <a:avLst/>
-          </a:prstGeom>
-          <a:solidFill>
-            <a:schemeClr val="accent1"/>
-          </a:solidFill>
-          <a:ln/>
-        </p:spPr>
-      </p:sp>
-      <p:sp>
-        <p:nvSpPr>
-          <p:cNvPr id="19" name="Text 17"/>
-          <p:cNvSpPr txBox="1"/>
-          <p:nvPr/>
-        </p:nvSpPr>
-        <p:spPr>
-          <a:xfrm>
-            <a:off x="10332720" y="2286000"/>
-            <a:ext cx="731520" cy="548640"/>
-          </a:xfrm>
-          <a:prstGeom prst="rect">
-            <a:avLst/>
-          </a:prstGeom>
-          <a:noFill/>
-          <a:ln/>
-        </p:spPr>
-        <p:txBody>
-          <a:bodyPr wrap="square" lIns="0" tIns="0" rIns="0" bIns="0" rtlCol="0" anchor="ctr"/>
-          <a:lstStyle/>
-          <a:p>
-            <a:pPr algn="ctr" indent="0" marL="0">
-              <a:buNone/>
-            </a:pPr>
-            <a:r>
-              <a:rPr lang="en-US" sz="2400" b="1" dirty="0">
-                <a:solidFill>
-                  <a:srgbClr val="FFFFFF"/>
-                </a:solidFill>
-              </a:rPr>
-              <a:t>4</a:t>
-            </a:r>
-            <a:endParaRPr lang="en-US" sz="2400" dirty="0"/>
-          </a:p>
-        </p:txBody>
-      </p:sp>
-      <p:sp>
-        <p:nvSpPr>
-          <p:cNvPr id="20" name="Text 18"/>
-          <p:cNvSpPr txBox="1"/>
-          <p:nvPr/>
-        </p:nvSpPr>
-        <p:spPr>
-          <a:xfrm>
-            <a:off x="9464040" y="3108960"/>
-            <a:ext cx="2514600" cy="868680"/>
-          </a:xfrm>
-          <a:prstGeom prst="rect">
-            <a:avLst/>
-          </a:prstGeom>
-          <a:noFill/>
-          <a:ln/>
-        </p:spPr>
-        <p:txBody>
-          <a:bodyPr wrap="square" lIns="0" tIns="0" rIns="0" bIns="0" rtlCol="0" anchor="ctr"/>
-          <a:lstStyle/>
-          <a:p>
-            <a:pPr algn="ctr" indent="0" marL="0">
-              <a:buNone/>
-            </a:pPr>
-            <a:r>
-              <a:rPr lang="en-US" sz="2200" b="1" dirty="0">
-                <a:solidFill>
-                  <a:schemeClr val="tx1"/>
-                </a:solidFill>
-              </a:rPr>
-              <a:t>Capture</a:t>
-            </a:r>
-            <a:endParaRPr lang="en-US" sz="2200" dirty="0"/>
-          </a:p>
-        </p:txBody>
-      </p:sp>
-      <p:sp>
-        <p:nvSpPr>
-          <p:cNvPr id="21" name="missing-shots"/>
-          <p:cNvSpPr/>
-          <p:nvPr/>
-        </p:nvSpPr>
-        <p:spPr>
-          <a:xfrm>
-            <a:off x="548640" y="4526280"/>
-            <a:ext cx="11109960" cy="1691640"/>
-          </a:xfrm>
-          <a:prstGeom prst="roundRect">
-            <a:avLst>
-              <a:gd name="adj" fmla="val 8649"/>
-            </a:avLst>
-          </a:prstGeom>
-          <a:solidFill>
-            <a:srgbClr val="E8F5FF"/>
-          </a:solidFill>
-          <a:ln/>
-          <a:effectLst>
-            <a:outerShdw sx="100000" sy="100000" kx="0" ky="0" algn="bl" rotWithShape="0" blurRad="101600" dist="25400" dir="5400000">
-              <a:srgbClr val="0B1F3A">
-                <a:alpha val="8000"/>
-              </a:srgbClr>
-            </a:outerShdw>
-          </a:effectLst>
-        </p:spPr>
-      </p:sp>
-      <p:sp>
-        <p:nvSpPr>
-          <p:cNvPr id="22" name="Text 20"/>
-          <p:cNvSpPr txBox="1"/>
-          <p:nvPr/>
-        </p:nvSpPr>
-        <p:spPr>
-          <a:xfrm>
-            <a:off x="777240" y="4709160"/>
-            <a:ext cx="10652760" cy="457200"/>
-          </a:xfrm>
-          <a:prstGeom prst="rect">
-            <a:avLst/>
-          </a:prstGeom>
-          <a:noFill/>
-          <a:ln/>
-        </p:spPr>
-        <p:txBody>
-          <a:bodyPr wrap="square" lIns="0" tIns="0" rIns="0" bIns="0" rtlCol="0" anchor="ctr"/>
-          <a:lstStyle/>
-          <a:p>
-            <a:pPr indent="0" marL="0">
-              <a:buNone/>
-            </a:pPr>
-            <a:r>
-              <a:rPr lang="en-US" sz="2200" b="1" dirty="0">
-                <a:solidFill>
-                  <a:schemeClr val="tx1"/>
-                </a:solidFill>
-              </a:rPr>
-              <a:t>Follow these four taps on the phone.</a:t>
-            </a:r>
-            <a:endParaRPr lang="en-US" sz="2200" dirty="0"/>
-          </a:p>
-        </p:txBody>
-      </p:sp>
-      <p:sp>
-        <p:nvSpPr>
-          <p:cNvPr id="23" name="Text 21"/>
-          <p:cNvSpPr txBox="1"/>
-          <p:nvPr/>
-        </p:nvSpPr>
-        <p:spPr>
-          <a:xfrm>
-            <a:off x="777240" y="5212080"/>
-            <a:ext cx="10652760" cy="731520"/>
-          </a:xfrm>
-          <a:prstGeom prst="rect">
-            <a:avLst/>
-          </a:prstGeom>
-          <a:noFill/>
-          <a:ln/>
-        </p:spPr>
-        <p:txBody>
-          <a:bodyPr wrap="square" lIns="0" tIns="0" rIns="0" bIns="0" rtlCol="0" anchor="ctr"/>
-          <a:lstStyle/>
-          <a:p>
-            <a:pPr indent="0" marL="0">
-              <a:buNone/>
-            </a:pPr>
-            <a:r>
-              <a:rPr lang="en-US" sz="1600" dirty="0">
-                <a:solidFill>
-                  <a:schemeClr val="accent6"/>
-                </a:solidFill>
-              </a:rPr>
-              <a:t>Hide the Expo tools button. If voice is slow, keep going.</a:t>
-            </a:r>
-            <a:endParaRPr lang="en-US" sz="1600" dirty="0"/>
+              <a:t>4  Capture the landmark. Hide Expo tools.</a:t>
+            </a:r>
+            <a:endParaRPr lang="en-US" sz="1400" dirty="0"/>
           </a:p>
         </p:txBody>
       </p:sp>
@@ -4004,8 +3808,8 @@
         </p:nvSpPr>
         <p:spPr>
           <a:xfrm>
-            <a:off x="548640" y="256032"/>
-            <a:ext cx="11064240" cy="658368"/>
+            <a:off x="457200" y="201168"/>
+            <a:ext cx="11247120" cy="566928"/>
           </a:xfrm>
           <a:prstGeom prst="rect">
             <a:avLst/>
@@ -4021,31 +3825,31 @@
               <a:buNone/>
             </a:pPr>
             <a:r>
-              <a:rPr lang="en-US" sz="3600" b="1" dirty="0">
+              <a:rPr lang="en-US" sz="3000" b="1" dirty="0">
                 <a:solidFill>
                   <a:schemeClr val="tx1"/>
                 </a:solidFill>
               </a:rPr>
               <a:t>A phone, a small API, the real world</a:t>
             </a:r>
-            <a:endParaRPr lang="en-US" sz="3600" dirty="0"/>
-          </a:p>
-        </p:txBody>
-      </p:sp>
-      <p:sp>
-        <p:nvSpPr>
-          <p:cNvPr id="3" name="arch-Phone"/>
+            <a:endParaRPr lang="en-US" sz="3000" dirty="0"/>
+          </a:p>
+        </p:txBody>
+      </p:sp>
+      <p:sp>
+        <p:nvSpPr>
+          <p:cNvPr id="3" name="arch-0"/>
           <p:cNvSpPr/>
           <p:nvPr/>
         </p:nvSpPr>
         <p:spPr>
           <a:xfrm>
-            <a:off x="640080" y="1371600"/>
-            <a:ext cx="3246120" cy="2468880"/>
+            <a:off x="502920" y="1097280"/>
+            <a:ext cx="3383280" cy="2240280"/>
           </a:xfrm>
           <a:prstGeom prst="roundRect">
             <a:avLst>
-              <a:gd name="adj" fmla="val 5926"/>
+              <a:gd name="adj" fmla="val 5714"/>
             </a:avLst>
           </a:prstGeom>
           <a:solidFill>
@@ -4055,7 +3859,7 @@
           <a:effectLst>
             <a:outerShdw sx="100000" sy="100000" kx="0" ky="0" algn="bl" rotWithShape="0" blurRad="101600" dist="25400" dir="5400000">
               <a:srgbClr val="0B1F3A">
-                <a:alpha val="8000"/>
+                <a:alpha val="10000"/>
               </a:srgbClr>
             </a:outerShdw>
           </a:effectLst>
@@ -4069,8 +3873,8 @@
         </p:nvSpPr>
         <p:spPr>
           <a:xfrm>
-            <a:off x="822960" y="1600200"/>
-            <a:ext cx="2880360" cy="548640"/>
+            <a:off x="704088" y="1280160"/>
+            <a:ext cx="2971800" cy="457200"/>
           </a:xfrm>
           <a:prstGeom prst="rect">
             <a:avLst/>
@@ -4086,14 +3890,14 @@
               <a:buNone/>
             </a:pPr>
             <a:r>
-              <a:rPr lang="en-US" sz="2600" b="1" dirty="0">
+              <a:rPr lang="en-US" sz="2400" b="1" dirty="0">
                 <a:solidFill>
                   <a:schemeClr val="tx1"/>
                 </a:solidFill>
               </a:rPr>
               <a:t>Phone</a:t>
             </a:r>
-            <a:endParaRPr lang="en-US" sz="2600" dirty="0"/>
+            <a:endParaRPr lang="en-US" sz="2400" dirty="0"/>
           </a:p>
         </p:txBody>
       </p:sp>
@@ -4105,8 +3909,8 @@
         </p:nvSpPr>
         <p:spPr>
           <a:xfrm>
-            <a:off x="822960" y="2286000"/>
-            <a:ext cx="2880360" cy="1234440"/>
+            <a:off x="704088" y="1874520"/>
+            <a:ext cx="2971800" cy="1188720"/>
           </a:xfrm>
           <a:prstGeom prst="rect">
             <a:avLst/>
@@ -4149,14 +3953,14 @@
       </p:sp>
       <p:sp>
         <p:nvSpPr>
-          <p:cNvPr id="6" name="arrow-0"/>
-          <p:cNvSpPr txBox="1"/>
-          <p:nvPr/>
-        </p:nvSpPr>
-        <p:spPr>
-          <a:xfrm>
-            <a:off x="3840480" y="2194560"/>
-            <a:ext cx="685800" cy="640080"/>
+          <p:cNvPr id="6" name="Text 4"/>
+          <p:cNvSpPr txBox="1"/>
+          <p:nvPr/>
+        </p:nvSpPr>
+        <p:spPr>
+          <a:xfrm>
+            <a:off x="3749040" y="1920240"/>
+            <a:ext cx="640080" cy="502920"/>
           </a:xfrm>
           <a:prstGeom prst="rect">
             <a:avLst/>
@@ -4172,41 +3976,41 @@
               <a:buNone/>
             </a:pPr>
             <a:r>
-              <a:rPr lang="en-US" sz="3200" b="1" dirty="0">
+              <a:rPr lang="en-US" sz="2800" b="1" dirty="0">
                 <a:solidFill>
                   <a:schemeClr val="accent1"/>
                 </a:solidFill>
               </a:rPr>
               <a:t>→</a:t>
             </a:r>
-            <a:endParaRPr lang="en-US" sz="3200" dirty="0"/>
-          </a:p>
-        </p:txBody>
-      </p:sp>
-      <p:sp>
-        <p:nvSpPr>
-          <p:cNvPr id="7" name="arch-API"/>
+            <a:endParaRPr lang="en-US" sz="2800" dirty="0"/>
+          </a:p>
+        </p:txBody>
+      </p:sp>
+      <p:sp>
+        <p:nvSpPr>
+          <p:cNvPr id="7" name="arch-1"/>
           <p:cNvSpPr/>
           <p:nvPr/>
         </p:nvSpPr>
         <p:spPr>
           <a:xfrm>
-            <a:off x="4480560" y="1371600"/>
-            <a:ext cx="3246120" cy="2468880"/>
+            <a:off x="4389120" y="1097280"/>
+            <a:ext cx="3383280" cy="2240280"/>
           </a:xfrm>
           <a:prstGeom prst="roundRect">
             <a:avLst>
-              <a:gd name="adj" fmla="val 5926"/>
+              <a:gd name="adj" fmla="val 5714"/>
             </a:avLst>
           </a:prstGeom>
           <a:solidFill>
-            <a:schemeClr val="tx2"/>
+            <a:srgbClr val="0B1F3A"/>
           </a:solidFill>
           <a:ln/>
           <a:effectLst>
             <a:outerShdw sx="100000" sy="100000" kx="0" ky="0" algn="bl" rotWithShape="0" blurRad="101600" dist="25400" dir="5400000">
               <a:srgbClr val="0B1F3A">
-                <a:alpha val="8000"/>
+                <a:alpha val="10000"/>
               </a:srgbClr>
             </a:outerShdw>
           </a:effectLst>
@@ -4220,8 +4024,8 @@
         </p:nvSpPr>
         <p:spPr>
           <a:xfrm>
-            <a:off x="4663440" y="1600200"/>
-            <a:ext cx="2880360" cy="548640"/>
+            <a:off x="4590288" y="1280160"/>
+            <a:ext cx="2971800" cy="457200"/>
           </a:xfrm>
           <a:prstGeom prst="rect">
             <a:avLst/>
@@ -4237,14 +4041,14 @@
               <a:buNone/>
             </a:pPr>
             <a:r>
-              <a:rPr lang="en-US" sz="2600" b="1" dirty="0">
+              <a:rPr lang="en-US" sz="2400" b="1" dirty="0">
                 <a:solidFill>
                   <a:schemeClr val="accent3"/>
                 </a:solidFill>
               </a:rPr>
               <a:t>API</a:t>
             </a:r>
-            <a:endParaRPr lang="en-US" sz="2600" dirty="0"/>
+            <a:endParaRPr lang="en-US" sz="2400" dirty="0"/>
           </a:p>
         </p:txBody>
       </p:sp>
@@ -4256,8 +4060,8 @@
         </p:nvSpPr>
         <p:spPr>
           <a:xfrm>
-            <a:off x="4663440" y="2286000"/>
-            <a:ext cx="2880360" cy="1234440"/>
+            <a:off x="4590288" y="1874520"/>
+            <a:ext cx="2971800" cy="1188720"/>
           </a:xfrm>
           <a:prstGeom prst="rect">
             <a:avLst/>
@@ -4300,14 +4104,14 @@
       </p:sp>
       <p:sp>
         <p:nvSpPr>
-          <p:cNvPr id="10" name="arrow-1"/>
-          <p:cNvSpPr txBox="1"/>
-          <p:nvPr/>
-        </p:nvSpPr>
-        <p:spPr>
-          <a:xfrm>
-            <a:off x="7680960" y="2194560"/>
-            <a:ext cx="685800" cy="640080"/>
+          <p:cNvPr id="10" name="Text 8"/>
+          <p:cNvSpPr txBox="1"/>
+          <p:nvPr/>
+        </p:nvSpPr>
+        <p:spPr>
+          <a:xfrm>
+            <a:off x="7635240" y="1920240"/>
+            <a:ext cx="640080" cy="502920"/>
           </a:xfrm>
           <a:prstGeom prst="rect">
             <a:avLst/>
@@ -4323,31 +4127,31 @@
               <a:buNone/>
             </a:pPr>
             <a:r>
-              <a:rPr lang="en-US" sz="3200" b="1" dirty="0">
+              <a:rPr lang="en-US" sz="2800" b="1" dirty="0">
                 <a:solidFill>
                   <a:schemeClr val="accent1"/>
                 </a:solidFill>
               </a:rPr>
               <a:t>→</a:t>
             </a:r>
-            <a:endParaRPr lang="en-US" sz="3200" dirty="0"/>
-          </a:p>
-        </p:txBody>
-      </p:sp>
-      <p:sp>
-        <p:nvSpPr>
-          <p:cNvPr id="11" name="arch-World"/>
+            <a:endParaRPr lang="en-US" sz="2800" dirty="0"/>
+          </a:p>
+        </p:txBody>
+      </p:sp>
+      <p:sp>
+        <p:nvSpPr>
+          <p:cNvPr id="11" name="arch-2"/>
           <p:cNvSpPr/>
           <p:nvPr/>
         </p:nvSpPr>
         <p:spPr>
           <a:xfrm>
-            <a:off x="8321040" y="1371600"/>
-            <a:ext cx="3246120" cy="2468880"/>
+            <a:off x="8275320" y="1097280"/>
+            <a:ext cx="3383280" cy="2240280"/>
           </a:xfrm>
           <a:prstGeom prst="roundRect">
             <a:avLst>
-              <a:gd name="adj" fmla="val 5926"/>
+              <a:gd name="adj" fmla="val 5714"/>
             </a:avLst>
           </a:prstGeom>
           <a:solidFill>
@@ -4357,7 +4161,7 @@
           <a:effectLst>
             <a:outerShdw sx="100000" sy="100000" kx="0" ky="0" algn="bl" rotWithShape="0" blurRad="101600" dist="25400" dir="5400000">
               <a:srgbClr val="0B1F3A">
-                <a:alpha val="8000"/>
+                <a:alpha val="10000"/>
               </a:srgbClr>
             </a:outerShdw>
           </a:effectLst>
@@ -4371,8 +4175,8 @@
         </p:nvSpPr>
         <p:spPr>
           <a:xfrm>
-            <a:off x="8503920" y="1600200"/>
-            <a:ext cx="2880360" cy="548640"/>
+            <a:off x="8476488" y="1280160"/>
+            <a:ext cx="2971800" cy="457200"/>
           </a:xfrm>
           <a:prstGeom prst="rect">
             <a:avLst/>
@@ -4388,14 +4192,14 @@
               <a:buNone/>
             </a:pPr>
             <a:r>
-              <a:rPr lang="en-US" sz="2600" b="1" dirty="0">
+              <a:rPr lang="en-US" sz="2400" b="1" dirty="0">
                 <a:solidFill>
                   <a:schemeClr val="tx1"/>
                 </a:solidFill>
               </a:rPr>
               <a:t>World</a:t>
             </a:r>
-            <a:endParaRPr lang="en-US" sz="2600" dirty="0"/>
+            <a:endParaRPr lang="en-US" sz="2400" dirty="0"/>
           </a:p>
         </p:txBody>
       </p:sp>
@@ -4407,8 +4211,8 @@
         </p:nvSpPr>
         <p:spPr>
           <a:xfrm>
-            <a:off x="8503920" y="2286000"/>
-            <a:ext cx="2880360" cy="1234440"/>
+            <a:off x="8476488" y="1874520"/>
+            <a:ext cx="2971800" cy="1188720"/>
           </a:xfrm>
           <a:prstGeom prst="rect">
             <a:avLst/>
@@ -4451,14 +4255,14 @@
       </p:sp>
       <p:sp>
         <p:nvSpPr>
-          <p:cNvPr id="14" name="fact-dot-0"/>
+          <p:cNvPr id="14" name="f-0"/>
           <p:cNvSpPr/>
           <p:nvPr/>
         </p:nvSpPr>
         <p:spPr>
           <a:xfrm>
-            <a:off x="685800" y="4270248"/>
-            <a:ext cx="256032" cy="256032"/>
+            <a:off x="594360" y="3822192"/>
+            <a:ext cx="292608" cy="292608"/>
           </a:xfrm>
           <a:prstGeom prst="ellipse">
             <a:avLst/>
@@ -4477,8 +4281,8 @@
         </p:nvSpPr>
         <p:spPr>
           <a:xfrm>
-            <a:off x="1097280" y="4160520"/>
-            <a:ext cx="10424160" cy="502920"/>
+            <a:off x="1051560" y="3657600"/>
+            <a:ext cx="10515600" cy="640080"/>
           </a:xfrm>
           <a:prstGeom prst="rect">
             <a:avLst/>
@@ -4507,14 +4311,14 @@
       </p:sp>
       <p:sp>
         <p:nvSpPr>
-          <p:cNvPr id="16" name="fact-dot-1"/>
+          <p:cNvPr id="16" name="f-1"/>
           <p:cNvSpPr/>
           <p:nvPr/>
         </p:nvSpPr>
         <p:spPr>
           <a:xfrm>
-            <a:off x="685800" y="4910328"/>
-            <a:ext cx="256032" cy="256032"/>
+            <a:off x="594360" y="4599432"/>
+            <a:ext cx="292608" cy="292608"/>
           </a:xfrm>
           <a:prstGeom prst="ellipse">
             <a:avLst/>
@@ -4533,8 +4337,8 @@
         </p:nvSpPr>
         <p:spPr>
           <a:xfrm>
-            <a:off x="1097280" y="4800600"/>
-            <a:ext cx="10424160" cy="502920"/>
+            <a:off x="1051560" y="4434840"/>
+            <a:ext cx="10515600" cy="640080"/>
           </a:xfrm>
           <a:prstGeom prst="rect">
             <a:avLst/>
@@ -4563,14 +4367,14 @@
       </p:sp>
       <p:sp>
         <p:nvSpPr>
-          <p:cNvPr id="18" name="fact-dot-2"/>
+          <p:cNvPr id="18" name="f-2"/>
           <p:cNvSpPr/>
           <p:nvPr/>
         </p:nvSpPr>
         <p:spPr>
           <a:xfrm>
-            <a:off x="685800" y="5550408"/>
-            <a:ext cx="256032" cy="256032"/>
+            <a:off x="594360" y="5376672"/>
+            <a:ext cx="292608" cy="292608"/>
           </a:xfrm>
           <a:prstGeom prst="ellipse">
             <a:avLst/>
@@ -4589,8 +4393,8 @@
         </p:nvSpPr>
         <p:spPr>
           <a:xfrm>
-            <a:off x="1097280" y="5440680"/>
-            <a:ext cx="10424160" cy="502920"/>
+            <a:off x="1051560" y="5212080"/>
+            <a:ext cx="10515600" cy="640080"/>
           </a:xfrm>
           <a:prstGeom prst="rect">
             <a:avLst/>
@@ -4652,8 +4456,8 @@
         </p:nvSpPr>
         <p:spPr>
           <a:xfrm>
-            <a:off x="548640" y="256032"/>
-            <a:ext cx="11064240" cy="658368"/>
+            <a:off x="457200" y="201168"/>
+            <a:ext cx="11247120" cy="566928"/>
           </a:xfrm>
           <a:prstGeom prst="rect">
             <a:avLst/>
@@ -4669,49 +4473,20 @@
               <a:buNone/>
             </a:pPr>
             <a:r>
-              <a:rPr lang="en-US" sz="3600" b="1" dirty="0">
+              <a:rPr lang="en-US" sz="3000" b="1" dirty="0">
                 <a:solidFill>
                   <a:schemeClr val="tx1"/>
                 </a:solidFill>
               </a:rPr>
-              <a:t>Walking becomes play</a:t>
-            </a:r>
-            <a:endParaRPr lang="en-US" sz="3600" dirty="0"/>
-          </a:p>
-        </p:txBody>
-      </p:sp>
-      <p:sp>
-        <p:nvSpPr>
-          <p:cNvPr id="3" name="special-0"/>
-          <p:cNvSpPr/>
-          <p:nvPr/>
-        </p:nvSpPr>
-        <p:spPr>
-          <a:xfrm>
-            <a:off x="502920" y="1097280"/>
-            <a:ext cx="3657600" cy="3794760"/>
-          </a:xfrm>
-          <a:prstGeom prst="roundRect">
-            <a:avLst>
-              <a:gd name="adj" fmla="val 4000"/>
-            </a:avLst>
-          </a:prstGeom>
-          <a:solidFill>
-            <a:srgbClr val="FFFFFF"/>
-          </a:solidFill>
-          <a:ln/>
-          <a:effectLst>
-            <a:outerShdw sx="100000" sy="100000" kx="0" ky="0" algn="bl" rotWithShape="0" blurRad="101600" dist="25400" dir="5400000">
-              <a:srgbClr val="0B1F3A">
-                <a:alpha val="8000"/>
-              </a:srgbClr>
-            </a:outerShdw>
-          </a:effectLst>
-        </p:spPr>
+              <a:t>Walking earns creatures and landmarks</a:t>
+            </a:r>
+            <a:endParaRPr lang="en-US" sz="3000" dirty="0"/>
+          </a:p>
+        </p:txBody>
       </p:sp>
       <p:pic>
         <p:nvPicPr>
-          <p:cNvPr id="4" name="special-art-0" descr="G:\broswer download\big-red-hacks2026\mobile\assets\splash-icon.png">    </p:cNvPr>
+          <p:cNvPr id="3" name="egg" descr="G:\broswer download\big-red-hacks2026\docs\presentation\app_images\C2EA70B0-0CD6-4D92-AAFE-8EC1C33A2133.jpg">    </p:cNvPr>
           <p:cNvPicPr>
             <a:picLocks noChangeAspect="1"/>
           </p:cNvPicPr>
@@ -4725,118 +4500,17 @@
         </p:blipFill>
         <p:spPr>
           <a:xfrm>
-            <a:off x="1600200" y="1280160"/>
-            <a:ext cx="1417320" cy="1417320"/>
+            <a:off x="411480" y="960120"/>
+            <a:ext cx="3246120" cy="2877365"/>
           </a:xfrm>
           <a:prstGeom prst="rect">
             <a:avLst/>
           </a:prstGeom>
         </p:spPr>
       </p:pic>
-      <p:sp>
-        <p:nvSpPr>
-          <p:cNvPr id="5" name="Text 2"/>
-          <p:cNvSpPr txBox="1"/>
-          <p:nvPr/>
-        </p:nvSpPr>
-        <p:spPr>
-          <a:xfrm>
-            <a:off x="704088" y="2834640"/>
-            <a:ext cx="3246120" cy="640080"/>
-          </a:xfrm>
-          <a:prstGeom prst="rect">
-            <a:avLst/>
-          </a:prstGeom>
-          <a:noFill/>
-          <a:ln/>
-        </p:spPr>
-        <p:txBody>
-          <a:bodyPr wrap="square" lIns="0" tIns="0" rIns="0" bIns="0" rtlCol="0" anchor="ctr"/>
-          <a:lstStyle/>
-          <a:p>
-            <a:pPr indent="0" marL="0">
-              <a:buNone/>
-            </a:pPr>
-            <a:r>
-              <a:rPr lang="en-US" sz="2000" b="1" dirty="0">
-                <a:solidFill>
-                  <a:schemeClr val="tx1"/>
-                </a:solidFill>
-              </a:rPr>
-              <a:t>The map is a trail</a:t>
-            </a:r>
-            <a:endParaRPr lang="en-US" sz="2000" dirty="0"/>
-          </a:p>
-        </p:txBody>
-      </p:sp>
-      <p:sp>
-        <p:nvSpPr>
-          <p:cNvPr id="6" name="Text 3"/>
-          <p:cNvSpPr txBox="1"/>
-          <p:nvPr/>
-        </p:nvSpPr>
-        <p:spPr>
-          <a:xfrm>
-            <a:off x="704088" y="3520440"/>
-            <a:ext cx="3246120" cy="1097280"/>
-          </a:xfrm>
-          <a:prstGeom prst="rect">
-            <a:avLst/>
-          </a:prstGeom>
-          <a:noFill/>
-          <a:ln/>
-        </p:spPr>
-        <p:txBody>
-          <a:bodyPr wrap="square" lIns="0" tIns="0" rIns="0" bIns="0" rtlCol="0" anchor="ctr"/>
-          <a:lstStyle/>
-          <a:p>
-            <a:pPr indent="0" marL="0">
-              <a:buNone/>
-            </a:pPr>
-            <a:r>
-              <a:rPr lang="en-US" sz="1600" dirty="0">
-                <a:solidFill>
-                  <a:schemeClr val="accent6"/>
-                </a:solidFill>
-              </a:rPr>
-              <a:t>A blooming path and a squad, not only a blue line.</a:t>
-            </a:r>
-            <a:endParaRPr lang="en-US" sz="1600" dirty="0"/>
-          </a:p>
-        </p:txBody>
-      </p:sp>
-      <p:sp>
-        <p:nvSpPr>
-          <p:cNvPr id="7" name="special-1"/>
-          <p:cNvSpPr/>
-          <p:nvPr/>
-        </p:nvSpPr>
-        <p:spPr>
-          <a:xfrm>
-            <a:off x="4343400" y="1097280"/>
-            <a:ext cx="3657600" cy="3794760"/>
-          </a:xfrm>
-          <a:prstGeom prst="roundRect">
-            <a:avLst>
-              <a:gd name="adj" fmla="val 4000"/>
-            </a:avLst>
-          </a:prstGeom>
-          <a:solidFill>
-            <a:srgbClr val="FFFFFF"/>
-          </a:solidFill>
-          <a:ln/>
-          <a:effectLst>
-            <a:outerShdw sx="100000" sy="100000" kx="0" ky="0" algn="bl" rotWithShape="0" blurRad="101600" dist="25400" dir="5400000">
-              <a:srgbClr val="0B1F3A">
-                <a:alpha val="8000"/>
-              </a:srgbClr>
-            </a:outerShdw>
-          </a:effectLst>
-        </p:spPr>
-      </p:sp>
       <p:pic>
         <p:nvPicPr>
-          <p:cNvPr id="8" name="special-art-1" descr="G:\broswer download\big-red-hacks2026\mobile\assets\badges\gold.png">    </p:cNvPr>
+          <p:cNvPr id="4" name="mochi" descr="G:\broswer download\big-red-hacks2026\docs\presentation\app_images\0B82DD1F-6522-46CD-8774-F7C4336505D4.jpg">    </p:cNvPr>
           <p:cNvPicPr>
             <a:picLocks noChangeAspect="1"/>
           </p:cNvPicPr>
@@ -4850,8 +4524,8 @@
         </p:blipFill>
         <p:spPr>
           <a:xfrm>
-            <a:off x="5440680" y="1280160"/>
-            <a:ext cx="1417320" cy="1417320"/>
+            <a:off x="3794760" y="960120"/>
+            <a:ext cx="3063240" cy="3807460"/>
           </a:xfrm>
           <a:prstGeom prst="rect">
             <a:avLst/>
@@ -4860,108 +4534,29 @@
       </p:pic>
       <p:sp>
         <p:nvSpPr>
-          <p:cNvPr id="9" name="Text 5"/>
-          <p:cNvSpPr txBox="1"/>
-          <p:nvPr/>
-        </p:nvSpPr>
-        <p:spPr>
-          <a:xfrm>
-            <a:off x="4544568" y="2834640"/>
-            <a:ext cx="3246120" cy="640080"/>
-          </a:xfrm>
-          <a:prstGeom prst="rect">
-            <a:avLst/>
-          </a:prstGeom>
-          <a:noFill/>
-          <a:ln/>
-        </p:spPr>
-        <p:txBody>
-          <a:bodyPr wrap="square" lIns="0" tIns="0" rIns="0" bIns="0" rtlCol="0" anchor="ctr"/>
-          <a:lstStyle/>
-          <a:p>
-            <a:pPr indent="0" marL="0">
-              <a:buNone/>
-            </a:pPr>
-            <a:r>
-              <a:rPr lang="en-US" sz="2000" b="1" dirty="0">
-                <a:solidFill>
-                  <a:schemeClr val="tx1"/>
-                </a:solidFill>
-              </a:rPr>
-              <a:t>Steps earn creatures</a:t>
-            </a:r>
-            <a:endParaRPr lang="en-US" sz="2000" dirty="0"/>
-          </a:p>
-        </p:txBody>
-      </p:sp>
-      <p:sp>
-        <p:nvSpPr>
-          <p:cNvPr id="10" name="Text 6"/>
-          <p:cNvSpPr txBox="1"/>
-          <p:nvPr/>
-        </p:nvSpPr>
-        <p:spPr>
-          <a:xfrm>
-            <a:off x="4544568" y="3520440"/>
-            <a:ext cx="3246120" cy="1097280"/>
-          </a:xfrm>
-          <a:prstGeom prst="rect">
-            <a:avLst/>
-          </a:prstGeom>
-          <a:noFill/>
-          <a:ln/>
-        </p:spPr>
-        <p:txBody>
-          <a:bodyPr wrap="square" lIns="0" tIns="0" rIns="0" bIns="0" rtlCol="0" anchor="ctr"/>
-          <a:lstStyle/>
-          <a:p>
-            <a:pPr indent="0" marL="0">
-              <a:buNone/>
-            </a:pPr>
-            <a:r>
-              <a:rPr lang="en-US" sz="1600" dirty="0">
-                <a:solidFill>
-                  <a:schemeClr val="accent6"/>
-                </a:solidFill>
-              </a:rPr>
-              <a:t>Eggs, ranks, and captures — completable in Demo Walk.</a:t>
-            </a:r>
-            <a:endParaRPr lang="en-US" sz="1600" dirty="0"/>
-          </a:p>
-        </p:txBody>
-      </p:sp>
-      <p:sp>
-        <p:nvSpPr>
-          <p:cNvPr id="11" name="special-2"/>
+          <p:cNvPr id="5" name="captured-frame"/>
           <p:cNvSpPr/>
           <p:nvPr/>
         </p:nvSpPr>
         <p:spPr>
           <a:xfrm>
-            <a:off x="8183880" y="1097280"/>
-            <a:ext cx="3657600" cy="3794760"/>
+            <a:off x="6967728" y="886968"/>
+            <a:ext cx="2420049" cy="4352544"/>
           </a:xfrm>
           <a:prstGeom prst="roundRect">
             <a:avLst>
-              <a:gd name="adj" fmla="val 4000"/>
+              <a:gd name="adj" fmla="val 6801"/>
             </a:avLst>
           </a:prstGeom>
           <a:solidFill>
-            <a:srgbClr val="FFFFFF"/>
-          </a:solidFill>
-          <a:ln/>
-          <a:effectLst>
-            <a:outerShdw sx="100000" sy="100000" kx="0" ky="0" algn="bl" rotWithShape="0" blurRad="101600" dist="25400" dir="5400000">
-              <a:srgbClr val="0B1F3A">
-                <a:alpha val="8000"/>
-              </a:srgbClr>
-            </a:outerShdw>
-          </a:effectLst>
+            <a:srgbClr val="0B1F3A"/>
+          </a:solidFill>
+          <a:ln/>
         </p:spPr>
       </p:sp>
       <p:pic>
         <p:nvPicPr>
-          <p:cNvPr id="12" name="special-art-2" descr="G:\broswer download\big-red-hacks2026\docs\presentation\assets\scout.png">    </p:cNvPr>
+          <p:cNvPr id="6" name="captured" descr="G:\broswer download\big-red-hacks2026\docs\presentation\app_images\D8BE4252-56A8-4B93-B944-9D82B404BB87.jpg">    </p:cNvPr>
           <p:cNvPicPr>
             <a:picLocks noChangeAspect="1"/>
           </p:cNvPicPr>
@@ -4975,8 +4570,8 @@
         </p:blipFill>
         <p:spPr>
           <a:xfrm>
-            <a:off x="9281160" y="1280160"/>
-            <a:ext cx="1417320" cy="1417320"/>
+            <a:off x="7040880" y="960120"/>
+            <a:ext cx="2273745" cy="4206240"/>
           </a:xfrm>
           <a:prstGeom prst="rect">
             <a:avLst/>
@@ -4985,100 +4580,28 @@
       </p:pic>
       <p:sp>
         <p:nvSpPr>
-          <p:cNvPr id="13" name="Text 8"/>
-          <p:cNvSpPr txBox="1"/>
-          <p:nvPr/>
-        </p:nvSpPr>
-        <p:spPr>
-          <a:xfrm>
-            <a:off x="8385048" y="2834640"/>
-            <a:ext cx="3246120" cy="640080"/>
-          </a:xfrm>
-          <a:prstGeom prst="rect">
-            <a:avLst/>
-          </a:prstGeom>
-          <a:noFill/>
-          <a:ln/>
-        </p:spPr>
-        <p:txBody>
-          <a:bodyPr wrap="square" lIns="0" tIns="0" rIns="0" bIns="0" rtlCol="0" anchor="ctr"/>
-          <a:lstStyle/>
-          <a:p>
-            <a:pPr indent="0" marL="0">
-              <a:buNone/>
-            </a:pPr>
-            <a:r>
-              <a:rPr lang="en-US" sz="2000" b="1" dirty="0">
-                <a:solidFill>
-                  <a:schemeClr val="tx1"/>
-                </a:solidFill>
-              </a:rPr>
-              <a:t>It continues in iMessage</a:t>
-            </a:r>
-            <a:endParaRPr lang="en-US" sz="2000" dirty="0"/>
-          </a:p>
-        </p:txBody>
-      </p:sp>
-      <p:sp>
-        <p:nvSpPr>
-          <p:cNvPr id="14" name="Text 9"/>
-          <p:cNvSpPr txBox="1"/>
-          <p:nvPr/>
-        </p:nvSpPr>
-        <p:spPr>
-          <a:xfrm>
-            <a:off x="8385048" y="3520440"/>
-            <a:ext cx="3246120" cy="1097280"/>
-          </a:xfrm>
-          <a:prstGeom prst="rect">
-            <a:avLst/>
-          </a:prstGeom>
-          <a:noFill/>
-          <a:ln/>
-        </p:spPr>
-        <p:txBody>
-          <a:bodyPr wrap="square" lIns="0" tIns="0" rIns="0" bIns="0" rtlCol="0" anchor="ctr"/>
-          <a:lstStyle/>
-          <a:p>
-            <a:pPr indent="0" marL="0">
-              <a:buNone/>
-            </a:pPr>
-            <a:r>
-              <a:rPr lang="en-US" sz="1600" dirty="0">
-                <a:solidFill>
-                  <a:schemeClr val="accent6"/>
-                </a:solidFill>
-              </a:rPr>
-              <a:t>Same squad over Photon. Terminal today; iMessage with keys.</a:t>
-            </a:r>
-            <a:endParaRPr lang="en-US" sz="1600" dirty="0"/>
-          </a:p>
-        </p:txBody>
-      </p:sp>
-      <p:sp>
-        <p:nvSpPr>
-          <p:cNvPr id="15" name="working"/>
+          <p:cNvPr id="7" name="egg-c"/>
           <p:cNvSpPr/>
           <p:nvPr/>
         </p:nvSpPr>
         <p:spPr>
           <a:xfrm>
-            <a:off x="502920" y="5074920"/>
-            <a:ext cx="5532120" cy="1188720"/>
+            <a:off x="411480" y="3947213"/>
+            <a:ext cx="3246120" cy="1051560"/>
           </a:xfrm>
           <a:prstGeom prst="roundRect">
             <a:avLst>
-              <a:gd name="adj" fmla="val 12308"/>
+              <a:gd name="adj" fmla="val 12174"/>
             </a:avLst>
           </a:prstGeom>
           <a:solidFill>
-            <a:schemeClr val="bg2"/>
+            <a:srgbClr val="FFFFFF"/>
           </a:solidFill>
           <a:ln/>
           <a:effectLst>
             <a:outerShdw sx="100000" sy="100000" kx="0" ky="0" algn="bl" rotWithShape="0" blurRad="101600" dist="25400" dir="5400000">
               <a:srgbClr val="0B1F3A">
-                <a:alpha val="8000"/>
+                <a:alpha val="10000"/>
               </a:srgbClr>
             </a:outerShdw>
           </a:effectLst>
@@ -5086,14 +4609,14 @@
       </p:sp>
       <p:sp>
         <p:nvSpPr>
-          <p:cNvPr id="16" name="Text 11"/>
-          <p:cNvSpPr txBox="1"/>
-          <p:nvPr/>
-        </p:nvSpPr>
-        <p:spPr>
-          <a:xfrm>
-            <a:off x="685800" y="5257800"/>
-            <a:ext cx="5166360" cy="822960"/>
+          <p:cNvPr id="8" name="Text 3"/>
+          <p:cNvSpPr txBox="1"/>
+          <p:nvPr/>
+        </p:nvSpPr>
+        <p:spPr>
+          <a:xfrm>
+            <a:off x="539496" y="4020365"/>
+            <a:ext cx="2990088" cy="905256"/>
           </a:xfrm>
           <a:prstGeom prst="rect">
             <a:avLst/>
@@ -5109,41 +4632,41 @@
               <a:buNone/>
             </a:pPr>
             <a:r>
-              <a:rPr lang="en-US" sz="1600" dirty="0">
+              <a:rPr lang="en-US" sz="1400" dirty="0">
                 <a:solidFill>
                   <a:schemeClr val="tx1"/>
                 </a:solidFill>
               </a:rPr>
-              <a:t>Working  ·  ISS overhead can boost rare hatches.</a:t>
-            </a:r>
-            <a:endParaRPr lang="en-US" sz="1600" dirty="0"/>
-          </a:p>
-        </p:txBody>
-      </p:sp>
-      <p:sp>
-        <p:nvSpPr>
-          <p:cNvPr id="17" name="later"/>
+              <a:t>An egg fills as you walk. Demo walks on.</a:t>
+            </a:r>
+            <a:endParaRPr lang="en-US" sz="1400" dirty="0"/>
+          </a:p>
+        </p:txBody>
+      </p:sp>
+      <p:sp>
+        <p:nvSpPr>
+          <p:cNvPr id="9" name="mochi-c"/>
           <p:cNvSpPr/>
           <p:nvPr/>
         </p:nvSpPr>
         <p:spPr>
           <a:xfrm>
-            <a:off x="6217920" y="5074920"/>
-            <a:ext cx="5440680" cy="1188720"/>
+            <a:off x="3794760" y="4877308"/>
+            <a:ext cx="3063240" cy="1051560"/>
           </a:xfrm>
           <a:prstGeom prst="roundRect">
             <a:avLst>
-              <a:gd name="adj" fmla="val 12308"/>
+              <a:gd name="adj" fmla="val 12174"/>
             </a:avLst>
           </a:prstGeom>
           <a:solidFill>
-            <a:srgbClr val="E8F5FF"/>
+            <a:srgbClr val="FFFFFF"/>
           </a:solidFill>
           <a:ln/>
           <a:effectLst>
             <a:outerShdw sx="100000" sy="100000" kx="0" ky="0" algn="bl" rotWithShape="0" blurRad="101600" dist="25400" dir="5400000">
               <a:srgbClr val="0B1F3A">
-                <a:alpha val="8000"/>
+                <a:alpha val="10000"/>
               </a:srgbClr>
             </a:outerShdw>
           </a:effectLst>
@@ -5151,14 +4674,14 @@
       </p:sp>
       <p:sp>
         <p:nvSpPr>
-          <p:cNvPr id="18" name="Text 13"/>
-          <p:cNvSpPr txBox="1"/>
-          <p:nvPr/>
-        </p:nvSpPr>
-        <p:spPr>
-          <a:xfrm>
-            <a:off x="6400800" y="5257800"/>
-            <a:ext cx="5074920" cy="822960"/>
+          <p:cNvPr id="10" name="Text 5"/>
+          <p:cNvSpPr txBox="1"/>
+          <p:nvPr/>
+        </p:nvSpPr>
+        <p:spPr>
+          <a:xfrm>
+            <a:off x="3922776" y="4950460"/>
+            <a:ext cx="2807208" cy="905256"/>
           </a:xfrm>
           <a:prstGeom prst="rect">
             <a:avLst/>
@@ -5174,14 +4697,79 @@
               <a:buNone/>
             </a:pPr>
             <a:r>
-              <a:rPr lang="en-US" sz="1600" dirty="0">
-                <a:solidFill>
-                  <a:schemeClr val="accent6"/>
-                </a:solidFill>
-              </a:rPr>
-              <a:t>Later  ·  live Grok without a key, cloud deploy, background tracking.</a:t>
-            </a:r>
-            <a:endParaRPr lang="en-US" sz="1600" dirty="0"/>
+              <a:rPr lang="en-US" sz="1400" dirty="0">
+                <a:solidFill>
+                  <a:schemeClr val="tx1"/>
+                </a:solidFill>
+              </a:rPr>
+              <a:t>Meet Mochi — a rare Storyteller from a hatch.</a:t>
+            </a:r>
+            <a:endParaRPr lang="en-US" sz="1400" dirty="0"/>
+          </a:p>
+        </p:txBody>
+      </p:sp>
+      <p:sp>
+        <p:nvSpPr>
+          <p:cNvPr id="11" name="cap-c"/>
+          <p:cNvSpPr/>
+          <p:nvPr/>
+        </p:nvSpPr>
+        <p:spPr>
+          <a:xfrm>
+            <a:off x="7040880" y="5276088"/>
+            <a:ext cx="4663440" cy="640080"/>
+          </a:xfrm>
+          <a:prstGeom prst="roundRect">
+            <a:avLst>
+              <a:gd name="adj" fmla="val 20000"/>
+            </a:avLst>
+          </a:prstGeom>
+          <a:solidFill>
+            <a:srgbClr val="FFFFFF"/>
+          </a:solidFill>
+          <a:ln/>
+          <a:effectLst>
+            <a:outerShdw sx="100000" sy="100000" kx="0" ky="0" algn="bl" rotWithShape="0" blurRad="101600" dist="25400" dir="5400000">
+              <a:srgbClr val="0B1F3A">
+                <a:alpha val="10000"/>
+              </a:srgbClr>
+            </a:outerShdw>
+          </a:effectLst>
+        </p:spPr>
+      </p:sp>
+      <p:sp>
+        <p:nvSpPr>
+          <p:cNvPr id="12" name="Text 7"/>
+          <p:cNvSpPr txBox="1"/>
+          <p:nvPr/>
+        </p:nvSpPr>
+        <p:spPr>
+          <a:xfrm>
+            <a:off x="7168896" y="5349240"/>
+            <a:ext cx="4407408" cy="493776"/>
+          </a:xfrm>
+          <a:prstGeom prst="rect">
+            <a:avLst/>
+          </a:prstGeom>
+          <a:noFill/>
+          <a:ln/>
+        </p:spPr>
+        <p:txBody>
+          <a:bodyPr wrap="square" lIns="0" tIns="0" rIns="0" bIns="0" rtlCol="0" anchor="ctr"/>
+          <a:lstStyle/>
+          <a:p>
+            <a:pPr indent="0" marL="0">
+              <a:buNone/>
+            </a:pPr>
+            <a:r>
+              <a:rPr lang="en-US" sz="1400" dirty="0">
+                <a:solidFill>
+                  <a:schemeClr val="tx1"/>
+                </a:solidFill>
+              </a:rPr>
+              <a:t>Nova holds Bailey Hall.</a:t>
+            </a:r>
+            <a:endParaRPr lang="en-US" sz="1400" dirty="0"/>
           </a:p>
         </p:txBody>
       </p:sp>
@@ -5220,8 +4808,8 @@
         </p:nvSpPr>
         <p:spPr>
           <a:xfrm>
-            <a:off x="548640" y="256032"/>
-            <a:ext cx="11064240" cy="658368"/>
+            <a:off x="457200" y="201168"/>
+            <a:ext cx="11247120" cy="566928"/>
           </a:xfrm>
           <a:prstGeom prst="rect">
             <a:avLst/>
@@ -5237,14 +4825,14 @@
               <a:buNone/>
             </a:pPr>
             <a:r>
-              <a:rPr lang="en-US" sz="3600" b="1" dirty="0">
+              <a:rPr lang="en-US" sz="3000" b="1" dirty="0">
                 <a:solidFill>
                   <a:schemeClr val="tx1"/>
                 </a:solidFill>
               </a:rPr>
               <a:t>Everyday walks. Extraordinary company.</a:t>
             </a:r>
-            <a:endParaRPr lang="en-US" sz="3600" dirty="0"/>
+            <a:endParaRPr lang="en-US" sz="3000" dirty="0"/>
           </a:p>
         </p:txBody>
       </p:sp>
@@ -5256,8 +4844,8 @@
         </p:nvSpPr>
         <p:spPr>
           <a:xfrm>
-            <a:off x="548640" y="1005840"/>
-            <a:ext cx="11064240" cy="411480"/>
+            <a:off x="457200" y="914400"/>
+            <a:ext cx="11247120" cy="365760"/>
           </a:xfrm>
           <a:prstGeom prst="rect">
             <a:avLst/>
@@ -5292,8 +4880,8 @@
         </p:nvSpPr>
         <p:spPr>
           <a:xfrm>
-            <a:off x="548640" y="1554480"/>
-            <a:ext cx="11064240" cy="365760"/>
+            <a:off x="457200" y="1417320"/>
+            <a:ext cx="11247120" cy="320040"/>
           </a:xfrm>
           <a:prstGeom prst="rect">
             <a:avLst/>
@@ -5328,12 +4916,12 @@
         </p:nvSpPr>
         <p:spPr>
           <a:xfrm>
-            <a:off x="548640" y="2057400"/>
-            <a:ext cx="3611880" cy="2148840"/>
+            <a:off x="457200" y="1874520"/>
+            <a:ext cx="3657600" cy="2057400"/>
           </a:xfrm>
           <a:prstGeom prst="roundRect">
             <a:avLst>
-              <a:gd name="adj" fmla="val 6809"/>
+              <a:gd name="adj" fmla="val 6222"/>
             </a:avLst>
           </a:prstGeom>
           <a:solidFill>
@@ -5343,7 +4931,7 @@
           <a:effectLst>
             <a:outerShdw sx="100000" sy="100000" kx="0" ky="0" algn="bl" rotWithShape="0" blurRad="101600" dist="25400" dir="5400000">
               <a:srgbClr val="0B1F3A">
-                <a:alpha val="8000"/>
+                <a:alpha val="10000"/>
               </a:srgbClr>
             </a:outerShdw>
           </a:effectLst>
@@ -5357,8 +4945,8 @@
         </p:nvSpPr>
         <p:spPr>
           <a:xfrm>
-            <a:off x="749808" y="2286000"/>
-            <a:ext cx="3200400" cy="777240"/>
+            <a:off x="658368" y="2057400"/>
+            <a:ext cx="3246120" cy="777240"/>
           </a:xfrm>
           <a:prstGeom prst="rect">
             <a:avLst/>
@@ -5393,8 +4981,8 @@
         </p:nvSpPr>
         <p:spPr>
           <a:xfrm>
-            <a:off x="749808" y="3108960"/>
-            <a:ext cx="3200400" cy="822960"/>
+            <a:off x="658368" y="2880360"/>
+            <a:ext cx="3246120" cy="777240"/>
           </a:xfrm>
           <a:prstGeom prst="rect">
             <a:avLst/>
@@ -5429,12 +5017,12 @@
         </p:nvSpPr>
         <p:spPr>
           <a:xfrm>
-            <a:off x="4343400" y="2057400"/>
-            <a:ext cx="3611880" cy="2148840"/>
+            <a:off x="4297680" y="1874520"/>
+            <a:ext cx="3657600" cy="2057400"/>
           </a:xfrm>
           <a:prstGeom prst="roundRect">
             <a:avLst>
-              <a:gd name="adj" fmla="val 6809"/>
+              <a:gd name="adj" fmla="val 6222"/>
             </a:avLst>
           </a:prstGeom>
           <a:solidFill>
@@ -5444,7 +5032,7 @@
           <a:effectLst>
             <a:outerShdw sx="100000" sy="100000" kx="0" ky="0" algn="bl" rotWithShape="0" blurRad="101600" dist="25400" dir="5400000">
               <a:srgbClr val="0B1F3A">
-                <a:alpha val="8000"/>
+                <a:alpha val="10000"/>
               </a:srgbClr>
             </a:outerShdw>
           </a:effectLst>
@@ -5458,8 +5046,8 @@
         </p:nvSpPr>
         <p:spPr>
           <a:xfrm>
-            <a:off x="4544568" y="2286000"/>
-            <a:ext cx="3200400" cy="777240"/>
+            <a:off x="4498848" y="2057400"/>
+            <a:ext cx="3246120" cy="777240"/>
           </a:xfrm>
           <a:prstGeom prst="rect">
             <a:avLst/>
@@ -5494,8 +5082,8 @@
         </p:nvSpPr>
         <p:spPr>
           <a:xfrm>
-            <a:off x="4544568" y="3108960"/>
-            <a:ext cx="3200400" cy="822960"/>
+            <a:off x="4498848" y="2880360"/>
+            <a:ext cx="3246120" cy="777240"/>
           </a:xfrm>
           <a:prstGeom prst="rect">
             <a:avLst/>
@@ -5530,12 +5118,12 @@
         </p:nvSpPr>
         <p:spPr>
           <a:xfrm>
-            <a:off x="8138160" y="2057400"/>
-            <a:ext cx="3611880" cy="2148840"/>
+            <a:off x="8138160" y="1874520"/>
+            <a:ext cx="3657600" cy="2057400"/>
           </a:xfrm>
           <a:prstGeom prst="roundRect">
             <a:avLst>
-              <a:gd name="adj" fmla="val 6809"/>
+              <a:gd name="adj" fmla="val 6222"/>
             </a:avLst>
           </a:prstGeom>
           <a:solidFill>
@@ -5545,7 +5133,7 @@
           <a:effectLst>
             <a:outerShdw sx="100000" sy="100000" kx="0" ky="0" algn="bl" rotWithShape="0" blurRad="101600" dist="25400" dir="5400000">
               <a:srgbClr val="0B1F3A">
-                <a:alpha val="8000"/>
+                <a:alpha val="10000"/>
               </a:srgbClr>
             </a:outerShdw>
           </a:effectLst>
@@ -5559,8 +5147,8 @@
         </p:nvSpPr>
         <p:spPr>
           <a:xfrm>
-            <a:off x="8339328" y="2286000"/>
-            <a:ext cx="3200400" cy="777240"/>
+            <a:off x="8339328" y="2057400"/>
+            <a:ext cx="3246120" cy="777240"/>
           </a:xfrm>
           <a:prstGeom prst="rect">
             <a:avLst/>
@@ -5595,8 +5183,8 @@
         </p:nvSpPr>
         <p:spPr>
           <a:xfrm>
-            <a:off x="8339328" y="3108960"/>
-            <a:ext cx="3200400" cy="822960"/>
+            <a:off x="8339328" y="2880360"/>
+            <a:ext cx="3246120" cy="777240"/>
           </a:xfrm>
           <a:prstGeom prst="rect">
             <a:avLst/>
@@ -5639,8 +5227,8 @@
         </p:blipFill>
         <p:spPr>
           <a:xfrm>
-            <a:off x="640080" y="4480560"/>
-            <a:ext cx="1234440" cy="1234440"/>
+            <a:off x="502920" y="4251960"/>
+            <a:ext cx="1143000" cy="1143000"/>
           </a:xfrm>
           <a:prstGeom prst="rect">
             <a:avLst/>
@@ -5655,8 +5243,8 @@
         </p:nvSpPr>
         <p:spPr>
           <a:xfrm>
-            <a:off x="2011680" y="4709160"/>
-            <a:ext cx="9509760" cy="502920"/>
+            <a:off x="1874520" y="4389120"/>
+            <a:ext cx="9692640" cy="457200"/>
           </a:xfrm>
           <a:prstGeom prst="rect">
             <a:avLst/>
@@ -5691,8 +5279,8 @@
         </p:nvSpPr>
         <p:spPr>
           <a:xfrm>
-            <a:off x="2011680" y="5257800"/>
-            <a:ext cx="9509760" cy="365760"/>
+            <a:off x="1874520" y="4892040"/>
+            <a:ext cx="9692640" cy="365760"/>
           </a:xfrm>
           <a:prstGeom prst="rect">
             <a:avLst/>

</xml_diff>

<commit_message>
updated the slides with imessages
</commit_message>
<xml_diff>
--- a/docs/presentation/HuskiesPaws-BigRedHacks-2026.pptx
+++ b/docs/presentation/HuskiesPaws-BigRedHacks-2026.pptx
@@ -12,9 +12,10 @@
     <p:sldId id="260" r:id="rId6"/>
     <p:sldId id="261" r:id="rId7"/>
     <p:sldId id="262" r:id="rId8"/>
+    <p:sldId id="263" r:id="rId9"/>
   </p:sldIdLst>
   <p:notesMasterIdLst>
-    <p:notesMasterId r:id="rId9"/>
+    <p:notesMasterId r:id="rId10"/>
   </p:notesMasterIdLst>
   <p:sldSz cx="12191695" cy="6858000"/>
   <p:notesSz cx="6858000" cy="12191695"/>
@@ -113,27 +114,28 @@
   <p:extLst>
     <p:ext uri="{521415D9-36F7-43E2-AB2F-B90AF26B5E84}">
       <p14:sectionLst xmlns:p14="http://schemas.microsoft.com/office/powerpoint/2010/main">
-        <p14:section name="Pitch" id="{75c60f64-f831-6c14-78a7-61d93ef339ec}">
+        <p14:section name="Pitch" id="{988b1e71-1b5d-ce37-e0b3-2e366a6be4a8}">
           <p14:sldIdLst>
             <p14:sldId id="256"/>
             <p14:sldId id="257"/>
             <p14:sldId id="258"/>
           </p14:sldIdLst>
         </p14:section>
-        <p14:section name="Demo" id="{e85ba79f-efed-ae6f-698c-c17e38775cb1}">
+        <p14:section name="Demo" id="{0c1816e8-be19-15fd-7d77-6dcd8daab24e}">
           <p14:sldIdLst>
             <p14:sldId id="259"/>
           </p14:sldIdLst>
         </p14:section>
-        <p14:section name="Build" id="{a9fd02b3-0671-ec03-9fc5-fd48b3121434}">
+        <p14:section name="Build" id="{b5eb30e9-30c5-4312-17a8-e057b997c40a}">
           <p14:sldIdLst>
             <p14:sldId id="260"/>
             <p14:sldId id="261"/>
+            <p14:sldId id="262"/>
           </p14:sldIdLst>
         </p14:section>
-        <p14:section name="Close" id="{781d7c0b-19e4-d151-c0d1-62d4b7a8e03b}">
+        <p14:section name="Close" id="{aaf720ed-59fe-31f5-874c-9e96a20bad09}">
           <p14:sldIdLst>
-            <p14:sldId id="262"/>
+            <p14:sldId id="263"/>
           </p14:sldIdLst>
         </p14:section>
       </p14:sectionLst>
@@ -892,7 +894,7 @@
           <a:p>
             <a:r>
               <a:rPr lang="en-US" dirty="0"/>
-              <a:t>About 25 seconds. Phone talks to our Node API. Secrets never ship in the app. Wikipedia and OSM ground the adventure. Speech and Imagine are optional. Shared core keeps pets, ranks, and walks consistent. Photon is iMessage. Built in Cursor. Do not say Render is live unless health is green.</a:t>
+              <a:t>About 25 seconds. Phone talks to our Node API. Secrets never ship in the app. Wikipedia and OSM ground the adventure. The text path is iMessage, Photon Spectrum, the Node.js companion, and the same shared backend. Scout, Storyteller, and Pathfinder are roles. Built in Cursor. Do not say Render is live unless health is green.</a:t>
             </a:r>
             <a:endParaRPr lang="en-US" dirty="0"/>
           </a:p>
@@ -980,7 +982,8 @@
           <a:p>
             <a:r>
               <a:rPr lang="en-US" dirty="0"/>
-              <a:t>About 25 seconds. Three things they saw: navigation is play; walking earns creatures; you can hold a real landmark. ISS rare-hatch boost is in shared logic. Be honest about Grok keys, deploy, and background GPS. The squad can also live in iMessage.</a:t>
+              <a:t>Photon extends HuskiesPaws into iMessage. Players can interact with the squad by text, and walking updates connect the mobile adventure back to the conversation.
+Scout explores, the Storyteller tells the story, and the Pathfinder sends walking directions. Those are roles with template replies filled from Wikipedia and maps, not models collaborating. The explore, take me there, arrived sequence is covered by companion tests. This screenshot is a real Explore reply. Story voice notes and unprompted milestone texts are implemented; live iMessage delivery is not verified here.</a:t>
             </a:r>
             <a:endParaRPr lang="en-US" dirty="0"/>
           </a:p>
@@ -1068,7 +1071,7 @@
           <a:p>
             <a:r>
               <a:rPr lang="en-US" dirty="0"/>
-              <a:t>About 25 seconds. Close on campus exploration — not inflated stats. Next is planned: background tracking, a deploy that stays awake, richer social play. Line: Everyday walks. Extraordinary company. Hand them the phone.</a:t>
+              <a:t>About 25 seconds. Three things they saw: navigation is play; walking earns creatures; you can hold a real landmark. ISS rare-hatch boost is in shared logic. Be honest about Grok keys, deploy, and background GPS. The squad can also live in iMessage.</a:t>
             </a:r>
             <a:endParaRPr lang="en-US" dirty="0"/>
           </a:p>
@@ -1092,6 +1095,94 @@
             <a:fld id="{F7021451-1387-4CA6-816F-3879F97B5CBC}" type="slidenum">
               <a:rPr lang="en-US"/>
               <a:t>7</a:t>
+            </a:fld>
+            <a:endParaRPr lang="en-US"/>
+          </a:p>
+        </p:txBody>
+      </p:sp>
+    </p:spTree>
+    <p:extLst>
+      <p:ext uri="{BB962C8B-B14F-4D97-AF65-F5344CB8AC3E}">
+        <p14:creationId xmlns:p14="http://schemas.microsoft.com/office/powerpoint/2010/main" val="1024086991"/>
+      </p:ext>
+    </p:extLst>
+  </p:cSld>
+  <p:clrMapOvr>
+    <a:masterClrMapping/>
+  </p:clrMapOvr>
+</p:notes>
+</file>
+
+<file path=ppt/notesSlides/notesSlide8.xml><?xml version="1.0" encoding="utf-8"?>
+<p:notes xmlns:a="http://schemas.openxmlformats.org/drawingml/2006/main" xmlns:r="http://schemas.openxmlformats.org/officeDocument/2006/relationships" xmlns:p="http://schemas.openxmlformats.org/presentationml/2006/main">
+  <p:cSld>
+    <p:spTree>
+      <p:nvGrpSpPr>
+        <p:cNvPr id="1" name=""/>
+        <p:cNvGrpSpPr/>
+        <p:nvPr/>
+      </p:nvGrpSpPr>
+      <p:grpSpPr>
+        <a:xfrm>
+          <a:off x="0" y="0"/>
+          <a:ext cx="0" cy="0"/>
+          <a:chOff x="0" y="0"/>
+          <a:chExt cx="0" cy="0"/>
+        </a:xfrm>
+      </p:grpSpPr>
+      <p:sp>
+        <p:nvSpPr>
+          <p:cNvPr id="2" name="Slide Image Placeholder 1"/>
+          <p:cNvSpPr>
+            <a:spLocks noGrp="1" noRot="1" noChangeAspect="1"/>
+          </p:cNvSpPr>
+          <p:nvPr>
+            <p:ph type="sldImg"/>
+          </p:nvPr>
+        </p:nvSpPr>
+        <p:spPr/>
+      </p:sp>
+      <p:sp>
+        <p:nvSpPr>
+          <p:cNvPr id="3" name="Notes Placeholder 2"/>
+          <p:cNvSpPr>
+            <a:spLocks noGrp="1"/>
+          </p:cNvSpPr>
+          <p:nvPr>
+            <p:ph type="body" idx="1"/>
+          </p:nvPr>
+        </p:nvSpPr>
+        <p:spPr/>
+        <p:txBody>
+          <a:bodyPr/>
+          <a:lstStyle/>
+          <a:p>
+            <a:r>
+              <a:rPr lang="en-US" dirty="0"/>
+              <a:t>About 25 seconds. Close on campus exploration — not inflated stats. Next is planned: background tracking, a deploy that stays awake, richer social play. Line: Everyday walks. Extraordinary company. Hand them the phone.</a:t>
+            </a:r>
+            <a:endParaRPr lang="en-US" dirty="0"/>
+          </a:p>
+        </p:txBody>
+      </p:sp>
+      <p:sp>
+        <p:nvSpPr>
+          <p:cNvPr id="4" name="Slide Number Placeholder 3"/>
+          <p:cNvSpPr>
+            <a:spLocks noGrp="1"/>
+          </p:cNvSpPr>
+          <p:nvPr>
+            <p:ph type="sldNum" sz="quarter" idx="10"/>
+          </p:nvPr>
+        </p:nvSpPr>
+        <p:spPr/>
+        <p:txBody>
+          <a:bodyPr/>
+          <a:lstStyle/>
+          <a:p>
+            <a:fld id="{F7021451-1387-4CA6-816F-3879F97B5CBC}" type="slidenum">
+              <a:rPr lang="en-US"/>
+              <a:t>8</a:t>
             </a:fld>
             <a:endParaRPr lang="en-US"/>
           </a:p>
@@ -3844,12 +3935,12 @@
         </p:nvSpPr>
         <p:spPr>
           <a:xfrm>
-            <a:off x="502920" y="1097280"/>
-            <a:ext cx="3383280" cy="2240280"/>
+            <a:off x="502920" y="960120"/>
+            <a:ext cx="3383280" cy="1783080"/>
           </a:xfrm>
           <a:prstGeom prst="roundRect">
             <a:avLst>
-              <a:gd name="adj" fmla="val 5714"/>
+              <a:gd name="adj" fmla="val 7179"/>
             </a:avLst>
           </a:prstGeom>
           <a:solidFill>
@@ -3873,8 +3964,8 @@
         </p:nvSpPr>
         <p:spPr>
           <a:xfrm>
-            <a:off x="704088" y="1280160"/>
-            <a:ext cx="2971800" cy="457200"/>
+            <a:off x="704088" y="1078992"/>
+            <a:ext cx="2971800" cy="384048"/>
           </a:xfrm>
           <a:prstGeom prst="rect">
             <a:avLst/>
@@ -3890,14 +3981,14 @@
               <a:buNone/>
             </a:pPr>
             <a:r>
-              <a:rPr lang="en-US" sz="2400" b="1" dirty="0">
+              <a:rPr lang="en-US" sz="2200" b="1" dirty="0">
                 <a:solidFill>
                   <a:schemeClr val="tx1"/>
                 </a:solidFill>
               </a:rPr>
               <a:t>Phone</a:t>
             </a:r>
-            <a:endParaRPr lang="en-US" sz="2400" dirty="0"/>
+            <a:endParaRPr lang="en-US" sz="2200" dirty="0"/>
           </a:p>
         </p:txBody>
       </p:sp>
@@ -3909,8 +4000,8 @@
         </p:nvSpPr>
         <p:spPr>
           <a:xfrm>
-            <a:off x="704088" y="1874520"/>
-            <a:ext cx="2971800" cy="1188720"/>
+            <a:off x="704088" y="1536192"/>
+            <a:ext cx="2971800" cy="960120"/>
           </a:xfrm>
           <a:prstGeom prst="rect">
             <a:avLst/>
@@ -3926,28 +4017,28 @@
               <a:buNone/>
             </a:pPr>
             <a:r>
-              <a:rPr lang="en-US" sz="1800" dirty="0">
+              <a:rPr lang="en-US" sz="1600" dirty="0">
                 <a:solidFill>
                   <a:schemeClr val="accent6"/>
                 </a:solidFill>
               </a:rPr>
               <a:t>Expo app</a:t>
             </a:r>
-            <a:endParaRPr lang="en-US" sz="1800" dirty="0"/>
+            <a:endParaRPr lang="en-US" sz="1600" dirty="0"/>
           </a:p>
           <a:p>
             <a:pPr indent="0" marL="0">
               <a:buNone/>
             </a:pPr>
             <a:r>
-              <a:rPr lang="en-US" sz="1800" dirty="0">
+              <a:rPr lang="en-US" sz="1600" dirty="0">
                 <a:solidFill>
                   <a:schemeClr val="accent6"/>
                 </a:solidFill>
               </a:rPr>
               <a:t>Shared game logic</a:t>
             </a:r>
-            <a:endParaRPr lang="en-US" sz="1800" dirty="0"/>
+            <a:endParaRPr lang="en-US" sz="1600" dirty="0"/>
           </a:p>
         </p:txBody>
       </p:sp>
@@ -3959,8 +4050,8 @@
         </p:nvSpPr>
         <p:spPr>
           <a:xfrm>
-            <a:off x="3749040" y="1920240"/>
-            <a:ext cx="640080" cy="502920"/>
+            <a:off x="3749040" y="1554480"/>
+            <a:ext cx="640080" cy="457200"/>
           </a:xfrm>
           <a:prstGeom prst="rect">
             <a:avLst/>
@@ -3976,14 +4067,14 @@
               <a:buNone/>
             </a:pPr>
             <a:r>
-              <a:rPr lang="en-US" sz="2800" b="1" dirty="0">
+              <a:rPr lang="en-US" sz="2600" b="1" dirty="0">
                 <a:solidFill>
                   <a:schemeClr val="accent1"/>
                 </a:solidFill>
               </a:rPr>
               <a:t>→</a:t>
             </a:r>
-            <a:endParaRPr lang="en-US" sz="2800" dirty="0"/>
+            <a:endParaRPr lang="en-US" sz="2600" dirty="0"/>
           </a:p>
         </p:txBody>
       </p:sp>
@@ -3995,12 +4086,12 @@
         </p:nvSpPr>
         <p:spPr>
           <a:xfrm>
-            <a:off x="4389120" y="1097280"/>
-            <a:ext cx="3383280" cy="2240280"/>
+            <a:off x="4389120" y="960120"/>
+            <a:ext cx="3383280" cy="1783080"/>
           </a:xfrm>
           <a:prstGeom prst="roundRect">
             <a:avLst>
-              <a:gd name="adj" fmla="val 5714"/>
+              <a:gd name="adj" fmla="val 7179"/>
             </a:avLst>
           </a:prstGeom>
           <a:solidFill>
@@ -4024,8 +4115,8 @@
         </p:nvSpPr>
         <p:spPr>
           <a:xfrm>
-            <a:off x="4590288" y="1280160"/>
-            <a:ext cx="2971800" cy="457200"/>
+            <a:off x="4590288" y="1078992"/>
+            <a:ext cx="2971800" cy="384048"/>
           </a:xfrm>
           <a:prstGeom prst="rect">
             <a:avLst/>
@@ -4041,14 +4132,14 @@
               <a:buNone/>
             </a:pPr>
             <a:r>
-              <a:rPr lang="en-US" sz="2400" b="1" dirty="0">
+              <a:rPr lang="en-US" sz="2200" b="1" dirty="0">
                 <a:solidFill>
                   <a:schemeClr val="accent3"/>
                 </a:solidFill>
               </a:rPr>
               <a:t>API</a:t>
             </a:r>
-            <a:endParaRPr lang="en-US" sz="2400" dirty="0"/>
+            <a:endParaRPr lang="en-US" sz="2200" dirty="0"/>
           </a:p>
         </p:txBody>
       </p:sp>
@@ -4060,8 +4151,8 @@
         </p:nvSpPr>
         <p:spPr>
           <a:xfrm>
-            <a:off x="4590288" y="1874520"/>
-            <a:ext cx="2971800" cy="1188720"/>
+            <a:off x="4590288" y="1536192"/>
+            <a:ext cx="2971800" cy="960120"/>
           </a:xfrm>
           <a:prstGeom prst="rect">
             <a:avLst/>
@@ -4077,28 +4168,28 @@
               <a:buNone/>
             </a:pPr>
             <a:r>
-              <a:rPr lang="en-US" sz="1800" dirty="0">
+              <a:rPr lang="en-US" sz="1600" dirty="0">
                 <a:solidFill>
                   <a:srgbClr val="FFFFFF"/>
                 </a:solidFill>
               </a:rPr>
               <a:t>Node /api</a:t>
             </a:r>
-            <a:endParaRPr lang="en-US" sz="1800" dirty="0"/>
+            <a:endParaRPr lang="en-US" sz="1600" dirty="0"/>
           </a:p>
           <a:p>
             <a:pPr indent="0" marL="0">
               <a:buNone/>
             </a:pPr>
             <a:r>
-              <a:rPr lang="en-US" sz="1800" dirty="0">
+              <a:rPr lang="en-US" sz="1600" dirty="0">
                 <a:solidFill>
                   <a:srgbClr val="FFFFFF"/>
                 </a:solidFill>
               </a:rPr>
               <a:t>Secrets stay here</a:t>
             </a:r>
-            <a:endParaRPr lang="en-US" sz="1800" dirty="0"/>
+            <a:endParaRPr lang="en-US" sz="1600" dirty="0"/>
           </a:p>
         </p:txBody>
       </p:sp>
@@ -4110,8 +4201,8 @@
         </p:nvSpPr>
         <p:spPr>
           <a:xfrm>
-            <a:off x="7635240" y="1920240"/>
-            <a:ext cx="640080" cy="502920"/>
+            <a:off x="7635240" y="1554480"/>
+            <a:ext cx="640080" cy="457200"/>
           </a:xfrm>
           <a:prstGeom prst="rect">
             <a:avLst/>
@@ -4127,14 +4218,14 @@
               <a:buNone/>
             </a:pPr>
             <a:r>
-              <a:rPr lang="en-US" sz="2800" b="1" dirty="0">
+              <a:rPr lang="en-US" sz="2600" b="1" dirty="0">
                 <a:solidFill>
                   <a:schemeClr val="accent1"/>
                 </a:solidFill>
               </a:rPr>
               <a:t>→</a:t>
             </a:r>
-            <a:endParaRPr lang="en-US" sz="2800" dirty="0"/>
+            <a:endParaRPr lang="en-US" sz="2600" dirty="0"/>
           </a:p>
         </p:txBody>
       </p:sp>
@@ -4146,12 +4237,12 @@
         </p:nvSpPr>
         <p:spPr>
           <a:xfrm>
-            <a:off x="8275320" y="1097280"/>
-            <a:ext cx="3383280" cy="2240280"/>
+            <a:off x="8275320" y="960120"/>
+            <a:ext cx="3383280" cy="1783080"/>
           </a:xfrm>
           <a:prstGeom prst="roundRect">
             <a:avLst>
-              <a:gd name="adj" fmla="val 5714"/>
+              <a:gd name="adj" fmla="val 7179"/>
             </a:avLst>
           </a:prstGeom>
           <a:solidFill>
@@ -4175,8 +4266,8 @@
         </p:nvSpPr>
         <p:spPr>
           <a:xfrm>
-            <a:off x="8476488" y="1280160"/>
-            <a:ext cx="2971800" cy="457200"/>
+            <a:off x="8476488" y="1078992"/>
+            <a:ext cx="2971800" cy="384048"/>
           </a:xfrm>
           <a:prstGeom prst="rect">
             <a:avLst/>
@@ -4192,14 +4283,14 @@
               <a:buNone/>
             </a:pPr>
             <a:r>
-              <a:rPr lang="en-US" sz="2400" b="1" dirty="0">
+              <a:rPr lang="en-US" sz="2200" b="1" dirty="0">
                 <a:solidFill>
                   <a:schemeClr val="tx1"/>
                 </a:solidFill>
               </a:rPr>
               <a:t>World</a:t>
             </a:r>
-            <a:endParaRPr lang="en-US" sz="2400" dirty="0"/>
+            <a:endParaRPr lang="en-US" sz="2200" dirty="0"/>
           </a:p>
         </p:txBody>
       </p:sp>
@@ -4211,8 +4302,8 @@
         </p:nvSpPr>
         <p:spPr>
           <a:xfrm>
-            <a:off x="8476488" y="1874520"/>
-            <a:ext cx="2971800" cy="1188720"/>
+            <a:off x="8476488" y="1536192"/>
+            <a:ext cx="2971800" cy="960120"/>
           </a:xfrm>
           <a:prstGeom prst="rect">
             <a:avLst/>
@@ -4228,15 +4319,639 @@
               <a:buNone/>
             </a:pPr>
             <a:r>
+              <a:rPr lang="en-US" sz="1600" dirty="0">
+                <a:solidFill>
+                  <a:schemeClr val="accent6"/>
+                </a:solidFill>
+              </a:rPr>
+              <a:t>Wikipedia · OSM</a:t>
+            </a:r>
+            <a:endParaRPr lang="en-US" sz="1600" dirty="0"/>
+          </a:p>
+          <a:p>
+            <a:pPr indent="0" marL="0">
+              <a:buNone/>
+            </a:pPr>
+            <a:r>
+              <a:rPr lang="en-US" sz="1600" dirty="0">
+                <a:solidFill>
+                  <a:schemeClr val="accent6"/>
+                </a:solidFill>
+              </a:rPr>
+              <a:t>Voice and art optional</a:t>
+            </a:r>
+            <a:endParaRPr lang="en-US" sz="1600" dirty="0"/>
+          </a:p>
+        </p:txBody>
+      </p:sp>
+      <p:sp>
+        <p:nvSpPr>
+          <p:cNvPr id="14" name="chain-0"/>
+          <p:cNvSpPr/>
+          <p:nvPr/>
+        </p:nvSpPr>
+        <p:spPr>
+          <a:xfrm>
+            <a:off x="457200" y="2944368"/>
+            <a:ext cx="2542032" cy="1353312"/>
+          </a:xfrm>
+          <a:prstGeom prst="roundRect">
+            <a:avLst>
+              <a:gd name="adj" fmla="val 9459"/>
+            </a:avLst>
+          </a:prstGeom>
+          <a:solidFill>
+            <a:srgbClr val="FFFFFF"/>
+          </a:solidFill>
+          <a:ln/>
+          <a:effectLst>
+            <a:outerShdw sx="100000" sy="100000" kx="0" ky="0" algn="bl" rotWithShape="0" blurRad="101600" dist="25400" dir="5400000">
+              <a:srgbClr val="0B1F3A">
+                <a:alpha val="10000"/>
+              </a:srgbClr>
+            </a:outerShdw>
+          </a:effectLst>
+        </p:spPr>
+      </p:sp>
+      <p:sp>
+        <p:nvSpPr>
+          <p:cNvPr id="15" name="Text 13"/>
+          <p:cNvSpPr txBox="1"/>
+          <p:nvPr/>
+        </p:nvSpPr>
+        <p:spPr>
+          <a:xfrm>
+            <a:off x="566928" y="3072384"/>
+            <a:ext cx="2322576" cy="530352"/>
+          </a:xfrm>
+          <a:prstGeom prst="rect">
+            <a:avLst/>
+          </a:prstGeom>
+          <a:noFill/>
+          <a:ln/>
+        </p:spPr>
+        <p:txBody>
+          <a:bodyPr wrap="square" lIns="0" tIns="0" rIns="0" bIns="0" rtlCol="0" anchor="ctr"/>
+          <a:lstStyle/>
+          <a:p>
+            <a:pPr indent="0" marL="0">
+              <a:buNone/>
+            </a:pPr>
+            <a:r>
+              <a:rPr lang="en-US" sz="1500" b="1" dirty="0">
+                <a:solidFill>
+                  <a:schemeClr val="tx1"/>
+                </a:solidFill>
+              </a:rPr>
+              <a:t>iMessage</a:t>
+            </a:r>
+            <a:endParaRPr lang="en-US" sz="1500" dirty="0"/>
+          </a:p>
+        </p:txBody>
+      </p:sp>
+      <p:sp>
+        <p:nvSpPr>
+          <p:cNvPr id="16" name="Text 14"/>
+          <p:cNvSpPr txBox="1"/>
+          <p:nvPr/>
+        </p:nvSpPr>
+        <p:spPr>
+          <a:xfrm>
+            <a:off x="566928" y="3657600"/>
+            <a:ext cx="2322576" cy="420624"/>
+          </a:xfrm>
+          <a:prstGeom prst="rect">
+            <a:avLst/>
+          </a:prstGeom>
+          <a:noFill/>
+          <a:ln/>
+        </p:spPr>
+        <p:txBody>
+          <a:bodyPr wrap="square" lIns="0" tIns="0" rIns="0" bIns="0" rtlCol="0" anchor="ctr"/>
+          <a:lstStyle/>
+          <a:p>
+            <a:pPr indent="0" marL="0">
+              <a:buNone/>
+            </a:pPr>
+            <a:r>
+              <a:rPr lang="en-US" sz="1300" dirty="0">
+                <a:solidFill>
+                  <a:schemeClr val="accent6"/>
+                </a:solidFill>
+              </a:rPr>
+              <a:t>The player's chat</a:t>
+            </a:r>
+            <a:endParaRPr lang="en-US" sz="1300" dirty="0"/>
+          </a:p>
+        </p:txBody>
+      </p:sp>
+      <p:sp>
+        <p:nvSpPr>
+          <p:cNvPr id="17" name="Text 15"/>
+          <p:cNvSpPr txBox="1"/>
+          <p:nvPr/>
+        </p:nvSpPr>
+        <p:spPr>
+          <a:xfrm>
+            <a:off x="2962656" y="3401568"/>
+            <a:ext cx="420624" cy="365760"/>
+          </a:xfrm>
+          <a:prstGeom prst="rect">
+            <a:avLst/>
+          </a:prstGeom>
+          <a:noFill/>
+          <a:ln/>
+        </p:spPr>
+        <p:txBody>
+          <a:bodyPr wrap="square" lIns="0" tIns="0" rIns="0" bIns="0" rtlCol="0" anchor="ctr"/>
+          <a:lstStyle/>
+          <a:p>
+            <a:pPr algn="ctr" indent="0" marL="0">
+              <a:buNone/>
+            </a:pPr>
+            <a:r>
+              <a:rPr lang="en-US" sz="1600" b="1" dirty="0">
+                <a:solidFill>
+                  <a:schemeClr val="accent1"/>
+                </a:solidFill>
+              </a:rPr>
+              <a:t>↔</a:t>
+            </a:r>
+            <a:endParaRPr lang="en-US" sz="1600" dirty="0"/>
+          </a:p>
+        </p:txBody>
+      </p:sp>
+      <p:sp>
+        <p:nvSpPr>
+          <p:cNvPr id="18" name="chain-1"/>
+          <p:cNvSpPr/>
+          <p:nvPr/>
+        </p:nvSpPr>
+        <p:spPr>
+          <a:xfrm>
+            <a:off x="3364992" y="2944368"/>
+            <a:ext cx="2542032" cy="1353312"/>
+          </a:xfrm>
+          <a:prstGeom prst="roundRect">
+            <a:avLst>
+              <a:gd name="adj" fmla="val 9459"/>
+            </a:avLst>
+          </a:prstGeom>
+          <a:solidFill>
+            <a:srgbClr val="0B1F3A"/>
+          </a:solidFill>
+          <a:ln/>
+          <a:effectLst>
+            <a:outerShdw sx="100000" sy="100000" kx="0" ky="0" algn="bl" rotWithShape="0" blurRad="101600" dist="25400" dir="5400000">
+              <a:srgbClr val="0B1F3A">
+                <a:alpha val="10000"/>
+              </a:srgbClr>
+            </a:outerShdw>
+          </a:effectLst>
+        </p:spPr>
+      </p:sp>
+      <p:sp>
+        <p:nvSpPr>
+          <p:cNvPr id="19" name="Text 17"/>
+          <p:cNvSpPr txBox="1"/>
+          <p:nvPr/>
+        </p:nvSpPr>
+        <p:spPr>
+          <a:xfrm>
+            <a:off x="3474720" y="3072384"/>
+            <a:ext cx="2322576" cy="530352"/>
+          </a:xfrm>
+          <a:prstGeom prst="rect">
+            <a:avLst/>
+          </a:prstGeom>
+          <a:noFill/>
+          <a:ln/>
+        </p:spPr>
+        <p:txBody>
+          <a:bodyPr wrap="square" lIns="0" tIns="0" rIns="0" bIns="0" rtlCol="0" anchor="ctr"/>
+          <a:lstStyle/>
+          <a:p>
+            <a:pPr indent="0" marL="0">
+              <a:buNone/>
+            </a:pPr>
+            <a:r>
+              <a:rPr lang="en-US" sz="1500" b="1" dirty="0">
+                <a:solidFill>
+                  <a:schemeClr val="accent3"/>
+                </a:solidFill>
+              </a:rPr>
+              <a:t>Photon Spectrum</a:t>
+            </a:r>
+            <a:endParaRPr lang="en-US" sz="1500" dirty="0"/>
+          </a:p>
+        </p:txBody>
+      </p:sp>
+      <p:sp>
+        <p:nvSpPr>
+          <p:cNvPr id="20" name="Text 18"/>
+          <p:cNvSpPr txBox="1"/>
+          <p:nvPr/>
+        </p:nvSpPr>
+        <p:spPr>
+          <a:xfrm>
+            <a:off x="3474720" y="3657600"/>
+            <a:ext cx="2322576" cy="420624"/>
+          </a:xfrm>
+          <a:prstGeom prst="rect">
+            <a:avLst/>
+          </a:prstGeom>
+          <a:noFill/>
+          <a:ln/>
+        </p:spPr>
+        <p:txBody>
+          <a:bodyPr wrap="square" lIns="0" tIns="0" rIns="0" bIns="0" rtlCol="0" anchor="ctr"/>
+          <a:lstStyle/>
+          <a:p>
+            <a:pPr indent="0" marL="0">
+              <a:buNone/>
+            </a:pPr>
+            <a:r>
+              <a:rPr lang="en-US" sz="1300" dirty="0">
+                <a:solidFill>
+                  <a:srgbClr val="FFFFFF"/>
+                </a:solidFill>
+              </a:rPr>
+              <a:t>The iMessage line</a:t>
+            </a:r>
+            <a:endParaRPr lang="en-US" sz="1300" dirty="0"/>
+          </a:p>
+        </p:txBody>
+      </p:sp>
+      <p:sp>
+        <p:nvSpPr>
+          <p:cNvPr id="21" name="Text 19"/>
+          <p:cNvSpPr txBox="1"/>
+          <p:nvPr/>
+        </p:nvSpPr>
+        <p:spPr>
+          <a:xfrm>
+            <a:off x="5870448" y="3401568"/>
+            <a:ext cx="420624" cy="365760"/>
+          </a:xfrm>
+          <a:prstGeom prst="rect">
+            <a:avLst/>
+          </a:prstGeom>
+          <a:noFill/>
+          <a:ln/>
+        </p:spPr>
+        <p:txBody>
+          <a:bodyPr wrap="square" lIns="0" tIns="0" rIns="0" bIns="0" rtlCol="0" anchor="ctr"/>
+          <a:lstStyle/>
+          <a:p>
+            <a:pPr algn="ctr" indent="0" marL="0">
+              <a:buNone/>
+            </a:pPr>
+            <a:r>
+              <a:rPr lang="en-US" sz="1600" b="1" dirty="0">
+                <a:solidFill>
+                  <a:schemeClr val="accent1"/>
+                </a:solidFill>
+              </a:rPr>
+              <a:t>↔</a:t>
+            </a:r>
+            <a:endParaRPr lang="en-US" sz="1600" dirty="0"/>
+          </a:p>
+        </p:txBody>
+      </p:sp>
+      <p:sp>
+        <p:nvSpPr>
+          <p:cNvPr id="22" name="chain-2"/>
+          <p:cNvSpPr/>
+          <p:nvPr/>
+        </p:nvSpPr>
+        <p:spPr>
+          <a:xfrm>
+            <a:off x="6272784" y="2944368"/>
+            <a:ext cx="2542032" cy="1353312"/>
+          </a:xfrm>
+          <a:prstGeom prst="roundRect">
+            <a:avLst>
+              <a:gd name="adj" fmla="val 9459"/>
+            </a:avLst>
+          </a:prstGeom>
+          <a:solidFill>
+            <a:srgbClr val="FFFFFF"/>
+          </a:solidFill>
+          <a:ln/>
+          <a:effectLst>
+            <a:outerShdw sx="100000" sy="100000" kx="0" ky="0" algn="bl" rotWithShape="0" blurRad="101600" dist="25400" dir="5400000">
+              <a:srgbClr val="0B1F3A">
+                <a:alpha val="10000"/>
+              </a:srgbClr>
+            </a:outerShdw>
+          </a:effectLst>
+        </p:spPr>
+      </p:sp>
+      <p:sp>
+        <p:nvSpPr>
+          <p:cNvPr id="23" name="Text 21"/>
+          <p:cNvSpPr txBox="1"/>
+          <p:nvPr/>
+        </p:nvSpPr>
+        <p:spPr>
+          <a:xfrm>
+            <a:off x="6382512" y="3072384"/>
+            <a:ext cx="2322576" cy="530352"/>
+          </a:xfrm>
+          <a:prstGeom prst="rect">
+            <a:avLst/>
+          </a:prstGeom>
+          <a:noFill/>
+          <a:ln/>
+        </p:spPr>
+        <p:txBody>
+          <a:bodyPr wrap="square" lIns="0" tIns="0" rIns="0" bIns="0" rtlCol="0" anchor="ctr"/>
+          <a:lstStyle/>
+          <a:p>
+            <a:pPr indent="0" marL="0">
+              <a:buNone/>
+            </a:pPr>
+            <a:r>
+              <a:rPr lang="en-US" sz="1500" b="1" dirty="0">
+                <a:solidFill>
+                  <a:schemeClr val="tx1"/>
+                </a:solidFill>
+              </a:rPr>
+              <a:t>Node.js companion</a:t>
+            </a:r>
+            <a:endParaRPr lang="en-US" sz="1500" dirty="0"/>
+          </a:p>
+        </p:txBody>
+      </p:sp>
+      <p:sp>
+        <p:nvSpPr>
+          <p:cNvPr id="24" name="Text 22"/>
+          <p:cNvSpPr txBox="1"/>
+          <p:nvPr/>
+        </p:nvSpPr>
+        <p:spPr>
+          <a:xfrm>
+            <a:off x="6382512" y="3657600"/>
+            <a:ext cx="2322576" cy="420624"/>
+          </a:xfrm>
+          <a:prstGeom prst="rect">
+            <a:avLst/>
+          </a:prstGeom>
+          <a:noFill/>
+          <a:ln/>
+        </p:spPr>
+        <p:txBody>
+          <a:bodyPr wrap="square" lIns="0" tIns="0" rIns="0" bIns="0" rtlCol="0" anchor="ctr"/>
+          <a:lstStyle/>
+          <a:p>
+            <a:pPr indent="0" marL="0">
+              <a:buNone/>
+            </a:pPr>
+            <a:r>
+              <a:rPr lang="en-US" sz="1300" dirty="0">
+                <a:solidFill>
+                  <a:schemeClr val="accent6"/>
+                </a:solidFill>
+              </a:rPr>
+              <a:t>Role-based replies</a:t>
+            </a:r>
+            <a:endParaRPr lang="en-US" sz="1300" dirty="0"/>
+          </a:p>
+        </p:txBody>
+      </p:sp>
+      <p:sp>
+        <p:nvSpPr>
+          <p:cNvPr id="25" name="Text 23"/>
+          <p:cNvSpPr txBox="1"/>
+          <p:nvPr/>
+        </p:nvSpPr>
+        <p:spPr>
+          <a:xfrm>
+            <a:off x="8778240" y="3401568"/>
+            <a:ext cx="420624" cy="365760"/>
+          </a:xfrm>
+          <a:prstGeom prst="rect">
+            <a:avLst/>
+          </a:prstGeom>
+          <a:noFill/>
+          <a:ln/>
+        </p:spPr>
+        <p:txBody>
+          <a:bodyPr wrap="square" lIns="0" tIns="0" rIns="0" bIns="0" rtlCol="0" anchor="ctr"/>
+          <a:lstStyle/>
+          <a:p>
+            <a:pPr algn="ctr" indent="0" marL="0">
+              <a:buNone/>
+            </a:pPr>
+            <a:r>
+              <a:rPr lang="en-US" sz="1600" b="1" dirty="0">
+                <a:solidFill>
+                  <a:schemeClr val="accent1"/>
+                </a:solidFill>
+              </a:rPr>
+              <a:t>↔</a:t>
+            </a:r>
+            <a:endParaRPr lang="en-US" sz="1600" dirty="0"/>
+          </a:p>
+        </p:txBody>
+      </p:sp>
+      <p:sp>
+        <p:nvSpPr>
+          <p:cNvPr id="26" name="chain-3"/>
+          <p:cNvSpPr/>
+          <p:nvPr/>
+        </p:nvSpPr>
+        <p:spPr>
+          <a:xfrm>
+            <a:off x="9180576" y="2944368"/>
+            <a:ext cx="2542032" cy="1353312"/>
+          </a:xfrm>
+          <a:prstGeom prst="roundRect">
+            <a:avLst>
+              <a:gd name="adj" fmla="val 9459"/>
+            </a:avLst>
+          </a:prstGeom>
+          <a:solidFill>
+            <a:srgbClr val="FFFFFF"/>
+          </a:solidFill>
+          <a:ln/>
+          <a:effectLst>
+            <a:outerShdw sx="100000" sy="100000" kx="0" ky="0" algn="bl" rotWithShape="0" blurRad="101600" dist="25400" dir="5400000">
+              <a:srgbClr val="0B1F3A">
+                <a:alpha val="10000"/>
+              </a:srgbClr>
+            </a:outerShdw>
+          </a:effectLst>
+        </p:spPr>
+      </p:sp>
+      <p:sp>
+        <p:nvSpPr>
+          <p:cNvPr id="27" name="Text 25"/>
+          <p:cNvSpPr txBox="1"/>
+          <p:nvPr/>
+        </p:nvSpPr>
+        <p:spPr>
+          <a:xfrm>
+            <a:off x="9290304" y="3072384"/>
+            <a:ext cx="2322576" cy="530352"/>
+          </a:xfrm>
+          <a:prstGeom prst="rect">
+            <a:avLst/>
+          </a:prstGeom>
+          <a:noFill/>
+          <a:ln/>
+        </p:spPr>
+        <p:txBody>
+          <a:bodyPr wrap="square" lIns="0" tIns="0" rIns="0" bIns="0" rtlCol="0" anchor="ctr"/>
+          <a:lstStyle/>
+          <a:p>
+            <a:pPr indent="0" marL="0">
+              <a:buNone/>
+            </a:pPr>
+            <a:r>
+              <a:rPr lang="en-US" sz="1500" b="1" dirty="0">
+                <a:solidFill>
+                  <a:schemeClr val="tx1"/>
+                </a:solidFill>
+              </a:rPr>
+              <a:t>Shared backend</a:t>
+            </a:r>
+            <a:endParaRPr lang="en-US" sz="1500" dirty="0"/>
+          </a:p>
+        </p:txBody>
+      </p:sp>
+      <p:sp>
+        <p:nvSpPr>
+          <p:cNvPr id="28" name="Text 26"/>
+          <p:cNvSpPr txBox="1"/>
+          <p:nvPr/>
+        </p:nvSpPr>
+        <p:spPr>
+          <a:xfrm>
+            <a:off x="9290304" y="3657600"/>
+            <a:ext cx="2322576" cy="420624"/>
+          </a:xfrm>
+          <a:prstGeom prst="rect">
+            <a:avLst/>
+          </a:prstGeom>
+          <a:noFill/>
+          <a:ln/>
+        </p:spPr>
+        <p:txBody>
+          <a:bodyPr wrap="square" lIns="0" tIns="0" rIns="0" bIns="0" rtlCol="0" anchor="ctr"/>
+          <a:lstStyle/>
+          <a:p>
+            <a:pPr indent="0" marL="0">
+              <a:buNone/>
+            </a:pPr>
+            <a:r>
+              <a:rPr lang="en-US" sz="1300" dirty="0">
+                <a:solidFill>
+                  <a:schemeClr val="accent6"/>
+                </a:solidFill>
+              </a:rPr>
+              <a:t>core/ and /api</a:t>
+            </a:r>
+            <a:endParaRPr lang="en-US" sz="1300" dirty="0"/>
+          </a:p>
+        </p:txBody>
+      </p:sp>
+      <p:sp>
+        <p:nvSpPr>
+          <p:cNvPr id="29" name="f-0"/>
+          <p:cNvSpPr/>
+          <p:nvPr/>
+        </p:nvSpPr>
+        <p:spPr>
+          <a:xfrm>
+            <a:off x="594360" y="4736592"/>
+            <a:ext cx="292608" cy="292608"/>
+          </a:xfrm>
+          <a:prstGeom prst="ellipse">
+            <a:avLst/>
+          </a:prstGeom>
+          <a:solidFill>
+            <a:schemeClr val="accent2"/>
+          </a:solidFill>
+          <a:ln/>
+        </p:spPr>
+      </p:sp>
+      <p:sp>
+        <p:nvSpPr>
+          <p:cNvPr id="30" name="Text 28"/>
+          <p:cNvSpPr txBox="1"/>
+          <p:nvPr/>
+        </p:nvSpPr>
+        <p:spPr>
+          <a:xfrm>
+            <a:off x="1051560" y="4590288"/>
+            <a:ext cx="10515600" cy="566928"/>
+          </a:xfrm>
+          <a:prstGeom prst="rect">
+            <a:avLst/>
+          </a:prstGeom>
+          <a:noFill/>
+          <a:ln/>
+        </p:spPr>
+        <p:txBody>
+          <a:bodyPr wrap="square" lIns="0" tIns="0" rIns="0" bIns="0" rtlCol="0" anchor="ctr"/>
+          <a:lstStyle/>
+          <a:p>
+            <a:pPr indent="0" marL="0">
+              <a:buNone/>
+            </a:pPr>
+            <a:r>
               <a:rPr lang="en-US" sz="1800" dirty="0">
                 <a:solidFill>
-                  <a:schemeClr val="accent6"/>
-                </a:solidFill>
-              </a:rPr>
-              <a:t>Wikipedia · OSM</a:t>
+                  <a:schemeClr val="tx1"/>
+                </a:solidFill>
+              </a:rPr>
+              <a:t>Facts and routes come from tools, not the model.</a:t>
             </a:r>
             <a:endParaRPr lang="en-US" sz="1800" dirty="0"/>
           </a:p>
+        </p:txBody>
+      </p:sp>
+      <p:sp>
+        <p:nvSpPr>
+          <p:cNvPr id="31" name="f-1"/>
+          <p:cNvSpPr/>
+          <p:nvPr/>
+        </p:nvSpPr>
+        <p:spPr>
+          <a:xfrm>
+            <a:off x="594360" y="5303520"/>
+            <a:ext cx="292608" cy="292608"/>
+          </a:xfrm>
+          <a:prstGeom prst="ellipse">
+            <a:avLst/>
+          </a:prstGeom>
+          <a:solidFill>
+            <a:schemeClr val="accent2"/>
+          </a:solidFill>
+          <a:ln/>
+        </p:spPr>
+      </p:sp>
+      <p:sp>
+        <p:nvSpPr>
+          <p:cNvPr id="32" name="Text 30"/>
+          <p:cNvSpPr txBox="1"/>
+          <p:nvPr/>
+        </p:nvSpPr>
+        <p:spPr>
+          <a:xfrm>
+            <a:off x="1051560" y="5157216"/>
+            <a:ext cx="10515600" cy="566928"/>
+          </a:xfrm>
+          <a:prstGeom prst="rect">
+            <a:avLst/>
+          </a:prstGeom>
+          <a:noFill/>
+          <a:ln/>
+        </p:spPr>
+        <p:txBody>
+          <a:bodyPr wrap="square" lIns="0" tIns="0" rIns="0" bIns="0" rtlCol="0" anchor="ctr"/>
+          <a:lstStyle/>
           <a:p>
             <a:pPr indent="0" marL="0">
               <a:buNone/>
@@ -4244,10 +4959,10 @@
             <a:r>
               <a:rPr lang="en-US" sz="1800" dirty="0">
                 <a:solidFill>
-                  <a:schemeClr val="accent6"/>
-                </a:solidFill>
-              </a:rPr>
-              <a:t>Voice and art optional</a:t>
+                  <a:schemeClr val="tx1"/>
+                </a:solidFill>
+              </a:rPr>
+              <a:t>Scout, Storyteller, and Pathfinder are roles, not collaborating models.</a:t>
             </a:r>
             <a:endParaRPr lang="en-US" sz="1800" dirty="0"/>
           </a:p>
@@ -4255,13 +4970,13 @@
       </p:sp>
       <p:sp>
         <p:nvSpPr>
-          <p:cNvPr id="14" name="f-0"/>
+          <p:cNvPr id="33" name="f-2"/>
           <p:cNvSpPr/>
           <p:nvPr/>
         </p:nvSpPr>
         <p:spPr>
           <a:xfrm>
-            <a:off x="594360" y="3822192"/>
+            <a:off x="594360" y="5870448"/>
             <a:ext cx="292608" cy="292608"/>
           </a:xfrm>
           <a:prstGeom prst="ellipse">
@@ -4275,14 +4990,14 @@
       </p:sp>
       <p:sp>
         <p:nvSpPr>
-          <p:cNvPr id="15" name="Text 13"/>
-          <p:cNvSpPr txBox="1"/>
-          <p:nvPr/>
-        </p:nvSpPr>
-        <p:spPr>
-          <a:xfrm>
-            <a:off x="1051560" y="3657600"/>
-            <a:ext cx="10515600" cy="640080"/>
+          <p:cNvPr id="34" name="Text 32"/>
+          <p:cNvSpPr txBox="1"/>
+          <p:nvPr/>
+        </p:nvSpPr>
+        <p:spPr>
+          <a:xfrm>
+            <a:off x="1051560" y="5724144"/>
+            <a:ext cx="10515600" cy="566928"/>
           </a:xfrm>
           <a:prstGeom prst="rect">
             <a:avLst/>
@@ -4298,126 +5013,14 @@
               <a:buNone/>
             </a:pPr>
             <a:r>
-              <a:rPr lang="en-US" sz="2000" dirty="0">
+              <a:rPr lang="en-US" sz="1800" dirty="0">
                 <a:solidFill>
                   <a:schemeClr val="tx1"/>
                 </a:solidFill>
               </a:rPr>
-              <a:t>Facts and routes come from tools, not the model.</a:t>
-            </a:r>
-            <a:endParaRPr lang="en-US" sz="2000" dirty="0"/>
-          </a:p>
-        </p:txBody>
-      </p:sp>
-      <p:sp>
-        <p:nvSpPr>
-          <p:cNvPr id="16" name="f-1"/>
-          <p:cNvSpPr/>
-          <p:nvPr/>
-        </p:nvSpPr>
-        <p:spPr>
-          <a:xfrm>
-            <a:off x="594360" y="4599432"/>
-            <a:ext cx="292608" cy="292608"/>
-          </a:xfrm>
-          <a:prstGeom prst="ellipse">
-            <a:avLst/>
-          </a:prstGeom>
-          <a:solidFill>
-            <a:schemeClr val="accent2"/>
-          </a:solidFill>
-          <a:ln/>
-        </p:spPr>
-      </p:sp>
-      <p:sp>
-        <p:nvSpPr>
-          <p:cNvPr id="17" name="Text 15"/>
-          <p:cNvSpPr txBox="1"/>
-          <p:nvPr/>
-        </p:nvSpPr>
-        <p:spPr>
-          <a:xfrm>
-            <a:off x="1051560" y="4434840"/>
-            <a:ext cx="10515600" cy="640080"/>
-          </a:xfrm>
-          <a:prstGeom prst="rect">
-            <a:avLst/>
-          </a:prstGeom>
-          <a:noFill/>
-          <a:ln/>
-        </p:spPr>
-        <p:txBody>
-          <a:bodyPr wrap="square" lIns="0" tIns="0" rIns="0" bIns="0" rtlCol="0" anchor="ctr"/>
-          <a:lstStyle/>
-          <a:p>
-            <a:pPr indent="0" marL="0">
-              <a:buNone/>
-            </a:pPr>
-            <a:r>
-              <a:rPr lang="en-US" sz="2000" dirty="0">
-                <a:solidFill>
-                  <a:schemeClr val="tx1"/>
-                </a:solidFill>
-              </a:rPr>
-              <a:t>Photon carries the same squad into iMessage.</a:t>
-            </a:r>
-            <a:endParaRPr lang="en-US" sz="2000" dirty="0"/>
-          </a:p>
-        </p:txBody>
-      </p:sp>
-      <p:sp>
-        <p:nvSpPr>
-          <p:cNvPr id="18" name="f-2"/>
-          <p:cNvSpPr/>
-          <p:nvPr/>
-        </p:nvSpPr>
-        <p:spPr>
-          <a:xfrm>
-            <a:off x="594360" y="5376672"/>
-            <a:ext cx="292608" cy="292608"/>
-          </a:xfrm>
-          <a:prstGeom prst="ellipse">
-            <a:avLst/>
-          </a:prstGeom>
-          <a:solidFill>
-            <a:schemeClr val="accent2"/>
-          </a:solidFill>
-          <a:ln/>
-        </p:spPr>
-      </p:sp>
-      <p:sp>
-        <p:nvSpPr>
-          <p:cNvPr id="19" name="Text 17"/>
-          <p:cNvSpPr txBox="1"/>
-          <p:nvPr/>
-        </p:nvSpPr>
-        <p:spPr>
-          <a:xfrm>
-            <a:off x="1051560" y="5212080"/>
-            <a:ext cx="10515600" cy="640080"/>
-          </a:xfrm>
-          <a:prstGeom prst="rect">
-            <a:avLst/>
-          </a:prstGeom>
-          <a:noFill/>
-          <a:ln/>
-        </p:spPr>
-        <p:txBody>
-          <a:bodyPr wrap="square" lIns="0" tIns="0" rIns="0" bIns="0" rtlCol="0" anchor="ctr"/>
-          <a:lstStyle/>
-          <a:p>
-            <a:pPr indent="0" marL="0">
-              <a:buNone/>
-            </a:pPr>
-            <a:r>
-              <a:rPr lang="en-US" sz="2000" dirty="0">
-                <a:solidFill>
-                  <a:schemeClr val="tx1"/>
-                </a:solidFill>
-              </a:rPr>
               <a:t>Designed and iterated in Cursor.</a:t>
             </a:r>
-            <a:endParaRPr lang="en-US" sz="2000" dirty="0"/>
+            <a:endParaRPr lang="en-US" sz="1800" dirty="0"/>
           </a:p>
         </p:txBody>
       </p:sp>
@@ -4478,15 +5081,855 @@
                   <a:schemeClr val="tx1"/>
                 </a:solidFill>
               </a:rPr>
-              <a:t>Walking earns creatures and landmarks</a:t>
+              <a:t>Your adventure continues in iMessage</a:t>
             </a:r>
             <a:endParaRPr lang="en-US" sz="3000" dirty="0"/>
           </a:p>
         </p:txBody>
+      </p:sp>
+      <p:sp>
+        <p:nvSpPr>
+          <p:cNvPr id="3" name="im-0"/>
+          <p:cNvSpPr/>
+          <p:nvPr/>
+        </p:nvSpPr>
+        <p:spPr>
+          <a:xfrm>
+            <a:off x="457200" y="932688"/>
+            <a:ext cx="8092440" cy="1060704"/>
+          </a:xfrm>
+          <a:prstGeom prst="roundRect">
+            <a:avLst>
+              <a:gd name="adj" fmla="val 12069"/>
+            </a:avLst>
+          </a:prstGeom>
+          <a:solidFill>
+            <a:srgbClr val="FFFFFF"/>
+          </a:solidFill>
+          <a:ln/>
+          <a:effectLst>
+            <a:outerShdw sx="100000" sy="100000" kx="0" ky="0" algn="bl" rotWithShape="0" blurRad="101600" dist="25400" dir="5400000">
+              <a:srgbClr val="0B1F3A">
+                <a:alpha val="10000"/>
+              </a:srgbClr>
+            </a:outerShdw>
+          </a:effectLst>
+        </p:spPr>
+      </p:sp>
+      <p:sp>
+        <p:nvSpPr>
+          <p:cNvPr id="4" name="im-n-0"/>
+          <p:cNvSpPr/>
+          <p:nvPr/>
+        </p:nvSpPr>
+        <p:spPr>
+          <a:xfrm>
+            <a:off x="640080" y="1188720"/>
+            <a:ext cx="530352" cy="530352"/>
+          </a:xfrm>
+          <a:prstGeom prst="ellipse">
+            <a:avLst/>
+          </a:prstGeom>
+          <a:solidFill>
+            <a:schemeClr val="accent1"/>
+          </a:solidFill>
+          <a:ln/>
+        </p:spPr>
+      </p:sp>
+      <p:sp>
+        <p:nvSpPr>
+          <p:cNvPr id="5" name="Text 3"/>
+          <p:cNvSpPr txBox="1"/>
+          <p:nvPr/>
+        </p:nvSpPr>
+        <p:spPr>
+          <a:xfrm>
+            <a:off x="640080" y="1243584"/>
+            <a:ext cx="530352" cy="420624"/>
+          </a:xfrm>
+          <a:prstGeom prst="rect">
+            <a:avLst/>
+          </a:prstGeom>
+          <a:noFill/>
+          <a:ln/>
+        </p:spPr>
+        <p:txBody>
+          <a:bodyPr wrap="square" lIns="0" tIns="0" rIns="0" bIns="0" rtlCol="0" anchor="ctr"/>
+          <a:lstStyle/>
+          <a:p>
+            <a:pPr algn="ctr" indent="0" marL="0">
+              <a:buNone/>
+            </a:pPr>
+            <a:r>
+              <a:rPr lang="en-US" sz="1600" b="1" dirty="0">
+                <a:solidFill>
+                  <a:srgbClr val="FFFFFF"/>
+                </a:solidFill>
+              </a:rPr>
+              <a:t>1</a:t>
+            </a:r>
+            <a:endParaRPr lang="en-US" sz="1600" dirty="0"/>
+          </a:p>
+        </p:txBody>
+      </p:sp>
+      <p:sp>
+        <p:nvSpPr>
+          <p:cNvPr id="6" name="Text 4"/>
+          <p:cNvSpPr txBox="1"/>
+          <p:nvPr/>
+        </p:nvSpPr>
+        <p:spPr>
+          <a:xfrm>
+            <a:off x="1371600" y="1042416"/>
+            <a:ext cx="6949440" cy="329184"/>
+          </a:xfrm>
+          <a:prstGeom prst="rect">
+            <a:avLst/>
+          </a:prstGeom>
+          <a:noFill/>
+          <a:ln/>
+        </p:spPr>
+        <p:txBody>
+          <a:bodyPr wrap="square" lIns="0" tIns="0" rIns="0" bIns="0" rtlCol="0" anchor="ctr"/>
+          <a:lstStyle/>
+          <a:p>
+            <a:pPr indent="0" marL="0">
+              <a:buNone/>
+            </a:pPr>
+            <a:r>
+              <a:rPr lang="en-US" sz="1800" b="1" dirty="0">
+                <a:solidFill>
+                  <a:schemeClr val="tx1"/>
+                </a:solidFill>
+              </a:rPr>
+              <a:t>Text the squad</a:t>
+            </a:r>
+            <a:endParaRPr lang="en-US" sz="1800" dirty="0"/>
+          </a:p>
+        </p:txBody>
+      </p:sp>
+      <p:sp>
+        <p:nvSpPr>
+          <p:cNvPr id="7" name="Text 5"/>
+          <p:cNvSpPr txBox="1"/>
+          <p:nvPr/>
+        </p:nvSpPr>
+        <p:spPr>
+          <a:xfrm>
+            <a:off x="1371600" y="1389888"/>
+            <a:ext cx="6949440" cy="475488"/>
+          </a:xfrm>
+          <a:prstGeom prst="rect">
+            <a:avLst/>
+          </a:prstGeom>
+          <a:noFill/>
+          <a:ln/>
+        </p:spPr>
+        <p:txBody>
+          <a:bodyPr wrap="square" lIns="0" tIns="0" rIns="0" bIns="0" rtlCol="0" anchor="ctr"/>
+          <a:lstStyle/>
+          <a:p>
+            <a:pPr indent="0" marL="0">
+              <a:buNone/>
+            </a:pPr>
+            <a:r>
+              <a:rPr lang="en-US" sz="1500" dirty="0">
+                <a:solidFill>
+                  <a:schemeClr val="accent6"/>
+                </a:solidFill>
+              </a:rPr>
+              <a:t>Explore nearby landmarks, hear stories, and get walking directions.</a:t>
+            </a:r>
+            <a:endParaRPr lang="en-US" sz="1500" dirty="0"/>
+          </a:p>
+        </p:txBody>
+      </p:sp>
+      <p:sp>
+        <p:nvSpPr>
+          <p:cNvPr id="8" name="im-1"/>
+          <p:cNvSpPr/>
+          <p:nvPr/>
+        </p:nvSpPr>
+        <p:spPr>
+          <a:xfrm>
+            <a:off x="457200" y="2103120"/>
+            <a:ext cx="8092440" cy="1060704"/>
+          </a:xfrm>
+          <a:prstGeom prst="roundRect">
+            <a:avLst>
+              <a:gd name="adj" fmla="val 12069"/>
+            </a:avLst>
+          </a:prstGeom>
+          <a:solidFill>
+            <a:srgbClr val="FFFFFF"/>
+          </a:solidFill>
+          <a:ln/>
+          <a:effectLst>
+            <a:outerShdw sx="100000" sy="100000" kx="0" ky="0" algn="bl" rotWithShape="0" blurRad="101600" dist="25400" dir="5400000">
+              <a:srgbClr val="0B1F3A">
+                <a:alpha val="10000"/>
+              </a:srgbClr>
+            </a:outerShdw>
+          </a:effectLst>
+        </p:spPr>
+      </p:sp>
+      <p:sp>
+        <p:nvSpPr>
+          <p:cNvPr id="9" name="im-n-1"/>
+          <p:cNvSpPr/>
+          <p:nvPr/>
+        </p:nvSpPr>
+        <p:spPr>
+          <a:xfrm>
+            <a:off x="640080" y="2359152"/>
+            <a:ext cx="530352" cy="530352"/>
+          </a:xfrm>
+          <a:prstGeom prst="ellipse">
+            <a:avLst/>
+          </a:prstGeom>
+          <a:solidFill>
+            <a:schemeClr val="accent1"/>
+          </a:solidFill>
+          <a:ln/>
+        </p:spPr>
+      </p:sp>
+      <p:sp>
+        <p:nvSpPr>
+          <p:cNvPr id="10" name="Text 8"/>
+          <p:cNvSpPr txBox="1"/>
+          <p:nvPr/>
+        </p:nvSpPr>
+        <p:spPr>
+          <a:xfrm>
+            <a:off x="640080" y="2414016"/>
+            <a:ext cx="530352" cy="420624"/>
+          </a:xfrm>
+          <a:prstGeom prst="rect">
+            <a:avLst/>
+          </a:prstGeom>
+          <a:noFill/>
+          <a:ln/>
+        </p:spPr>
+        <p:txBody>
+          <a:bodyPr wrap="square" lIns="0" tIns="0" rIns="0" bIns="0" rtlCol="0" anchor="ctr"/>
+          <a:lstStyle/>
+          <a:p>
+            <a:pPr algn="ctr" indent="0" marL="0">
+              <a:buNone/>
+            </a:pPr>
+            <a:r>
+              <a:rPr lang="en-US" sz="1600" b="1" dirty="0">
+                <a:solidFill>
+                  <a:srgbClr val="FFFFFF"/>
+                </a:solidFill>
+              </a:rPr>
+              <a:t>2</a:t>
+            </a:r>
+            <a:endParaRPr lang="en-US" sz="1600" dirty="0"/>
+          </a:p>
+        </p:txBody>
+      </p:sp>
+      <p:sp>
+        <p:nvSpPr>
+          <p:cNvPr id="11" name="Text 9"/>
+          <p:cNvSpPr txBox="1"/>
+          <p:nvPr/>
+        </p:nvSpPr>
+        <p:spPr>
+          <a:xfrm>
+            <a:off x="1371600" y="2212848"/>
+            <a:ext cx="6949440" cy="329184"/>
+          </a:xfrm>
+          <a:prstGeom prst="rect">
+            <a:avLst/>
+          </a:prstGeom>
+          <a:noFill/>
+          <a:ln/>
+        </p:spPr>
+        <p:txBody>
+          <a:bodyPr wrap="square" lIns="0" tIns="0" rIns="0" bIns="0" rtlCol="0" anchor="ctr"/>
+          <a:lstStyle/>
+          <a:p>
+            <a:pPr indent="0" marL="0">
+              <a:buNone/>
+            </a:pPr>
+            <a:r>
+              <a:rPr lang="en-US" sz="1800" b="1" dirty="0">
+                <a:solidFill>
+                  <a:schemeClr val="tx1"/>
+                </a:solidFill>
+              </a:rPr>
+              <a:t>Updates from the walk</a:t>
+            </a:r>
+            <a:endParaRPr lang="en-US" sz="1800" dirty="0"/>
+          </a:p>
+        </p:txBody>
+      </p:sp>
+      <p:sp>
+        <p:nvSpPr>
+          <p:cNvPr id="12" name="Text 10"/>
+          <p:cNvSpPr txBox="1"/>
+          <p:nvPr/>
+        </p:nvSpPr>
+        <p:spPr>
+          <a:xfrm>
+            <a:off x="1371600" y="2560320"/>
+            <a:ext cx="6949440" cy="475488"/>
+          </a:xfrm>
+          <a:prstGeom prst="rect">
+            <a:avLst/>
+          </a:prstGeom>
+          <a:noFill/>
+          <a:ln/>
+        </p:spPr>
+        <p:txBody>
+          <a:bodyPr wrap="square" lIns="0" tIns="0" rIns="0" bIns="0" rtlCol="0" anchor="ctr"/>
+          <a:lstStyle/>
+          <a:p>
+            <a:pPr indent="0" marL="0">
+              <a:buNone/>
+            </a:pPr>
+            <a:r>
+              <a:rPr lang="en-US" sz="1500" dirty="0">
+                <a:solidFill>
+                  <a:schemeClr val="accent6"/>
+                </a:solidFill>
+              </a:rPr>
+              <a:t>When the app records a new landmark or a step milestone.</a:t>
+            </a:r>
+            <a:endParaRPr lang="en-US" sz="1500" dirty="0"/>
+          </a:p>
+        </p:txBody>
+      </p:sp>
+      <p:sp>
+        <p:nvSpPr>
+          <p:cNvPr id="13" name="im-2"/>
+          <p:cNvSpPr/>
+          <p:nvPr/>
+        </p:nvSpPr>
+        <p:spPr>
+          <a:xfrm>
+            <a:off x="457200" y="3273552"/>
+            <a:ext cx="8092440" cy="1060704"/>
+          </a:xfrm>
+          <a:prstGeom prst="roundRect">
+            <a:avLst>
+              <a:gd name="adj" fmla="val 12069"/>
+            </a:avLst>
+          </a:prstGeom>
+          <a:solidFill>
+            <a:srgbClr val="FFFFFF"/>
+          </a:solidFill>
+          <a:ln/>
+          <a:effectLst>
+            <a:outerShdw sx="100000" sy="100000" kx="0" ky="0" algn="bl" rotWithShape="0" blurRad="101600" dist="25400" dir="5400000">
+              <a:srgbClr val="0B1F3A">
+                <a:alpha val="10000"/>
+              </a:srgbClr>
+            </a:outerShdw>
+          </a:effectLst>
+        </p:spPr>
+      </p:sp>
+      <p:sp>
+        <p:nvSpPr>
+          <p:cNvPr id="14" name="im-n-2"/>
+          <p:cNvSpPr/>
+          <p:nvPr/>
+        </p:nvSpPr>
+        <p:spPr>
+          <a:xfrm>
+            <a:off x="640080" y="3529584"/>
+            <a:ext cx="530352" cy="530352"/>
+          </a:xfrm>
+          <a:prstGeom prst="ellipse">
+            <a:avLst/>
+          </a:prstGeom>
+          <a:solidFill>
+            <a:schemeClr val="accent1"/>
+          </a:solidFill>
+          <a:ln/>
+        </p:spPr>
+      </p:sp>
+      <p:sp>
+        <p:nvSpPr>
+          <p:cNvPr id="15" name="Text 13"/>
+          <p:cNvSpPr txBox="1"/>
+          <p:nvPr/>
+        </p:nvSpPr>
+        <p:spPr>
+          <a:xfrm>
+            <a:off x="640080" y="3584448"/>
+            <a:ext cx="530352" cy="420624"/>
+          </a:xfrm>
+          <a:prstGeom prst="rect">
+            <a:avLst/>
+          </a:prstGeom>
+          <a:noFill/>
+          <a:ln/>
+        </p:spPr>
+        <p:txBody>
+          <a:bodyPr wrap="square" lIns="0" tIns="0" rIns="0" bIns="0" rtlCol="0" anchor="ctr"/>
+          <a:lstStyle/>
+          <a:p>
+            <a:pPr algn="ctr" indent="0" marL="0">
+              <a:buNone/>
+            </a:pPr>
+            <a:r>
+              <a:rPr lang="en-US" sz="1600" b="1" dirty="0">
+                <a:solidFill>
+                  <a:srgbClr val="FFFFFF"/>
+                </a:solidFill>
+              </a:rPr>
+              <a:t>3</a:t>
+            </a:r>
+            <a:endParaRPr lang="en-US" sz="1600" dirty="0"/>
+          </a:p>
+        </p:txBody>
+      </p:sp>
+      <p:sp>
+        <p:nvSpPr>
+          <p:cNvPr id="16" name="Text 14"/>
+          <p:cNvSpPr txBox="1"/>
+          <p:nvPr/>
+        </p:nvSpPr>
+        <p:spPr>
+          <a:xfrm>
+            <a:off x="1371600" y="3383280"/>
+            <a:ext cx="6949440" cy="329184"/>
+          </a:xfrm>
+          <a:prstGeom prst="rect">
+            <a:avLst/>
+          </a:prstGeom>
+          <a:noFill/>
+          <a:ln/>
+        </p:spPr>
+        <p:txBody>
+          <a:bodyPr wrap="square" lIns="0" tIns="0" rIns="0" bIns="0" rtlCol="0" anchor="ctr"/>
+          <a:lstStyle/>
+          <a:p>
+            <a:pPr indent="0" marL="0">
+              <a:buNone/>
+            </a:pPr>
+            <a:r>
+              <a:rPr lang="en-US" sz="1800" b="1" dirty="0">
+                <a:solidFill>
+                  <a:schemeClr val="tx1"/>
+                </a:solidFill>
+              </a:rPr>
+              <a:t>Photon Spectrum</a:t>
+            </a:r>
+            <a:endParaRPr lang="en-US" sz="1800" dirty="0"/>
+          </a:p>
+        </p:txBody>
+      </p:sp>
+      <p:sp>
+        <p:nvSpPr>
+          <p:cNvPr id="17" name="Text 15"/>
+          <p:cNvSpPr txBox="1"/>
+          <p:nvPr/>
+        </p:nvSpPr>
+        <p:spPr>
+          <a:xfrm>
+            <a:off x="1371600" y="3730752"/>
+            <a:ext cx="6949440" cy="475488"/>
+          </a:xfrm>
+          <a:prstGeom prst="rect">
+            <a:avLst/>
+          </a:prstGeom>
+          <a:noFill/>
+          <a:ln/>
+        </p:spPr>
+        <p:txBody>
+          <a:bodyPr wrap="square" lIns="0" tIns="0" rIns="0" bIns="0" rtlCol="0" anchor="ctr"/>
+          <a:lstStyle/>
+          <a:p>
+            <a:pPr indent="0" marL="0">
+              <a:buNone/>
+            </a:pPr>
+            <a:r>
+              <a:rPr lang="en-US" sz="1500" dirty="0">
+                <a:solidFill>
+                  <a:schemeClr val="accent6"/>
+                </a:solidFill>
+              </a:rPr>
+              <a:t>Same game logic as the phone. Scout, Storyteller, and Pathfinder are roles.</a:t>
+            </a:r>
+            <a:endParaRPr lang="en-US" sz="1500" dirty="0"/>
+          </a:p>
+        </p:txBody>
+      </p:sp>
+      <p:sp>
+        <p:nvSpPr>
+          <p:cNvPr id="18" name="seq-card"/>
+          <p:cNvSpPr/>
+          <p:nvPr/>
+        </p:nvSpPr>
+        <p:spPr>
+          <a:xfrm>
+            <a:off x="457200" y="4480560"/>
+            <a:ext cx="8092440" cy="1554480"/>
+          </a:xfrm>
+          <a:prstGeom prst="roundRect">
+            <a:avLst>
+              <a:gd name="adj" fmla="val 8235"/>
+            </a:avLst>
+          </a:prstGeom>
+          <a:solidFill>
+            <a:srgbClr val="FFFFFF"/>
+          </a:solidFill>
+          <a:ln/>
+          <a:effectLst>
+            <a:outerShdw sx="100000" sy="100000" kx="0" ky="0" algn="bl" rotWithShape="0" blurRad="101600" dist="25400" dir="5400000">
+              <a:srgbClr val="0B1F3A">
+                <a:alpha val="10000"/>
+              </a:srgbClr>
+            </a:outerShdw>
+          </a:effectLst>
+        </p:spPr>
+      </p:sp>
+      <p:sp>
+        <p:nvSpPr>
+          <p:cNvPr id="19" name="Text 17"/>
+          <p:cNvSpPr txBox="1"/>
+          <p:nvPr/>
+        </p:nvSpPr>
+        <p:spPr>
+          <a:xfrm>
+            <a:off x="640080" y="4590288"/>
+            <a:ext cx="7726680" cy="292608"/>
+          </a:xfrm>
+          <a:prstGeom prst="rect">
+            <a:avLst/>
+          </a:prstGeom>
+          <a:noFill/>
+          <a:ln/>
+        </p:spPr>
+        <p:txBody>
+          <a:bodyPr wrap="square" lIns="0" tIns="0" rIns="0" bIns="0" rtlCol="0" anchor="ctr"/>
+          <a:lstStyle/>
+          <a:p>
+            <a:pPr indent="0" marL="0">
+              <a:buNone/>
+            </a:pPr>
+            <a:r>
+              <a:rPr lang="en-US" sz="1400" b="1" dirty="0">
+                <a:solidFill>
+                  <a:schemeClr val="tx1"/>
+                </a:solidFill>
+              </a:rPr>
+              <a:t>A supported sequence</a:t>
+            </a:r>
+            <a:endParaRPr lang="en-US" sz="1400" dirty="0"/>
+          </a:p>
+        </p:txBody>
+      </p:sp>
+      <p:sp>
+        <p:nvSpPr>
+          <p:cNvPr id="20" name="cmd-0"/>
+          <p:cNvSpPr/>
+          <p:nvPr/>
+        </p:nvSpPr>
+        <p:spPr>
+          <a:xfrm>
+            <a:off x="640080" y="4937760"/>
+            <a:ext cx="2148840" cy="438912"/>
+          </a:xfrm>
+          <a:prstGeom prst="roundRect">
+            <a:avLst>
+              <a:gd name="adj" fmla="val 20833"/>
+            </a:avLst>
+          </a:prstGeom>
+          <a:solidFill>
+            <a:srgbClr val="0B1F3A"/>
+          </a:solidFill>
+          <a:ln/>
+        </p:spPr>
+      </p:sp>
+      <p:sp>
+        <p:nvSpPr>
+          <p:cNvPr id="21" name="Text 19"/>
+          <p:cNvSpPr txBox="1"/>
+          <p:nvPr/>
+        </p:nvSpPr>
+        <p:spPr>
+          <a:xfrm>
+            <a:off x="640080" y="4992624"/>
+            <a:ext cx="2148840" cy="329184"/>
+          </a:xfrm>
+          <a:prstGeom prst="rect">
+            <a:avLst/>
+          </a:prstGeom>
+          <a:noFill/>
+          <a:ln/>
+        </p:spPr>
+        <p:txBody>
+          <a:bodyPr wrap="square" lIns="0" tIns="0" rIns="0" bIns="0" rtlCol="0" anchor="ctr"/>
+          <a:lstStyle/>
+          <a:p>
+            <a:pPr algn="ctr" indent="0" marL="0">
+              <a:buNone/>
+            </a:pPr>
+            <a:r>
+              <a:rPr lang="en-US" sz="1400" b="1" dirty="0">
+                <a:solidFill>
+                  <a:srgbClr val="FFFFFF"/>
+                </a:solidFill>
+              </a:rPr>
+              <a:t>explore</a:t>
+            </a:r>
+            <a:endParaRPr lang="en-US" sz="1400" dirty="0"/>
+          </a:p>
+        </p:txBody>
+      </p:sp>
+      <p:sp>
+        <p:nvSpPr>
+          <p:cNvPr id="22" name="Text 20"/>
+          <p:cNvSpPr txBox="1"/>
+          <p:nvPr/>
+        </p:nvSpPr>
+        <p:spPr>
+          <a:xfrm>
+            <a:off x="2724912" y="4974336"/>
+            <a:ext cx="502920" cy="365760"/>
+          </a:xfrm>
+          <a:prstGeom prst="rect">
+            <a:avLst/>
+          </a:prstGeom>
+          <a:noFill/>
+          <a:ln/>
+        </p:spPr>
+        <p:txBody>
+          <a:bodyPr wrap="square" lIns="0" tIns="0" rIns="0" bIns="0" rtlCol="0" anchor="ctr"/>
+          <a:lstStyle/>
+          <a:p>
+            <a:pPr algn="ctr" indent="0" marL="0">
+              <a:buNone/>
+            </a:pPr>
+            <a:r>
+              <a:rPr lang="en-US" sz="1600" b="1" dirty="0">
+                <a:solidFill>
+                  <a:schemeClr val="accent1"/>
+                </a:solidFill>
+              </a:rPr>
+              <a:t>→</a:t>
+            </a:r>
+            <a:endParaRPr lang="en-US" sz="1600" dirty="0"/>
+          </a:p>
+        </p:txBody>
+      </p:sp>
+      <p:sp>
+        <p:nvSpPr>
+          <p:cNvPr id="23" name="cmd-1"/>
+          <p:cNvSpPr/>
+          <p:nvPr/>
+        </p:nvSpPr>
+        <p:spPr>
+          <a:xfrm>
+            <a:off x="3246120" y="4937760"/>
+            <a:ext cx="2148840" cy="438912"/>
+          </a:xfrm>
+          <a:prstGeom prst="roundRect">
+            <a:avLst>
+              <a:gd name="adj" fmla="val 20833"/>
+            </a:avLst>
+          </a:prstGeom>
+          <a:solidFill>
+            <a:srgbClr val="0B1F3A"/>
+          </a:solidFill>
+          <a:ln/>
+        </p:spPr>
+      </p:sp>
+      <p:sp>
+        <p:nvSpPr>
+          <p:cNvPr id="24" name="Text 22"/>
+          <p:cNvSpPr txBox="1"/>
+          <p:nvPr/>
+        </p:nvSpPr>
+        <p:spPr>
+          <a:xfrm>
+            <a:off x="3246120" y="4992624"/>
+            <a:ext cx="2148840" cy="329184"/>
+          </a:xfrm>
+          <a:prstGeom prst="rect">
+            <a:avLst/>
+          </a:prstGeom>
+          <a:noFill/>
+          <a:ln/>
+        </p:spPr>
+        <p:txBody>
+          <a:bodyPr wrap="square" lIns="0" tIns="0" rIns="0" bIns="0" rtlCol="0" anchor="ctr"/>
+          <a:lstStyle/>
+          <a:p>
+            <a:pPr algn="ctr" indent="0" marL="0">
+              <a:buNone/>
+            </a:pPr>
+            <a:r>
+              <a:rPr lang="en-US" sz="1400" b="1" dirty="0">
+                <a:solidFill>
+                  <a:srgbClr val="FFFFFF"/>
+                </a:solidFill>
+              </a:rPr>
+              <a:t>take me there</a:t>
+            </a:r>
+            <a:endParaRPr lang="en-US" sz="1400" dirty="0"/>
+          </a:p>
+        </p:txBody>
+      </p:sp>
+      <p:sp>
+        <p:nvSpPr>
+          <p:cNvPr id="25" name="Text 23"/>
+          <p:cNvSpPr txBox="1"/>
+          <p:nvPr/>
+        </p:nvSpPr>
+        <p:spPr>
+          <a:xfrm>
+            <a:off x="5330952" y="4974336"/>
+            <a:ext cx="502920" cy="365760"/>
+          </a:xfrm>
+          <a:prstGeom prst="rect">
+            <a:avLst/>
+          </a:prstGeom>
+          <a:noFill/>
+          <a:ln/>
+        </p:spPr>
+        <p:txBody>
+          <a:bodyPr wrap="square" lIns="0" tIns="0" rIns="0" bIns="0" rtlCol="0" anchor="ctr"/>
+          <a:lstStyle/>
+          <a:p>
+            <a:pPr algn="ctr" indent="0" marL="0">
+              <a:buNone/>
+            </a:pPr>
+            <a:r>
+              <a:rPr lang="en-US" sz="1600" b="1" dirty="0">
+                <a:solidFill>
+                  <a:schemeClr val="accent1"/>
+                </a:solidFill>
+              </a:rPr>
+              <a:t>→</a:t>
+            </a:r>
+            <a:endParaRPr lang="en-US" sz="1600" dirty="0"/>
+          </a:p>
+        </p:txBody>
+      </p:sp>
+      <p:sp>
+        <p:nvSpPr>
+          <p:cNvPr id="26" name="cmd-2"/>
+          <p:cNvSpPr/>
+          <p:nvPr/>
+        </p:nvSpPr>
+        <p:spPr>
+          <a:xfrm>
+            <a:off x="5852160" y="4937760"/>
+            <a:ext cx="2148840" cy="438912"/>
+          </a:xfrm>
+          <a:prstGeom prst="roundRect">
+            <a:avLst>
+              <a:gd name="adj" fmla="val 20833"/>
+            </a:avLst>
+          </a:prstGeom>
+          <a:solidFill>
+            <a:srgbClr val="0B1F3A"/>
+          </a:solidFill>
+          <a:ln/>
+        </p:spPr>
+      </p:sp>
+      <p:sp>
+        <p:nvSpPr>
+          <p:cNvPr id="27" name="Text 25"/>
+          <p:cNvSpPr txBox="1"/>
+          <p:nvPr/>
+        </p:nvSpPr>
+        <p:spPr>
+          <a:xfrm>
+            <a:off x="5852160" y="4992624"/>
+            <a:ext cx="2148840" cy="329184"/>
+          </a:xfrm>
+          <a:prstGeom prst="rect">
+            <a:avLst/>
+          </a:prstGeom>
+          <a:noFill/>
+          <a:ln/>
+        </p:spPr>
+        <p:txBody>
+          <a:bodyPr wrap="square" lIns="0" tIns="0" rIns="0" bIns="0" rtlCol="0" anchor="ctr"/>
+          <a:lstStyle/>
+          <a:p>
+            <a:pPr algn="ctr" indent="0" marL="0">
+              <a:buNone/>
+            </a:pPr>
+            <a:r>
+              <a:rPr lang="en-US" sz="1400" b="1" dirty="0">
+                <a:solidFill>
+                  <a:srgbClr val="FFFFFF"/>
+                </a:solidFill>
+              </a:rPr>
+              <a:t>arrived</a:t>
+            </a:r>
+            <a:endParaRPr lang="en-US" sz="1400" dirty="0"/>
+          </a:p>
+        </p:txBody>
+      </p:sp>
+      <p:sp>
+        <p:nvSpPr>
+          <p:cNvPr id="28" name="Text 26"/>
+          <p:cNvSpPr txBox="1"/>
+          <p:nvPr/>
+        </p:nvSpPr>
+        <p:spPr>
+          <a:xfrm>
+            <a:off x="640080" y="5504688"/>
+            <a:ext cx="7726680" cy="365760"/>
+          </a:xfrm>
+          <a:prstGeom prst="rect">
+            <a:avLst/>
+          </a:prstGeom>
+          <a:noFill/>
+          <a:ln/>
+        </p:spPr>
+        <p:txBody>
+          <a:bodyPr wrap="square" lIns="0" tIns="0" rIns="0" bIns="0" rtlCol="0" anchor="ctr"/>
+          <a:lstStyle/>
+          <a:p>
+            <a:pPr indent="0" marL="0">
+              <a:buNone/>
+            </a:pPr>
+            <a:r>
+              <a:rPr lang="en-US" sz="1300" dirty="0">
+                <a:solidFill>
+                  <a:schemeClr val="accent6"/>
+                </a:solidFill>
+              </a:rPr>
+              <a:t>Tested in the companion. Milestone texts are built; live iMessage delivery is not verified.</a:t>
+            </a:r>
+            <a:endParaRPr lang="en-US" sz="1300" dirty="0"/>
+          </a:p>
+        </p:txBody>
+      </p:sp>
+      <p:sp>
+        <p:nvSpPr>
+          <p:cNvPr id="29" name="imessage-shot-frame"/>
+          <p:cNvSpPr/>
+          <p:nvPr/>
+        </p:nvSpPr>
+        <p:spPr>
+          <a:xfrm>
+            <a:off x="8933688" y="886968"/>
+            <a:ext cx="2391674" cy="5038344"/>
+          </a:xfrm>
+          <a:prstGeom prst="roundRect">
+            <a:avLst>
+              <a:gd name="adj" fmla="val 6882"/>
+            </a:avLst>
+          </a:prstGeom>
+          <a:solidFill>
+            <a:srgbClr val="0B1F3A"/>
+          </a:solidFill>
+          <a:ln/>
+        </p:spPr>
       </p:sp>
       <p:pic>
         <p:nvPicPr>
-          <p:cNvPr id="3" name="egg" descr="G:\broswer download\big-red-hacks2026\docs\presentation\app_images\C2EA70B0-0CD6-4D92-AAFE-8EC1C33A2133.jpg">    </p:cNvPr>
+          <p:cNvPr id="30" name="imessage-shot" descr="G:\broswer download\big-red-hacks2026\docs\presentation\app_images\imessage-pip-explore.jpg">    </p:cNvPr>
           <p:cNvPicPr>
             <a:picLocks noChangeAspect="1"/>
           </p:cNvPicPr>
@@ -4500,276 +5943,47 @@
         </p:blipFill>
         <p:spPr>
           <a:xfrm>
-            <a:off x="411480" y="960120"/>
-            <a:ext cx="3246120" cy="2877365"/>
+            <a:off x="9006840" y="960120"/>
+            <a:ext cx="2245370" cy="4892040"/>
           </a:xfrm>
           <a:prstGeom prst="rect">
             <a:avLst/>
           </a:prstGeom>
         </p:spPr>
       </p:pic>
-      <p:pic>
-        <p:nvPicPr>
-          <p:cNvPr id="4" name="mochi" descr="G:\broswer download\big-red-hacks2026\docs\presentation\app_images\0B82DD1F-6522-46CD-8774-F7C4336505D4.jpg">    </p:cNvPr>
-          <p:cNvPicPr>
-            <a:picLocks noChangeAspect="1"/>
-          </p:cNvPicPr>
-          <p:nvPr/>
-        </p:nvPicPr>
-        <p:blipFill>
-          <a:blip r:embed="rId2"/>
-          <a:stretch>
-            <a:fillRect/>
-          </a:stretch>
-        </p:blipFill>
-        <p:spPr>
-          <a:xfrm>
-            <a:off x="3794760" y="960120"/>
-            <a:ext cx="3063240" cy="3807460"/>
-          </a:xfrm>
-          <a:prstGeom prst="rect">
-            <a:avLst/>
-          </a:prstGeom>
-        </p:spPr>
-      </p:pic>
-      <p:sp>
-        <p:nvSpPr>
-          <p:cNvPr id="5" name="captured-frame"/>
-          <p:cNvSpPr/>
-          <p:nvPr/>
-        </p:nvSpPr>
-        <p:spPr>
-          <a:xfrm>
-            <a:off x="6967728" y="886968"/>
-            <a:ext cx="2420049" cy="4352544"/>
-          </a:xfrm>
-          <a:prstGeom prst="roundRect">
-            <a:avLst>
-              <a:gd name="adj" fmla="val 6801"/>
-            </a:avLst>
-          </a:prstGeom>
-          <a:solidFill>
-            <a:srgbClr val="0B1F3A"/>
-          </a:solidFill>
-          <a:ln/>
-        </p:spPr>
-      </p:sp>
-      <p:pic>
-        <p:nvPicPr>
-          <p:cNvPr id="6" name="captured" descr="G:\broswer download\big-red-hacks2026\docs\presentation\app_images\D8BE4252-56A8-4B93-B944-9D82B404BB87.jpg">    </p:cNvPr>
-          <p:cNvPicPr>
-            <a:picLocks noChangeAspect="1"/>
-          </p:cNvPicPr>
-          <p:nvPr/>
-        </p:nvPicPr>
-        <p:blipFill>
-          <a:blip r:embed="rId3"/>
-          <a:stretch>
-            <a:fillRect/>
-          </a:stretch>
-        </p:blipFill>
-        <p:spPr>
-          <a:xfrm>
-            <a:off x="7040880" y="960120"/>
-            <a:ext cx="2273745" cy="4206240"/>
-          </a:xfrm>
-          <a:prstGeom prst="rect">
-            <a:avLst/>
-          </a:prstGeom>
-        </p:spPr>
-      </p:pic>
-      <p:sp>
-        <p:nvSpPr>
-          <p:cNvPr id="7" name="egg-c"/>
-          <p:cNvSpPr/>
-          <p:nvPr/>
-        </p:nvSpPr>
-        <p:spPr>
-          <a:xfrm>
-            <a:off x="411480" y="3947213"/>
-            <a:ext cx="3246120" cy="1051560"/>
-          </a:xfrm>
-          <a:prstGeom prst="roundRect">
-            <a:avLst>
-              <a:gd name="adj" fmla="val 12174"/>
-            </a:avLst>
-          </a:prstGeom>
-          <a:solidFill>
-            <a:srgbClr val="FFFFFF"/>
-          </a:solidFill>
-          <a:ln/>
-          <a:effectLst>
-            <a:outerShdw sx="100000" sy="100000" kx="0" ky="0" algn="bl" rotWithShape="0" blurRad="101600" dist="25400" dir="5400000">
-              <a:srgbClr val="0B1F3A">
-                <a:alpha val="10000"/>
-              </a:srgbClr>
-            </a:outerShdw>
-          </a:effectLst>
-        </p:spPr>
-      </p:sp>
-      <p:sp>
-        <p:nvSpPr>
-          <p:cNvPr id="8" name="Text 3"/>
-          <p:cNvSpPr txBox="1"/>
-          <p:nvPr/>
-        </p:nvSpPr>
-        <p:spPr>
-          <a:xfrm>
-            <a:off x="539496" y="4020365"/>
-            <a:ext cx="2990088" cy="905256"/>
-          </a:xfrm>
-          <a:prstGeom prst="rect">
-            <a:avLst/>
-          </a:prstGeom>
-          <a:noFill/>
-          <a:ln/>
-        </p:spPr>
-        <p:txBody>
-          <a:bodyPr wrap="square" lIns="0" tIns="0" rIns="0" bIns="0" rtlCol="0" anchor="ctr"/>
-          <a:lstStyle/>
-          <a:p>
-            <a:pPr indent="0" marL="0">
-              <a:buNone/>
-            </a:pPr>
-            <a:r>
-              <a:rPr lang="en-US" sz="1400" dirty="0">
-                <a:solidFill>
-                  <a:schemeClr val="tx1"/>
-                </a:solidFill>
-              </a:rPr>
-              <a:t>An egg fills as you walk. Demo walks on.</a:t>
-            </a:r>
-            <a:endParaRPr lang="en-US" sz="1400" dirty="0"/>
-          </a:p>
-        </p:txBody>
-      </p:sp>
-      <p:sp>
-        <p:nvSpPr>
-          <p:cNvPr id="9" name="mochi-c"/>
-          <p:cNvSpPr/>
-          <p:nvPr/>
-        </p:nvSpPr>
-        <p:spPr>
-          <a:xfrm>
-            <a:off x="3794760" y="4877308"/>
-            <a:ext cx="3063240" cy="1051560"/>
-          </a:xfrm>
-          <a:prstGeom prst="roundRect">
-            <a:avLst>
-              <a:gd name="adj" fmla="val 12174"/>
-            </a:avLst>
-          </a:prstGeom>
-          <a:solidFill>
-            <a:srgbClr val="FFFFFF"/>
-          </a:solidFill>
-          <a:ln/>
-          <a:effectLst>
-            <a:outerShdw sx="100000" sy="100000" kx="0" ky="0" algn="bl" rotWithShape="0" blurRad="101600" dist="25400" dir="5400000">
-              <a:srgbClr val="0B1F3A">
-                <a:alpha val="10000"/>
-              </a:srgbClr>
-            </a:outerShdw>
-          </a:effectLst>
-        </p:spPr>
-      </p:sp>
-      <p:sp>
-        <p:nvSpPr>
-          <p:cNvPr id="10" name="Text 5"/>
-          <p:cNvSpPr txBox="1"/>
-          <p:nvPr/>
-        </p:nvSpPr>
-        <p:spPr>
-          <a:xfrm>
-            <a:off x="3922776" y="4950460"/>
-            <a:ext cx="2807208" cy="905256"/>
-          </a:xfrm>
-          <a:prstGeom prst="rect">
-            <a:avLst/>
-          </a:prstGeom>
-          <a:noFill/>
-          <a:ln/>
-        </p:spPr>
-        <p:txBody>
-          <a:bodyPr wrap="square" lIns="0" tIns="0" rIns="0" bIns="0" rtlCol="0" anchor="ctr"/>
-          <a:lstStyle/>
-          <a:p>
-            <a:pPr indent="0" marL="0">
-              <a:buNone/>
-            </a:pPr>
-            <a:r>
-              <a:rPr lang="en-US" sz="1400" dirty="0">
-                <a:solidFill>
-                  <a:schemeClr val="tx1"/>
-                </a:solidFill>
-              </a:rPr>
-              <a:t>Meet Mochi — a rare Storyteller from a hatch.</a:t>
-            </a:r>
-            <a:endParaRPr lang="en-US" sz="1400" dirty="0"/>
-          </a:p>
-        </p:txBody>
-      </p:sp>
-      <p:sp>
-        <p:nvSpPr>
-          <p:cNvPr id="11" name="cap-c"/>
-          <p:cNvSpPr/>
-          <p:nvPr/>
-        </p:nvSpPr>
-        <p:spPr>
-          <a:xfrm>
-            <a:off x="7040880" y="5276088"/>
-            <a:ext cx="4663440" cy="640080"/>
-          </a:xfrm>
-          <a:prstGeom prst="roundRect">
-            <a:avLst>
-              <a:gd name="adj" fmla="val 20000"/>
-            </a:avLst>
-          </a:prstGeom>
-          <a:solidFill>
-            <a:srgbClr val="FFFFFF"/>
-          </a:solidFill>
-          <a:ln/>
-          <a:effectLst>
-            <a:outerShdw sx="100000" sy="100000" kx="0" ky="0" algn="bl" rotWithShape="0" blurRad="101600" dist="25400" dir="5400000">
-              <a:srgbClr val="0B1F3A">
-                <a:alpha val="10000"/>
-              </a:srgbClr>
-            </a:outerShdw>
-          </a:effectLst>
-        </p:spPr>
-      </p:sp>
-      <p:sp>
-        <p:nvSpPr>
-          <p:cNvPr id="12" name="Text 7"/>
-          <p:cNvSpPr txBox="1"/>
-          <p:nvPr/>
-        </p:nvSpPr>
-        <p:spPr>
-          <a:xfrm>
-            <a:off x="7168896" y="5349240"/>
-            <a:ext cx="4407408" cy="493776"/>
-          </a:xfrm>
-          <a:prstGeom prst="rect">
-            <a:avLst/>
-          </a:prstGeom>
-          <a:noFill/>
-          <a:ln/>
-        </p:spPr>
-        <p:txBody>
-          <a:bodyPr wrap="square" lIns="0" tIns="0" rIns="0" bIns="0" rtlCol="0" anchor="ctr"/>
-          <a:lstStyle/>
-          <a:p>
-            <a:pPr indent="0" marL="0">
-              <a:buNone/>
-            </a:pPr>
-            <a:r>
-              <a:rPr lang="en-US" sz="1400" dirty="0">
-                <a:solidFill>
-                  <a:schemeClr val="tx1"/>
-                </a:solidFill>
-              </a:rPr>
-              <a:t>Nova holds Bailey Hall.</a:t>
-            </a:r>
-            <a:endParaRPr lang="en-US" sz="1400" dirty="0"/>
+      <p:sp>
+        <p:nvSpPr>
+          <p:cNvPr id="31" name="Text 28"/>
+          <p:cNvSpPr txBox="1"/>
+          <p:nvPr/>
+        </p:nvSpPr>
+        <p:spPr>
+          <a:xfrm>
+            <a:off x="8803645" y="6053328"/>
+            <a:ext cx="2651760" cy="274320"/>
+          </a:xfrm>
+          <a:prstGeom prst="rect">
+            <a:avLst/>
+          </a:prstGeom>
+          <a:noFill/>
+          <a:ln/>
+        </p:spPr>
+        <p:txBody>
+          <a:bodyPr wrap="square" lIns="0" tIns="0" rIns="0" bIns="0" rtlCol="0" anchor="ctr"/>
+          <a:lstStyle/>
+          <a:p>
+            <a:pPr algn="ctr" indent="0" marL="0">
+              <a:buNone/>
+            </a:pPr>
+            <a:r>
+              <a:rPr lang="en-US" sz="1200" dirty="0">
+                <a:solidFill>
+                  <a:schemeClr val="accent6"/>
+                </a:solidFill>
+              </a:rPr>
+              <a:t>Real iMessage · Explore</a:t>
+            </a:r>
+            <a:endParaRPr lang="en-US" sz="1200" dirty="0"/>
           </a:p>
         </p:txBody>
       </p:sp>
@@ -4784,6 +5998,358 @@
 <file path=ppt/slides/slide7.xml><?xml version="1.0" encoding="utf-8"?>
 <p:sld xmlns:a="http://schemas.openxmlformats.org/drawingml/2006/main" xmlns:r="http://schemas.openxmlformats.org/officeDocument/2006/relationships" xmlns:p="http://schemas.openxmlformats.org/presentationml/2006/main">
   <p:cSld name="Slide 7">
+    <p:spTree>
+      <p:nvGrpSpPr>
+        <p:cNvPr id="1" name=""/>
+        <p:cNvGrpSpPr/>
+        <p:nvPr/>
+      </p:nvGrpSpPr>
+      <p:grpSpPr>
+        <a:xfrm>
+          <a:off x="0" y="0"/>
+          <a:ext cx="0" cy="0"/>
+          <a:chOff x="0" y="0"/>
+          <a:chExt cx="0" cy="0"/>
+        </a:xfrm>
+      </p:grpSpPr>
+      <p:sp>
+        <p:nvSpPr>
+          <p:cNvPr id="2" name="Text 0"/>
+          <p:cNvSpPr txBox="1"/>
+          <p:nvPr>
+            <p:ph idx="100" type="title" hasCustomPrompt="1"/>
+          </p:nvPr>
+        </p:nvSpPr>
+        <p:spPr>
+          <a:xfrm>
+            <a:off x="457200" y="201168"/>
+            <a:ext cx="11247120" cy="566928"/>
+          </a:xfrm>
+          <a:prstGeom prst="rect">
+            <a:avLst/>
+          </a:prstGeom>
+          <a:noFill/>
+          <a:ln/>
+        </p:spPr>
+        <p:txBody>
+          <a:bodyPr wrap="square" lIns="0" tIns="0" rIns="0" bIns="0" rtlCol="0" anchor="ctr"/>
+          <a:lstStyle/>
+          <a:p>
+            <a:pPr algn="l" indent="0" marL="0">
+              <a:buNone/>
+            </a:pPr>
+            <a:r>
+              <a:rPr lang="en-US" sz="3000" b="1" dirty="0">
+                <a:solidFill>
+                  <a:schemeClr val="tx1"/>
+                </a:solidFill>
+              </a:rPr>
+              <a:t>Walking earns creatures and landmarks</a:t>
+            </a:r>
+            <a:endParaRPr lang="en-US" sz="3000" dirty="0"/>
+          </a:p>
+        </p:txBody>
+      </p:sp>
+      <p:pic>
+        <p:nvPicPr>
+          <p:cNvPr id="3" name="egg" descr="G:\broswer download\big-red-hacks2026\docs\presentation\app_images\C2EA70B0-0CD6-4D92-AAFE-8EC1C33A2133.jpg">    </p:cNvPr>
+          <p:cNvPicPr>
+            <a:picLocks noChangeAspect="1"/>
+          </p:cNvPicPr>
+          <p:nvPr/>
+        </p:nvPicPr>
+        <p:blipFill>
+          <a:blip r:embed="rId1"/>
+          <a:stretch>
+            <a:fillRect/>
+          </a:stretch>
+        </p:blipFill>
+        <p:spPr>
+          <a:xfrm>
+            <a:off x="411480" y="960120"/>
+            <a:ext cx="3246120" cy="2877365"/>
+          </a:xfrm>
+          <a:prstGeom prst="rect">
+            <a:avLst/>
+          </a:prstGeom>
+        </p:spPr>
+      </p:pic>
+      <p:pic>
+        <p:nvPicPr>
+          <p:cNvPr id="4" name="mochi" descr="G:\broswer download\big-red-hacks2026\docs\presentation\app_images\0B82DD1F-6522-46CD-8774-F7C4336505D4.jpg">    </p:cNvPr>
+          <p:cNvPicPr>
+            <a:picLocks noChangeAspect="1"/>
+          </p:cNvPicPr>
+          <p:nvPr/>
+        </p:nvPicPr>
+        <p:blipFill>
+          <a:blip r:embed="rId2"/>
+          <a:stretch>
+            <a:fillRect/>
+          </a:stretch>
+        </p:blipFill>
+        <p:spPr>
+          <a:xfrm>
+            <a:off x="3794760" y="960120"/>
+            <a:ext cx="3063240" cy="3807460"/>
+          </a:xfrm>
+          <a:prstGeom prst="rect">
+            <a:avLst/>
+          </a:prstGeom>
+        </p:spPr>
+      </p:pic>
+      <p:sp>
+        <p:nvSpPr>
+          <p:cNvPr id="5" name="captured-frame"/>
+          <p:cNvSpPr/>
+          <p:nvPr/>
+        </p:nvSpPr>
+        <p:spPr>
+          <a:xfrm>
+            <a:off x="6967728" y="886968"/>
+            <a:ext cx="2420049" cy="4352544"/>
+          </a:xfrm>
+          <a:prstGeom prst="roundRect">
+            <a:avLst>
+              <a:gd name="adj" fmla="val 6801"/>
+            </a:avLst>
+          </a:prstGeom>
+          <a:solidFill>
+            <a:srgbClr val="0B1F3A"/>
+          </a:solidFill>
+          <a:ln/>
+        </p:spPr>
+      </p:sp>
+      <p:pic>
+        <p:nvPicPr>
+          <p:cNvPr id="6" name="captured" descr="G:\broswer download\big-red-hacks2026\docs\presentation\app_images\D8BE4252-56A8-4B93-B944-9D82B404BB87.jpg">    </p:cNvPr>
+          <p:cNvPicPr>
+            <a:picLocks noChangeAspect="1"/>
+          </p:cNvPicPr>
+          <p:nvPr/>
+        </p:nvPicPr>
+        <p:blipFill>
+          <a:blip r:embed="rId3"/>
+          <a:stretch>
+            <a:fillRect/>
+          </a:stretch>
+        </p:blipFill>
+        <p:spPr>
+          <a:xfrm>
+            <a:off x="7040880" y="960120"/>
+            <a:ext cx="2273745" cy="4206240"/>
+          </a:xfrm>
+          <a:prstGeom prst="rect">
+            <a:avLst/>
+          </a:prstGeom>
+        </p:spPr>
+      </p:pic>
+      <p:sp>
+        <p:nvSpPr>
+          <p:cNvPr id="7" name="egg-c"/>
+          <p:cNvSpPr/>
+          <p:nvPr/>
+        </p:nvSpPr>
+        <p:spPr>
+          <a:xfrm>
+            <a:off x="411480" y="3947213"/>
+            <a:ext cx="3246120" cy="1051560"/>
+          </a:xfrm>
+          <a:prstGeom prst="roundRect">
+            <a:avLst>
+              <a:gd name="adj" fmla="val 12174"/>
+            </a:avLst>
+          </a:prstGeom>
+          <a:solidFill>
+            <a:srgbClr val="FFFFFF"/>
+          </a:solidFill>
+          <a:ln/>
+          <a:effectLst>
+            <a:outerShdw sx="100000" sy="100000" kx="0" ky="0" algn="bl" rotWithShape="0" blurRad="101600" dist="25400" dir="5400000">
+              <a:srgbClr val="0B1F3A">
+                <a:alpha val="10000"/>
+              </a:srgbClr>
+            </a:outerShdw>
+          </a:effectLst>
+        </p:spPr>
+      </p:sp>
+      <p:sp>
+        <p:nvSpPr>
+          <p:cNvPr id="8" name="Text 3"/>
+          <p:cNvSpPr txBox="1"/>
+          <p:nvPr/>
+        </p:nvSpPr>
+        <p:spPr>
+          <a:xfrm>
+            <a:off x="539496" y="4020365"/>
+            <a:ext cx="2990088" cy="905256"/>
+          </a:xfrm>
+          <a:prstGeom prst="rect">
+            <a:avLst/>
+          </a:prstGeom>
+          <a:noFill/>
+          <a:ln/>
+        </p:spPr>
+        <p:txBody>
+          <a:bodyPr wrap="square" lIns="0" tIns="0" rIns="0" bIns="0" rtlCol="0" anchor="ctr"/>
+          <a:lstStyle/>
+          <a:p>
+            <a:pPr indent="0" marL="0">
+              <a:buNone/>
+            </a:pPr>
+            <a:r>
+              <a:rPr lang="en-US" sz="1400" dirty="0">
+                <a:solidFill>
+                  <a:schemeClr val="tx1"/>
+                </a:solidFill>
+              </a:rPr>
+              <a:t>An egg fills as you walk. Demo walks on.</a:t>
+            </a:r>
+            <a:endParaRPr lang="en-US" sz="1400" dirty="0"/>
+          </a:p>
+        </p:txBody>
+      </p:sp>
+      <p:sp>
+        <p:nvSpPr>
+          <p:cNvPr id="9" name="mochi-c"/>
+          <p:cNvSpPr/>
+          <p:nvPr/>
+        </p:nvSpPr>
+        <p:spPr>
+          <a:xfrm>
+            <a:off x="3794760" y="4877308"/>
+            <a:ext cx="3063240" cy="1051560"/>
+          </a:xfrm>
+          <a:prstGeom prst="roundRect">
+            <a:avLst>
+              <a:gd name="adj" fmla="val 12174"/>
+            </a:avLst>
+          </a:prstGeom>
+          <a:solidFill>
+            <a:srgbClr val="FFFFFF"/>
+          </a:solidFill>
+          <a:ln/>
+          <a:effectLst>
+            <a:outerShdw sx="100000" sy="100000" kx="0" ky="0" algn="bl" rotWithShape="0" blurRad="101600" dist="25400" dir="5400000">
+              <a:srgbClr val="0B1F3A">
+                <a:alpha val="10000"/>
+              </a:srgbClr>
+            </a:outerShdw>
+          </a:effectLst>
+        </p:spPr>
+      </p:sp>
+      <p:sp>
+        <p:nvSpPr>
+          <p:cNvPr id="10" name="Text 5"/>
+          <p:cNvSpPr txBox="1"/>
+          <p:nvPr/>
+        </p:nvSpPr>
+        <p:spPr>
+          <a:xfrm>
+            <a:off x="3922776" y="4950460"/>
+            <a:ext cx="2807208" cy="905256"/>
+          </a:xfrm>
+          <a:prstGeom prst="rect">
+            <a:avLst/>
+          </a:prstGeom>
+          <a:noFill/>
+          <a:ln/>
+        </p:spPr>
+        <p:txBody>
+          <a:bodyPr wrap="square" lIns="0" tIns="0" rIns="0" bIns="0" rtlCol="0" anchor="ctr"/>
+          <a:lstStyle/>
+          <a:p>
+            <a:pPr indent="0" marL="0">
+              <a:buNone/>
+            </a:pPr>
+            <a:r>
+              <a:rPr lang="en-US" sz="1400" dirty="0">
+                <a:solidFill>
+                  <a:schemeClr val="tx1"/>
+                </a:solidFill>
+              </a:rPr>
+              <a:t>Meet Mochi — a rare Storyteller from a hatch.</a:t>
+            </a:r>
+            <a:endParaRPr lang="en-US" sz="1400" dirty="0"/>
+          </a:p>
+        </p:txBody>
+      </p:sp>
+      <p:sp>
+        <p:nvSpPr>
+          <p:cNvPr id="11" name="cap-c"/>
+          <p:cNvSpPr/>
+          <p:nvPr/>
+        </p:nvSpPr>
+        <p:spPr>
+          <a:xfrm>
+            <a:off x="7040880" y="5276088"/>
+            <a:ext cx="4663440" cy="640080"/>
+          </a:xfrm>
+          <a:prstGeom prst="roundRect">
+            <a:avLst>
+              <a:gd name="adj" fmla="val 20000"/>
+            </a:avLst>
+          </a:prstGeom>
+          <a:solidFill>
+            <a:srgbClr val="FFFFFF"/>
+          </a:solidFill>
+          <a:ln/>
+          <a:effectLst>
+            <a:outerShdw sx="100000" sy="100000" kx="0" ky="0" algn="bl" rotWithShape="0" blurRad="101600" dist="25400" dir="5400000">
+              <a:srgbClr val="0B1F3A">
+                <a:alpha val="10000"/>
+              </a:srgbClr>
+            </a:outerShdw>
+          </a:effectLst>
+        </p:spPr>
+      </p:sp>
+      <p:sp>
+        <p:nvSpPr>
+          <p:cNvPr id="12" name="Text 7"/>
+          <p:cNvSpPr txBox="1"/>
+          <p:nvPr/>
+        </p:nvSpPr>
+        <p:spPr>
+          <a:xfrm>
+            <a:off x="7168896" y="5349240"/>
+            <a:ext cx="4407408" cy="493776"/>
+          </a:xfrm>
+          <a:prstGeom prst="rect">
+            <a:avLst/>
+          </a:prstGeom>
+          <a:noFill/>
+          <a:ln/>
+        </p:spPr>
+        <p:txBody>
+          <a:bodyPr wrap="square" lIns="0" tIns="0" rIns="0" bIns="0" rtlCol="0" anchor="ctr"/>
+          <a:lstStyle/>
+          <a:p>
+            <a:pPr indent="0" marL="0">
+              <a:buNone/>
+            </a:pPr>
+            <a:r>
+              <a:rPr lang="en-US" sz="1400" dirty="0">
+                <a:solidFill>
+                  <a:schemeClr val="tx1"/>
+                </a:solidFill>
+              </a:rPr>
+              <a:t>Nova holds Bailey Hall.</a:t>
+            </a:r>
+            <a:endParaRPr lang="en-US" sz="1400" dirty="0"/>
+          </a:p>
+        </p:txBody>
+      </p:sp>
+    </p:spTree>
+  </p:cSld>
+  <p:clrMapOvr>
+    <a:masterClrMapping/>
+  </p:clrMapOvr>
+</p:sld>
+</file>
+
+<file path=ppt/slides/slide8.xml><?xml version="1.0" encoding="utf-8"?>
+<p:sld xmlns:a="http://schemas.openxmlformats.org/drawingml/2006/main" xmlns:r="http://schemas.openxmlformats.org/officeDocument/2006/relationships" xmlns:p="http://schemas.openxmlformats.org/presentationml/2006/main">
+  <p:cSld name="Slide 8">
     <p:spTree>
       <p:nvGrpSpPr>
         <p:cNvPr id="1" name=""/>

</xml_diff>